<commit_message>
docs(presentation): simplify A3 progress terminology
</commit_message>
<xml_diff>
--- a/docs/presentation/progress/ArmIndex_Progress_A0_A3_2026-08-18.pptx
+++ b/docs/presentation/progress/ArmIndex_Progress_A0_A3_2026-08-18.pptx
@@ -2,18 +2,18 @@
 <file path=ppt/presentation.xml><?xml version="1.0" encoding="utf-8"?>
 <p:presentation xmlns:p="http://schemas.openxmlformats.org/presentationml/2006/main">
   <p:sldMasterIdLst>
-    <p:sldMasterId xmlns:r="http://schemas.openxmlformats.org/officeDocument/2006/relationships" id="2147483648" r:id="Rdf7cf22802094acc"/>
+    <p:sldMasterId xmlns:r="http://schemas.openxmlformats.org/officeDocument/2006/relationships" id="2147483648" r:id="Re6c2297d0eb84070"/>
   </p:sldMasterIdLst>
   <p:notesMasterIdLst>
-    <p:notesMasterId xmlns:r="http://schemas.openxmlformats.org/officeDocument/2006/relationships" r:id="R996a00c688244dae"/>
+    <p:notesMasterId xmlns:r="http://schemas.openxmlformats.org/officeDocument/2006/relationships" r:id="Rb37c3ee2936149be"/>
   </p:notesMasterIdLst>
   <p:sldIdLst>
-    <p:sldId xmlns:r="http://schemas.openxmlformats.org/officeDocument/2006/relationships" id="256" r:id="R945623701c824635"/>
-    <p:sldId xmlns:r="http://schemas.openxmlformats.org/officeDocument/2006/relationships" id="257" r:id="R50d83de9c5c64ea1"/>
-    <p:sldId xmlns:r="http://schemas.openxmlformats.org/officeDocument/2006/relationships" id="258" r:id="Re300f17b666a4e70"/>
-    <p:sldId xmlns:r="http://schemas.openxmlformats.org/officeDocument/2006/relationships" id="259" r:id="R4f2f69f111234727"/>
-    <p:sldId xmlns:r="http://schemas.openxmlformats.org/officeDocument/2006/relationships" id="260" r:id="R63980ffa05b24d3e"/>
-    <p:sldId xmlns:r="http://schemas.openxmlformats.org/officeDocument/2006/relationships" id="261" r:id="R2489907d8fca4bc9"/>
+    <p:sldId xmlns:r="http://schemas.openxmlformats.org/officeDocument/2006/relationships" id="256" r:id="Rd9f63e6335c54b41"/>
+    <p:sldId xmlns:r="http://schemas.openxmlformats.org/officeDocument/2006/relationships" id="257" r:id="R16b889707cdc4aa1"/>
+    <p:sldId xmlns:r="http://schemas.openxmlformats.org/officeDocument/2006/relationships" id="258" r:id="Rba27820a2cfd4baf"/>
+    <p:sldId xmlns:r="http://schemas.openxmlformats.org/officeDocument/2006/relationships" id="259" r:id="R51d98030b4184e49"/>
+    <p:sldId xmlns:r="http://schemas.openxmlformats.org/officeDocument/2006/relationships" id="260" r:id="Rb700f4cdef1742ea"/>
+    <p:sldId xmlns:r="http://schemas.openxmlformats.org/officeDocument/2006/relationships" id="261" r:id="R73ea5de64857482a"/>
   </p:sldIdLst>
   <p:sldSz cx="12192000" cy="6858000"/>
   <p:notesSz cx="6858000" cy="9144000"/>
@@ -537,7 +537,7 @@
           <a:lstStyle xmlns:a="http://schemas.openxmlformats.org/drawingml/2006/main"/>
           <a:p xmlns:a="http://schemas.openxmlformats.org/drawingml/2006/main">
             <a:r>
-              <a:t>A0 establishes reproducibility and protected-data controls. A1 tests the common representation surface. A2 conducts constrained per-retriever search.</a:t>
+              <a:t>A0 establishes reproducibility and data-protection controls. A1 tests the common comparison. A2 conducts constrained representation search for each retriever.</a:t>
             </a:r>
           </a:p>
           <a:p xmlns:a="http://schemas.openxmlformats.org/drawingml/2006/main">
@@ -717,7 +717,7 @@
           <a:lstStyle xmlns:a="http://schemas.openxmlformats.org/drawingml/2006/main"/>
           <a:p xmlns:a="http://schemas.openxmlformats.org/drawingml/2006/main">
             <a:r>
-              <a:t>A1 measured five fixed representations across five frozen retrieval arms. A2 then searched its frozen candidate universe independently per arm.</a:t>
+              <a:t>A1 measured five fixed representations across five predefined retrieval arms. A2 then searched its predefined candidate set independently for each arm.</a:t>
             </a:r>
           </a:p>
           <a:p xmlns:a="http://schemas.openxmlformats.org/drawingml/2006/main">
@@ -807,7 +807,7 @@
           <a:lstStyle xmlns:a="http://schemas.openxmlformats.org/drawingml/2006/main"/>
           <a:p xmlns:a="http://schemas.openxmlformats.org/drawingml/2006/main">
             <a:r>
-              <a:t>ARM-03, ARM-04, and ARM-05 are the only A3 inputs. ARM-01 and ARM-02 had three-way top ties without a unique winner and remain useful diagnostic evidence.</a:t>
+              <a:t>ARM-03, ARM-04, and ARM-05 are the only A3 inputs. ARM-01 and ARM-02 had three-way top ties without a unique winner and remain useful interpretation evidence.</a:t>
             </a:r>
           </a:p>
           <a:p xmlns:a="http://schemas.openxmlformats.org/drawingml/2006/main">
@@ -902,12 +902,12 @@
           <a:lstStyle xmlns:a="http://schemas.openxmlformats.org/drawingml/2006/main"/>
           <a:p xmlns:a="http://schemas.openxmlformats.org/drawingml/2006/main">
             <a:r>
-              <a:t>Stage 028 has launched all nine transfer operations and five fixed-control operations.</a:t>
-            </a:r>
-          </a:p>
-          <a:p xmlns:a="http://schemas.openxmlformats.org/drawingml/2006/main">
-            <a:r>
-              <a:t>Launch is an operational fact, not a performance result. The next valid conclusion requires completed evidence collection, owner-local evaluation, coverage checks, and a result-integrity audit.</a:t>
+              <a:t>Stage 028 has launched all nine transfer operations and five fixed combination-control operations.</a:t>
+            </a:r>
+          </a:p>
+          <a:p xmlns:a="http://schemas.openxmlformats.org/drawingml/2006/main">
+            <a:r>
+              <a:t>Launch is an operational fact, not a performance result. The next valid conclusion requires completed evidence collection, protected local evaluation, completeness checks, and a result-integrity audit.</a:t>
             </a:r>
           </a:p>
           <a:p xmlns:a="http://schemas.openxmlformats.org/drawingml/2006/main">
@@ -995,7 +995,7 @@
   </p:cSld>
   <p:clrMap bg1="lt1" tx1="dk1" bg2="lt2" tx2="dk2" accent1="accent1" accent2="accent2" accent3="accent3" accent4="accent4" accent5="accent5" accent6="accent6" hlink="hlink" folHlink="folHlink"/>
   <p:sldLayoutIdLst>
-    <p:sldLayoutId xmlns:r="http://schemas.openxmlformats.org/officeDocument/2006/relationships" id="2147483649" r:id="R38272e9336e64a9f"/>
+    <p:sldLayoutId xmlns:r="http://schemas.openxmlformats.org/officeDocument/2006/relationships" id="2147483649" r:id="R2608f01dfe83423f"/>
   </p:sldLayoutIdLst>
   <p:txStyles>
     <p:titleStyle>
@@ -1546,7 +1546,7 @@
           <p:cNvPr id="9" name="eyebrow">
             <a:extLst xmlns:a="http://schemas.openxmlformats.org/drawingml/2006/main">
               <a:ext uri="{FF2B5EF4-FFF2-40B4-BE49-F238E27FC236}">
-                <a16:creationId xmlns:a16="http://schemas.microsoft.com/office/drawing/2014/main" id="{D63895C3-C981-46B1-954A-5647949B9A07}"/>
+                <a16:creationId xmlns:a16="http://schemas.microsoft.com/office/drawing/2014/main" id="{7C61F593-3AC4-495D-8A37-E7E48CD90958}"/>
               </a:ext>
             </a:extLst>
           </p:cNvPr>
@@ -1602,7 +1602,7 @@
           <p:cNvPr id="2" name="title">
             <a:extLst xmlns:a="http://schemas.openxmlformats.org/drawingml/2006/main">
               <a:ext uri="{FF2B5EF4-FFF2-40B4-BE49-F238E27FC236}">
-                <a16:creationId xmlns:a16="http://schemas.microsoft.com/office/drawing/2014/main" id="{3E66EB2C-AECD-4ECE-937C-0C3BA34C8110}"/>
+                <a16:creationId xmlns:a16="http://schemas.microsoft.com/office/drawing/2014/main" id="{90E70C68-40EA-443E-B319-F8186F750049}"/>
               </a:ext>
             </a:extLst>
           </p:cNvPr>
@@ -1658,7 +1658,7 @@
           <p:cNvPr id="3" name="subtitle">
             <a:extLst xmlns:a="http://schemas.openxmlformats.org/drawingml/2006/main">
               <a:ext uri="{FF2B5EF4-FFF2-40B4-BE49-F238E27FC236}">
-                <a16:creationId xmlns:a16="http://schemas.microsoft.com/office/drawing/2014/main" id="{B41CF5F4-0FC0-45FA-AD59-CA1901DB808D}"/>
+                <a16:creationId xmlns:a16="http://schemas.microsoft.com/office/drawing/2014/main" id="{2EA7CAB0-C2A6-461D-BA38-3D76C8118ED0}"/>
               </a:ext>
             </a:extLst>
           </p:cNvPr>
@@ -1704,7 +1704,7 @@
                 <a:ea typeface="Aptos"/>
                 <a:cs typeface="Aptos"/>
               </a:rPr>
-              <a:t>Retriever-conditioned representation search for cross-domain patent retrieval</a:t>
+              <a:t>Retriever-specific document representation search for cross-domain patent retrieval</a:t>
             </a:r>
           </a:p>
         </p:txBody>
@@ -1714,7 +1714,7 @@
           <p:cNvPr id="4" name="status-surface">
             <a:extLst xmlns:a="http://schemas.openxmlformats.org/drawingml/2006/main">
               <a:ext uri="{FF2B5EF4-FFF2-40B4-BE49-F238E27FC236}">
-                <a16:creationId xmlns:a16="http://schemas.microsoft.com/office/drawing/2014/main" id="{434AB692-41BF-4A05-9E1C-935E53CEB93B}"/>
+                <a16:creationId xmlns:a16="http://schemas.microsoft.com/office/drawing/2014/main" id="{5D1293DE-83F2-45F7-A5A0-CDF390256EBE}"/>
               </a:ext>
             </a:extLst>
           </p:cNvPr>
@@ -1749,7 +1749,7 @@
           <p:cNvPr id="5" name="status">
             <a:extLst xmlns:a="http://schemas.openxmlformats.org/drawingml/2006/main">
               <a:ext uri="{FF2B5EF4-FFF2-40B4-BE49-F238E27FC236}">
-                <a16:creationId xmlns:a16="http://schemas.microsoft.com/office/drawing/2014/main" id="{4C48CFFE-314A-40C3-9DE0-36B48FD0AF9C}"/>
+                <a16:creationId xmlns:a16="http://schemas.microsoft.com/office/drawing/2014/main" id="{0DB1EE79-5E72-4DC4-A5F9-F241B2125D49}"/>
               </a:ext>
             </a:extLst>
           </p:cNvPr>
@@ -1805,7 +1805,7 @@
           <p:cNvPr id="6" name="date">
             <a:extLst xmlns:a="http://schemas.openxmlformats.org/drawingml/2006/main">
               <a:ext uri="{FF2B5EF4-FFF2-40B4-BE49-F238E27FC236}">
-                <a16:creationId xmlns:a16="http://schemas.microsoft.com/office/drawing/2014/main" id="{0F1F97D0-1F76-432E-B0CD-97FE4EBA0400}"/>
+                <a16:creationId xmlns:a16="http://schemas.microsoft.com/office/drawing/2014/main" id="{79EA2513-2950-42F4-B9B1-FE2A3FE3F9B8}"/>
               </a:ext>
             </a:extLst>
           </p:cNvPr>
@@ -1883,7 +1883,7 @@
           <p:cNvPr id="8" name="footer">
             <a:extLst xmlns:a="http://schemas.openxmlformats.org/drawingml/2006/main">
               <a:ext uri="{FF2B5EF4-FFF2-40B4-BE49-F238E27FC236}">
-                <a16:creationId xmlns:a16="http://schemas.microsoft.com/office/drawing/2014/main" id="{D48582C3-C791-4448-9A6E-FE6074600771}"/>
+                <a16:creationId xmlns:a16="http://schemas.microsoft.com/office/drawing/2014/main" id="{21B4399E-52D3-4E8C-98E9-2FE042B46A73}"/>
               </a:ext>
             </a:extLst>
           </p:cNvPr>
@@ -1929,7 +1929,7 @@
                 <a:ea typeface="Aptos"/>
                 <a:cs typeface="Aptos"/>
               </a:rPr>
-              <a:t>Aggregate-safe advisor update. Selection and final confirmation remain closed.</a:t>
+              <a:t>Summary advisor update. Selection and final confirmation remain closed.</a:t>
             </a:r>
           </a:p>
         </p:txBody>
@@ -1937,7 +1937,7 @@
     </p:spTree>
     <p:extLst>
       <p:ext uri="{BB962C8B-B14F-4D97-AF65-F5344CB8AC3E}">
-        <p14:creationId xmlns:p14="http://schemas.microsoft.com/office/powerpoint/2010/main" val="1643437744"/>
+        <p14:creationId xmlns:p14="http://schemas.microsoft.com/office/powerpoint/2010/main" val="2028285412"/>
       </p:ext>
     </p:extLst>
   </p:cSld>
@@ -1968,7 +1968,7 @@
           <p:cNvPr id="28" name="eyebrow">
             <a:extLst xmlns:a="http://schemas.openxmlformats.org/drawingml/2006/main">
               <a:ext uri="{FF2B5EF4-FFF2-40B4-BE49-F238E27FC236}">
-                <a16:creationId xmlns:a16="http://schemas.microsoft.com/office/drawing/2014/main" id="{7A9D71B5-2005-4A80-B4D6-8FDBEBC0E953}"/>
+                <a16:creationId xmlns:a16="http://schemas.microsoft.com/office/drawing/2014/main" id="{7E053F67-A3A4-43BA-927E-A556281D734D}"/>
               </a:ext>
             </a:extLst>
           </p:cNvPr>
@@ -2024,7 +2024,7 @@
           <p:cNvPr id="2" name="title">
             <a:extLst xmlns:a="http://schemas.openxmlformats.org/drawingml/2006/main">
               <a:ext uri="{FF2B5EF4-FFF2-40B4-BE49-F238E27FC236}">
-                <a16:creationId xmlns:a16="http://schemas.microsoft.com/office/drawing/2014/main" id="{3C972F70-4328-488D-B938-C2DFCF5F2FC1}"/>
+                <a16:creationId xmlns:a16="http://schemas.microsoft.com/office/drawing/2014/main" id="{9B20B250-5E4E-4B00-824F-3765FE0B1883}"/>
               </a:ext>
             </a:extLst>
           </p:cNvPr>
@@ -2080,7 +2080,7 @@
           <p:cNvPr id="3" name="slide-number">
             <a:extLst xmlns:a="http://schemas.openxmlformats.org/drawingml/2006/main">
               <a:ext uri="{FF2B5EF4-FFF2-40B4-BE49-F238E27FC236}">
-                <a16:creationId xmlns:a16="http://schemas.microsoft.com/office/drawing/2014/main" id="{226DC09A-4991-40E4-ADF7-BAA1E00DE976}"/>
+                <a16:creationId xmlns:a16="http://schemas.microsoft.com/office/drawing/2014/main" id="{87521AA9-4D9D-48C6-98DE-23A7FA40BDAA}"/>
               </a:ext>
             </a:extLst>
           </p:cNvPr>
@@ -2136,7 +2136,7 @@
           <p:cNvPr id="4" name="subtitle">
             <a:extLst xmlns:a="http://schemas.openxmlformats.org/drawingml/2006/main">
               <a:ext uri="{FF2B5EF4-FFF2-40B4-BE49-F238E27FC236}">
-                <a16:creationId xmlns:a16="http://schemas.microsoft.com/office/drawing/2014/main" id="{14AE269D-D677-42C7-A97C-AD8DA63E9C72}"/>
+                <a16:creationId xmlns:a16="http://schemas.microsoft.com/office/drawing/2014/main" id="{C801B6C9-45EA-477B-8760-0AC1AAEC3821}"/>
               </a:ext>
             </a:extLst>
           </p:cNvPr>
@@ -2182,7 +2182,7 @@
                 <a:ea typeface="Aptos"/>
                 <a:cs typeface="Aptos"/>
               </a:rPr>
-              <a:t>Each phase answers a narrower question while keeping the retrievers, evaluator, and protected boundaries controlled.</a:t>
+              <a:t>Each phase answers a narrower question while keeping retrievers, scoring rules, and data protections controlled.</a:t>
             </a:r>
           </a:p>
         </p:txBody>
@@ -2192,7 +2192,7 @@
           <p:cNvPr id="5" name="phase-A0">
             <a:extLst xmlns:a="http://schemas.openxmlformats.org/drawingml/2006/main">
               <a:ext uri="{FF2B5EF4-FFF2-40B4-BE49-F238E27FC236}">
-                <a16:creationId xmlns:a16="http://schemas.microsoft.com/office/drawing/2014/main" id="{F7419A8C-9F21-4F76-84FA-9B2E9A133E19}"/>
+                <a16:creationId xmlns:a16="http://schemas.microsoft.com/office/drawing/2014/main" id="{C6D34D9C-521D-46C6-AEE6-95F9181A54C6}"/>
               </a:ext>
             </a:extLst>
           </p:cNvPr>
@@ -2227,7 +2227,7 @@
           <p:cNvPr id="6" name="phase-tag-A0">
             <a:extLst xmlns:a="http://schemas.openxmlformats.org/drawingml/2006/main">
               <a:ext uri="{FF2B5EF4-FFF2-40B4-BE49-F238E27FC236}">
-                <a16:creationId xmlns:a16="http://schemas.microsoft.com/office/drawing/2014/main" id="{86940FC5-8E17-4092-AB87-2DB924218B33}"/>
+                <a16:creationId xmlns:a16="http://schemas.microsoft.com/office/drawing/2014/main" id="{710B905C-381C-4A0F-B221-83DE06327259}"/>
               </a:ext>
             </a:extLst>
           </p:cNvPr>
@@ -2262,7 +2262,7 @@
           <p:cNvPr id="7" name="phase-label-A0">
             <a:extLst xmlns:a="http://schemas.openxmlformats.org/drawingml/2006/main">
               <a:ext uri="{FF2B5EF4-FFF2-40B4-BE49-F238E27FC236}">
-                <a16:creationId xmlns:a16="http://schemas.microsoft.com/office/drawing/2014/main" id="{2FC7F341-B991-49C6-A003-1BD820D0E841}"/>
+                <a16:creationId xmlns:a16="http://schemas.microsoft.com/office/drawing/2014/main" id="{63CD5A6E-9C39-4029-9E8D-BC5217FB6AAB}"/>
               </a:ext>
             </a:extLst>
           </p:cNvPr>
@@ -2318,7 +2318,7 @@
           <p:cNvPr id="8" name="phase-state-A0">
             <a:extLst xmlns:a="http://schemas.openxmlformats.org/drawingml/2006/main">
               <a:ext uri="{FF2B5EF4-FFF2-40B4-BE49-F238E27FC236}">
-                <a16:creationId xmlns:a16="http://schemas.microsoft.com/office/drawing/2014/main" id="{17718937-4D9B-4E79-9333-18A05AF116CD}"/>
+                <a16:creationId xmlns:a16="http://schemas.microsoft.com/office/drawing/2014/main" id="{4E151FE5-21FA-453C-BB83-7CCBA288EA5E}"/>
               </a:ext>
             </a:extLst>
           </p:cNvPr>
@@ -2374,7 +2374,7 @@
           <p:cNvPr id="9" name="phase-A1">
             <a:extLst xmlns:a="http://schemas.openxmlformats.org/drawingml/2006/main">
               <a:ext uri="{FF2B5EF4-FFF2-40B4-BE49-F238E27FC236}">
-                <a16:creationId xmlns:a16="http://schemas.microsoft.com/office/drawing/2014/main" id="{F9A6F984-3408-418A-BDEA-0F9DBBDDBD0A}"/>
+                <a16:creationId xmlns:a16="http://schemas.microsoft.com/office/drawing/2014/main" id="{A3A25283-DCAE-4E58-BAC8-BF9860FAB0FF}"/>
               </a:ext>
             </a:extLst>
           </p:cNvPr>
@@ -2409,7 +2409,7 @@
           <p:cNvPr id="10" name="phase-tag-A1">
             <a:extLst xmlns:a="http://schemas.openxmlformats.org/drawingml/2006/main">
               <a:ext uri="{FF2B5EF4-FFF2-40B4-BE49-F238E27FC236}">
-                <a16:creationId xmlns:a16="http://schemas.microsoft.com/office/drawing/2014/main" id="{9A68A34E-EB48-44C9-A85D-B3B13DDEB6A9}"/>
+                <a16:creationId xmlns:a16="http://schemas.microsoft.com/office/drawing/2014/main" id="{5D769FB2-FE58-4D54-9CE0-2B4307A2D4F5}"/>
               </a:ext>
             </a:extLst>
           </p:cNvPr>
@@ -2444,7 +2444,7 @@
           <p:cNvPr id="11" name="phase-label-A1">
             <a:extLst xmlns:a="http://schemas.openxmlformats.org/drawingml/2006/main">
               <a:ext uri="{FF2B5EF4-FFF2-40B4-BE49-F238E27FC236}">
-                <a16:creationId xmlns:a16="http://schemas.microsoft.com/office/drawing/2014/main" id="{553DBB08-D898-459E-B0F8-E8B957247153}"/>
+                <a16:creationId xmlns:a16="http://schemas.microsoft.com/office/drawing/2014/main" id="{04482D31-D182-48C8-BCDA-7A80568772EE}"/>
               </a:ext>
             </a:extLst>
           </p:cNvPr>
@@ -2500,7 +2500,7 @@
           <p:cNvPr id="12" name="phase-state-A1">
             <a:extLst xmlns:a="http://schemas.openxmlformats.org/drawingml/2006/main">
               <a:ext uri="{FF2B5EF4-FFF2-40B4-BE49-F238E27FC236}">
-                <a16:creationId xmlns:a16="http://schemas.microsoft.com/office/drawing/2014/main" id="{19721C85-16B4-4E18-AAC6-8695F9C8E110}"/>
+                <a16:creationId xmlns:a16="http://schemas.microsoft.com/office/drawing/2014/main" id="{B588BECA-5DF7-4065-BF4F-051B2216005A}"/>
               </a:ext>
             </a:extLst>
           </p:cNvPr>
@@ -2546,7 +2546,7 @@
                 <a:ea typeface="Aptos"/>
                 <a:cs typeface="Aptos"/>
               </a:rPr>
-              <a:t>Common screen</a:t>
+              <a:t>Common comparison</a:t>
             </a:r>
           </a:p>
         </p:txBody>
@@ -2556,7 +2556,7 @@
           <p:cNvPr id="13" name="phase-A2">
             <a:extLst xmlns:a="http://schemas.openxmlformats.org/drawingml/2006/main">
               <a:ext uri="{FF2B5EF4-FFF2-40B4-BE49-F238E27FC236}">
-                <a16:creationId xmlns:a16="http://schemas.microsoft.com/office/drawing/2014/main" id="{7E2D2CBD-C4C3-4CA6-8736-3B1DAAF4039B}"/>
+                <a16:creationId xmlns:a16="http://schemas.microsoft.com/office/drawing/2014/main" id="{A4D82DFB-5095-4EA5-AF04-8CB484481FDF}"/>
               </a:ext>
             </a:extLst>
           </p:cNvPr>
@@ -2591,7 +2591,7 @@
           <p:cNvPr id="14" name="phase-tag-A2">
             <a:extLst xmlns:a="http://schemas.openxmlformats.org/drawingml/2006/main">
               <a:ext uri="{FF2B5EF4-FFF2-40B4-BE49-F238E27FC236}">
-                <a16:creationId xmlns:a16="http://schemas.microsoft.com/office/drawing/2014/main" id="{BD82D127-883E-4208-99EA-FEF0D2FF6EC9}"/>
+                <a16:creationId xmlns:a16="http://schemas.microsoft.com/office/drawing/2014/main" id="{758CFE84-8024-453D-A69B-7B68BCA4A526}"/>
               </a:ext>
             </a:extLst>
           </p:cNvPr>
@@ -2626,7 +2626,7 @@
           <p:cNvPr id="15" name="phase-label-A2">
             <a:extLst xmlns:a="http://schemas.openxmlformats.org/drawingml/2006/main">
               <a:ext uri="{FF2B5EF4-FFF2-40B4-BE49-F238E27FC236}">
-                <a16:creationId xmlns:a16="http://schemas.microsoft.com/office/drawing/2014/main" id="{559666A7-F9CB-4C77-879F-7F091D9F00EC}"/>
+                <a16:creationId xmlns:a16="http://schemas.microsoft.com/office/drawing/2014/main" id="{333F6DBC-9808-48EC-8A10-70EC78A00859}"/>
               </a:ext>
             </a:extLst>
           </p:cNvPr>
@@ -2682,7 +2682,7 @@
           <p:cNvPr id="16" name="phase-state-A2">
             <a:extLst xmlns:a="http://schemas.openxmlformats.org/drawingml/2006/main">
               <a:ext uri="{FF2B5EF4-FFF2-40B4-BE49-F238E27FC236}">
-                <a16:creationId xmlns:a16="http://schemas.microsoft.com/office/drawing/2014/main" id="{7C121C57-6891-44B2-9AA0-822049184F8A}"/>
+                <a16:creationId xmlns:a16="http://schemas.microsoft.com/office/drawing/2014/main" id="{95E90F60-6AB8-475A-891F-752B4B73E694}"/>
               </a:ext>
             </a:extLst>
           </p:cNvPr>
@@ -2728,7 +2728,7 @@
                 <a:ea typeface="Aptos"/>
                 <a:cs typeface="Aptos"/>
               </a:rPr>
-              <a:t>Per-retriever search</a:t>
+              <a:t>Representation search</a:t>
             </a:r>
           </a:p>
         </p:txBody>
@@ -2738,7 +2738,7 @@
           <p:cNvPr id="17" name="phase-A3">
             <a:extLst xmlns:a="http://schemas.openxmlformats.org/drawingml/2006/main">
               <a:ext uri="{FF2B5EF4-FFF2-40B4-BE49-F238E27FC236}">
-                <a16:creationId xmlns:a16="http://schemas.microsoft.com/office/drawing/2014/main" id="{FCBD1B61-476F-416B-93CD-A112B19D5DE4}"/>
+                <a16:creationId xmlns:a16="http://schemas.microsoft.com/office/drawing/2014/main" id="{F0B293A1-5DC4-4C77-82A8-F9F48909F480}"/>
               </a:ext>
             </a:extLst>
           </p:cNvPr>
@@ -2773,7 +2773,7 @@
           <p:cNvPr id="18" name="phase-tag-A3">
             <a:extLst xmlns:a="http://schemas.openxmlformats.org/drawingml/2006/main">
               <a:ext uri="{FF2B5EF4-FFF2-40B4-BE49-F238E27FC236}">
-                <a16:creationId xmlns:a16="http://schemas.microsoft.com/office/drawing/2014/main" id="{039C0579-4D26-49E6-A12C-ABFFE0B96F0D}"/>
+                <a16:creationId xmlns:a16="http://schemas.microsoft.com/office/drawing/2014/main" id="{6510490D-478B-4DEB-923A-A9EC2E4B21A7}"/>
               </a:ext>
             </a:extLst>
           </p:cNvPr>
@@ -2808,7 +2808,7 @@
           <p:cNvPr id="19" name="phase-label-A3">
             <a:extLst xmlns:a="http://schemas.openxmlformats.org/drawingml/2006/main">
               <a:ext uri="{FF2B5EF4-FFF2-40B4-BE49-F238E27FC236}">
-                <a16:creationId xmlns:a16="http://schemas.microsoft.com/office/drawing/2014/main" id="{1C8FE088-2ABD-431E-B15A-713EB6F4959F}"/>
+                <a16:creationId xmlns:a16="http://schemas.microsoft.com/office/drawing/2014/main" id="{86516C77-C192-4A7E-88CF-3B6DE9290153}"/>
               </a:ext>
             </a:extLst>
           </p:cNvPr>
@@ -2864,7 +2864,7 @@
           <p:cNvPr id="20" name="phase-state-A3">
             <a:extLst xmlns:a="http://schemas.openxmlformats.org/drawingml/2006/main">
               <a:ext uri="{FF2B5EF4-FFF2-40B4-BE49-F238E27FC236}">
-                <a16:creationId xmlns:a16="http://schemas.microsoft.com/office/drawing/2014/main" id="{E6666A94-E66D-4930-BF5D-B22115491077}"/>
+                <a16:creationId xmlns:a16="http://schemas.microsoft.com/office/drawing/2014/main" id="{11A21B3D-21F4-4DBE-B5FC-5A0E36DB6B94}"/>
               </a:ext>
             </a:extLst>
           </p:cNvPr>
@@ -2920,7 +2920,7 @@
           <p:cNvPr id="21" name="a0-status">
             <a:extLst xmlns:a="http://schemas.openxmlformats.org/drawingml/2006/main">
               <a:ext uri="{FF2B5EF4-FFF2-40B4-BE49-F238E27FC236}">
-                <a16:creationId xmlns:a16="http://schemas.microsoft.com/office/drawing/2014/main" id="{7A3DBFC2-DC84-4E22-8A44-4F94EF65CAD3}"/>
+                <a16:creationId xmlns:a16="http://schemas.microsoft.com/office/drawing/2014/main" id="{9B5AB2AB-E681-41F7-94F7-24586D186997}"/>
               </a:ext>
             </a:extLst>
           </p:cNvPr>
@@ -2976,7 +2976,7 @@
           <p:cNvPr id="22" name="a1-status">
             <a:extLst xmlns:a="http://schemas.openxmlformats.org/drawingml/2006/main">
               <a:ext uri="{FF2B5EF4-FFF2-40B4-BE49-F238E27FC236}">
-                <a16:creationId xmlns:a16="http://schemas.microsoft.com/office/drawing/2014/main" id="{3D6CE6F7-0CF8-4FB1-9AE9-6AB47DFEB1E2}"/>
+                <a16:creationId xmlns:a16="http://schemas.microsoft.com/office/drawing/2014/main" id="{F304984E-32EE-41DB-958D-1943BF3173E5}"/>
               </a:ext>
             </a:extLst>
           </p:cNvPr>
@@ -3032,7 +3032,7 @@
           <p:cNvPr id="23" name="a2-status">
             <a:extLst xmlns:a="http://schemas.openxmlformats.org/drawingml/2006/main">
               <a:ext uri="{FF2B5EF4-FFF2-40B4-BE49-F238E27FC236}">
-                <a16:creationId xmlns:a16="http://schemas.microsoft.com/office/drawing/2014/main" id="{36C2A552-AAFE-4C61-ACD0-89DA9768A41D}"/>
+                <a16:creationId xmlns:a16="http://schemas.microsoft.com/office/drawing/2014/main" id="{6381427F-946F-4D02-A2CD-87C96FEB684A}"/>
               </a:ext>
             </a:extLst>
           </p:cNvPr>
@@ -3088,7 +3088,7 @@
           <p:cNvPr id="24" name="a3-status">
             <a:extLst xmlns:a="http://schemas.openxmlformats.org/drawingml/2006/main">
               <a:ext uri="{FF2B5EF4-FFF2-40B4-BE49-F238E27FC236}">
-                <a16:creationId xmlns:a16="http://schemas.microsoft.com/office/drawing/2014/main" id="{419EF1B7-2FDA-42DC-9C73-5D1656FE8206}"/>
+                <a16:creationId xmlns:a16="http://schemas.microsoft.com/office/drawing/2014/main" id="{C399E9FC-DCE0-484F-BE1E-4591B9966187}"/>
               </a:ext>
             </a:extLst>
           </p:cNvPr>
@@ -3144,7 +3144,7 @@
           <p:cNvPr id="25" name="takeaway">
             <a:extLst xmlns:a="http://schemas.openxmlformats.org/drawingml/2006/main">
               <a:ext uri="{FF2B5EF4-FFF2-40B4-BE49-F238E27FC236}">
-                <a16:creationId xmlns:a16="http://schemas.microsoft.com/office/drawing/2014/main" id="{8C27B057-61A5-472F-B166-C6FE9D7F5A62}"/>
+                <a16:creationId xmlns:a16="http://schemas.microsoft.com/office/drawing/2014/main" id="{409C3E15-5705-4F92-86A2-FD706FCE8C48}"/>
               </a:ext>
             </a:extLst>
           </p:cNvPr>
@@ -3222,7 +3222,7 @@
           <p:cNvPr id="27" name="footer">
             <a:extLst xmlns:a="http://schemas.openxmlformats.org/drawingml/2006/main">
               <a:ext uri="{FF2B5EF4-FFF2-40B4-BE49-F238E27FC236}">
-                <a16:creationId xmlns:a16="http://schemas.microsoft.com/office/drawing/2014/main" id="{93BA07BF-007B-465E-9BE5-9C56066846C5}"/>
+                <a16:creationId xmlns:a16="http://schemas.microsoft.com/office/drawing/2014/main" id="{D276D4F5-0928-4E03-826C-11F2432AA766}"/>
               </a:ext>
             </a:extLst>
           </p:cNvPr>
@@ -3268,7 +3268,7 @@
                 <a:ea typeface="Aptos"/>
                 <a:cs typeface="Aptos"/>
               </a:rPr>
-              <a:t>Phase roles and A3 scope are fixed before measurement.</a:t>
+              <a:t>Phase roles and A3 scope are set before measurement.</a:t>
             </a:r>
           </a:p>
         </p:txBody>
@@ -3276,7 +3276,7 @@
     </p:spTree>
     <p:extLst>
       <p:ext uri="{BB962C8B-B14F-4D97-AF65-F5344CB8AC3E}">
-        <p14:creationId xmlns:p14="http://schemas.microsoft.com/office/powerpoint/2010/main" val="1405178928"/>
+        <p14:creationId xmlns:p14="http://schemas.microsoft.com/office/powerpoint/2010/main" val="1023579802"/>
       </p:ext>
     </p:extLst>
   </p:cSld>
@@ -3307,7 +3307,7 @@
           <p:cNvPr id="12" name="eyebrow">
             <a:extLst xmlns:a="http://schemas.openxmlformats.org/drawingml/2006/main">
               <a:ext uri="{FF2B5EF4-FFF2-40B4-BE49-F238E27FC236}">
-                <a16:creationId xmlns:a16="http://schemas.microsoft.com/office/drawing/2014/main" id="{D5E9FB1E-DEFE-4451-8723-5B480FF7B13E}"/>
+                <a16:creationId xmlns:a16="http://schemas.microsoft.com/office/drawing/2014/main" id="{DA7D3B62-8BEF-4506-94E1-CD2EA7F4712B}"/>
               </a:ext>
             </a:extLst>
           </p:cNvPr>
@@ -3363,7 +3363,7 @@
           <p:cNvPr id="2" name="title">
             <a:extLst xmlns:a="http://schemas.openxmlformats.org/drawingml/2006/main">
               <a:ext uri="{FF2B5EF4-FFF2-40B4-BE49-F238E27FC236}">
-                <a16:creationId xmlns:a16="http://schemas.microsoft.com/office/drawing/2014/main" id="{DD5BC553-308E-4918-A569-39F4FCCCB95B}"/>
+                <a16:creationId xmlns:a16="http://schemas.microsoft.com/office/drawing/2014/main" id="{0E2C75F5-3A39-4B15-AE28-8134FC834A14}"/>
               </a:ext>
             </a:extLst>
           </p:cNvPr>
@@ -3419,7 +3419,7 @@
           <p:cNvPr id="3" name="slide-number">
             <a:extLst xmlns:a="http://schemas.openxmlformats.org/drawingml/2006/main">
               <a:ext uri="{FF2B5EF4-FFF2-40B4-BE49-F238E27FC236}">
-                <a16:creationId xmlns:a16="http://schemas.microsoft.com/office/drawing/2014/main" id="{B9F5A16B-9F41-49BE-AE0A-48B552D5813C}"/>
+                <a16:creationId xmlns:a16="http://schemas.microsoft.com/office/drawing/2014/main" id="{E828A765-2259-4E07-8B75-1DE5A85BDB93}"/>
               </a:ext>
             </a:extLst>
           </p:cNvPr>
@@ -3475,7 +3475,7 @@
           <p:cNvPr id="4" name="subtitle">
             <a:extLst xmlns:a="http://schemas.openxmlformats.org/drawingml/2006/main">
               <a:ext uri="{FF2B5EF4-FFF2-40B4-BE49-F238E27FC236}">
-                <a16:creationId xmlns:a16="http://schemas.microsoft.com/office/drawing/2014/main" id="{E4BB70A3-E5EE-4C89-813A-86E1FA31153F}"/>
+                <a16:creationId xmlns:a16="http://schemas.microsoft.com/office/drawing/2014/main" id="{49618571-AE83-4906-83CF-FB7394758C7C}"/>
               </a:ext>
             </a:extLst>
           </p:cNvPr>
@@ -3531,7 +3531,7 @@
           <p:cNvPr id="5" name="method-summary">
             <a:extLst xmlns:a="http://schemas.openxmlformats.org/drawingml/2006/main">
               <a:ext uri="{FF2B5EF4-FFF2-40B4-BE49-F238E27FC236}">
-                <a16:creationId xmlns:a16="http://schemas.microsoft.com/office/drawing/2014/main" id="{CDE503A9-C097-4EA9-8842-2EA63C88FA71}"/>
+                <a16:creationId xmlns:a16="http://schemas.microsoft.com/office/drawing/2014/main" id="{55194ECD-0EC2-4F75-989C-2B46BCB97B23}"/>
               </a:ext>
             </a:extLst>
           </p:cNvPr>
@@ -3566,7 +3566,7 @@
           <p:cNvPr id="6" name="why-title">
             <a:extLst xmlns:a="http://schemas.openxmlformats.org/drawingml/2006/main">
               <a:ext uri="{FF2B5EF4-FFF2-40B4-BE49-F238E27FC236}">
-                <a16:creationId xmlns:a16="http://schemas.microsoft.com/office/drawing/2014/main" id="{EC99411F-9FAF-4719-9FAD-8D0B14FAC531}"/>
+                <a16:creationId xmlns:a16="http://schemas.microsoft.com/office/drawing/2014/main" id="{5CF48102-51F8-47F5-8177-82CC65085E34}"/>
               </a:ext>
             </a:extLst>
           </p:cNvPr>
@@ -3622,7 +3622,7 @@
           <p:cNvPr id="7" name="why-body">
             <a:extLst xmlns:a="http://schemas.openxmlformats.org/drawingml/2006/main">
               <a:ext uri="{FF2B5EF4-FFF2-40B4-BE49-F238E27FC236}">
-                <a16:creationId xmlns:a16="http://schemas.microsoft.com/office/drawing/2014/main" id="{F810D258-D2B4-4A1B-9950-57DB69E9CC74}"/>
+                <a16:creationId xmlns:a16="http://schemas.microsoft.com/office/drawing/2014/main" id="{BBD397A4-6F6A-4466-AC97-B0318712A939}"/>
               </a:ext>
             </a:extLst>
           </p:cNvPr>
@@ -3728,7 +3728,7 @@
           <p:nvPr/>
         </p:nvPicPr>
         <p:blipFill>
-          <a:blip xmlns:r="http://schemas.openxmlformats.org/officeDocument/2006/relationships" xmlns:a="http://schemas.openxmlformats.org/drawingml/2006/main" r:embed="R11a05c1948cf4f78"/>
+          <a:blip xmlns:r="http://schemas.openxmlformats.org/officeDocument/2006/relationships" xmlns:a="http://schemas.openxmlformats.org/drawingml/2006/main" r:embed="R479c4423627a4d98"/>
           <a:stretch xmlns:a="http://schemas.openxmlformats.org/drawingml/2006/main"/>
         </p:blipFill>
         <p:spPr>
@@ -3746,7 +3746,7 @@
           <p:cNvPr id="9" name="figure-caption">
             <a:extLst xmlns:a="http://schemas.openxmlformats.org/drawingml/2006/main">
               <a:ext uri="{FF2B5EF4-FFF2-40B4-BE49-F238E27FC236}">
-                <a16:creationId xmlns:a16="http://schemas.microsoft.com/office/drawing/2014/main" id="{9D3D7829-4E31-42EB-96A5-E38D1A26F0F0}"/>
+                <a16:creationId xmlns:a16="http://schemas.microsoft.com/office/drawing/2014/main" id="{C70A39BD-51E6-4F87-9576-3046B41D205A}"/>
               </a:ext>
             </a:extLst>
           </p:cNvPr>
@@ -3824,7 +3824,7 @@
           <p:cNvPr id="11" name="footer">
             <a:extLst xmlns:a="http://schemas.openxmlformats.org/drawingml/2006/main">
               <a:ext uri="{FF2B5EF4-FFF2-40B4-BE49-F238E27FC236}">
-                <a16:creationId xmlns:a16="http://schemas.microsoft.com/office/drawing/2014/main" id="{FB3A74FD-99F2-4912-AAA7-BD5E73981F22}"/>
+                <a16:creationId xmlns:a16="http://schemas.microsoft.com/office/drawing/2014/main" id="{DA74C406-F296-4078-A9C5-BB6077BFFB97}"/>
               </a:ext>
             </a:extLst>
           </p:cNvPr>
@@ -3878,7 +3878,7 @@
     </p:spTree>
     <p:extLst>
       <p:ext uri="{BB962C8B-B14F-4D97-AF65-F5344CB8AC3E}">
-        <p14:creationId xmlns:p14="http://schemas.microsoft.com/office/powerpoint/2010/main" val="1586186712"/>
+        <p14:creationId xmlns:p14="http://schemas.microsoft.com/office/powerpoint/2010/main" val="1103555335"/>
       </p:ext>
     </p:extLst>
   </p:cSld>
@@ -3909,7 +3909,7 @@
           <p:cNvPr id="14" name="eyebrow">
             <a:extLst xmlns:a="http://schemas.openxmlformats.org/drawingml/2006/main">
               <a:ext uri="{FF2B5EF4-FFF2-40B4-BE49-F238E27FC236}">
-                <a16:creationId xmlns:a16="http://schemas.microsoft.com/office/drawing/2014/main" id="{522EF1BC-A24C-4C33-AF6F-65B6B0C3ED25}"/>
+                <a16:creationId xmlns:a16="http://schemas.microsoft.com/office/drawing/2014/main" id="{3A104A06-6FE4-4AB9-A5B1-347FFACEBD7F}"/>
               </a:ext>
             </a:extLst>
           </p:cNvPr>
@@ -3965,7 +3965,7 @@
           <p:cNvPr id="2" name="title">
             <a:extLst xmlns:a="http://schemas.openxmlformats.org/drawingml/2006/main">
               <a:ext uri="{FF2B5EF4-FFF2-40B4-BE49-F238E27FC236}">
-                <a16:creationId xmlns:a16="http://schemas.microsoft.com/office/drawing/2014/main" id="{BA14906B-69FD-42B8-A696-DBD48DC939F2}"/>
+                <a16:creationId xmlns:a16="http://schemas.microsoft.com/office/drawing/2014/main" id="{079910FB-6F21-432A-8848-85E1619F58B4}"/>
               </a:ext>
             </a:extLst>
           </p:cNvPr>
@@ -4021,7 +4021,7 @@
           <p:cNvPr id="3" name="slide-number">
             <a:extLst xmlns:a="http://schemas.openxmlformats.org/drawingml/2006/main">
               <a:ext uri="{FF2B5EF4-FFF2-40B4-BE49-F238E27FC236}">
-                <a16:creationId xmlns:a16="http://schemas.microsoft.com/office/drawing/2014/main" id="{6CEDF6A8-CB13-485E-AA80-971926CC1893}"/>
+                <a16:creationId xmlns:a16="http://schemas.microsoft.com/office/drawing/2014/main" id="{309C2EAB-B61F-4CB8-B5B4-1997E425F29F}"/>
               </a:ext>
             </a:extLst>
           </p:cNvPr>
@@ -4077,7 +4077,7 @@
           <p:cNvPr id="4" name="subtitle">
             <a:extLst xmlns:a="http://schemas.openxmlformats.org/drawingml/2006/main">
               <a:ext uri="{FF2B5EF4-FFF2-40B4-BE49-F238E27FC236}">
-                <a16:creationId xmlns:a16="http://schemas.microsoft.com/office/drawing/2014/main" id="{CF692CAE-699B-4DCB-841A-FE25B9997E45}"/>
+                <a16:creationId xmlns:a16="http://schemas.microsoft.com/office/drawing/2014/main" id="{95328FB8-2DDC-4031-AB26-59D4194A049A}"/>
               </a:ext>
             </a:extLst>
           </p:cNvPr>
@@ -4123,7 +4123,7 @@
                 <a:ea typeface="Aptos"/>
                 <a:cs typeface="Aptos"/>
               </a:rPr>
-              <a:t>A1 maps the common representation surface; A2 searches a frozen candidate universe per retriever.</a:t>
+              <a:t>A1 maps the common comparison; A2 searches a predefined candidate set for each retriever.</a:t>
             </a:r>
           </a:p>
         </p:txBody>
@@ -4133,7 +4133,7 @@
           <p:cNvPr id="5" name="a1-summary">
             <a:extLst xmlns:a="http://schemas.openxmlformats.org/drawingml/2006/main">
               <a:ext uri="{FF2B5EF4-FFF2-40B4-BE49-F238E27FC236}">
-                <a16:creationId xmlns:a16="http://schemas.microsoft.com/office/drawing/2014/main" id="{20F9873E-C77B-4695-9C2A-7CF25FE0B4D2}"/>
+                <a16:creationId xmlns:a16="http://schemas.microsoft.com/office/drawing/2014/main" id="{0A2D781D-8228-4293-B765-ABD478245BC3}"/>
               </a:ext>
             </a:extLst>
           </p:cNvPr>
@@ -4168,7 +4168,7 @@
           <p:cNvPr id="6" name="a1-label">
             <a:extLst xmlns:a="http://schemas.openxmlformats.org/drawingml/2006/main">
               <a:ext uri="{FF2B5EF4-FFF2-40B4-BE49-F238E27FC236}">
-                <a16:creationId xmlns:a16="http://schemas.microsoft.com/office/drawing/2014/main" id="{BC97BD4A-3B6E-4BBA-900F-43DA49C2FE01}"/>
+                <a16:creationId xmlns:a16="http://schemas.microsoft.com/office/drawing/2014/main" id="{28F7052F-2CDC-4C25-A5B3-9E2178D01C02}"/>
               </a:ext>
             </a:extLst>
           </p:cNvPr>
@@ -4224,7 +4224,7 @@
           <p:cNvPr id="7" name="a1-value">
             <a:extLst xmlns:a="http://schemas.openxmlformats.org/drawingml/2006/main">
               <a:ext uri="{FF2B5EF4-FFF2-40B4-BE49-F238E27FC236}">
-                <a16:creationId xmlns:a16="http://schemas.microsoft.com/office/drawing/2014/main" id="{589A22ED-B2EA-43C8-BB17-11BF909D4996}"/>
+                <a16:creationId xmlns:a16="http://schemas.microsoft.com/office/drawing/2014/main" id="{688D72FE-BB08-4FBF-A06D-D41E0C872F1C}"/>
               </a:ext>
             </a:extLst>
           </p:cNvPr>
@@ -4330,7 +4330,7 @@
           <p:nvPr/>
         </p:nvPicPr>
         <p:blipFill>
-          <a:blip xmlns:r="http://schemas.openxmlformats.org/officeDocument/2006/relationships" xmlns:a="http://schemas.openxmlformats.org/drawingml/2006/main" r:embed="R4dbbd7a5f43048db"/>
+          <a:blip xmlns:r="http://schemas.openxmlformats.org/officeDocument/2006/relationships" xmlns:a="http://schemas.openxmlformats.org/drawingml/2006/main" r:embed="Rce95fc5feef94bdf"/>
           <a:stretch xmlns:a="http://schemas.openxmlformats.org/drawingml/2006/main"/>
         </p:blipFill>
         <p:spPr>
@@ -4348,7 +4348,7 @@
           <p:cNvPr id="9" name="a2-accounting-label">
             <a:extLst xmlns:a="http://schemas.openxmlformats.org/drawingml/2006/main">
               <a:ext uri="{FF2B5EF4-FFF2-40B4-BE49-F238E27FC236}">
-                <a16:creationId xmlns:a16="http://schemas.microsoft.com/office/drawing/2014/main" id="{C5B6D609-2F96-4E01-A549-B6E013933A42}"/>
+                <a16:creationId xmlns:a16="http://schemas.microsoft.com/office/drawing/2014/main" id="{960CBB41-198A-477B-B2BF-D8A767279343}"/>
               </a:ext>
             </a:extLst>
           </p:cNvPr>
@@ -4404,7 +4404,7 @@
           <p:cNvPr id="10" name="a2-accounting">
             <a:extLst xmlns:a="http://schemas.openxmlformats.org/drawingml/2006/main">
               <a:ext uri="{FF2B5EF4-FFF2-40B4-BE49-F238E27FC236}">
-                <a16:creationId xmlns:a16="http://schemas.microsoft.com/office/drawing/2014/main" id="{A2FEC96E-6B5B-4B86-BE14-5694ED68C730}"/>
+                <a16:creationId xmlns:a16="http://schemas.microsoft.com/office/drawing/2014/main" id="{B64A465E-60CE-4136-A85E-D10FA7731306}"/>
               </a:ext>
             </a:extLst>
           </p:cNvPr>
@@ -4460,7 +4460,7 @@
           <p:cNvPr id="11" name="a2-caption">
             <a:extLst xmlns:a="http://schemas.openxmlformats.org/drawingml/2006/main">
               <a:ext uri="{FF2B5EF4-FFF2-40B4-BE49-F238E27FC236}">
-                <a16:creationId xmlns:a16="http://schemas.microsoft.com/office/drawing/2014/main" id="{26A81CCE-B576-4195-996A-910E4D0A22BF}"/>
+                <a16:creationId xmlns:a16="http://schemas.microsoft.com/office/drawing/2014/main" id="{1762E263-C72B-4A13-B583-F68E0C27E1BD}"/>
               </a:ext>
             </a:extLst>
           </p:cNvPr>
@@ -4538,7 +4538,7 @@
           <p:cNvPr id="13" name="footer">
             <a:extLst xmlns:a="http://schemas.openxmlformats.org/drawingml/2006/main">
               <a:ext uri="{FF2B5EF4-FFF2-40B4-BE49-F238E27FC236}">
-                <a16:creationId xmlns:a16="http://schemas.microsoft.com/office/drawing/2014/main" id="{5CA83C78-C969-4818-9EE9-C6892A83684C}"/>
+                <a16:creationId xmlns:a16="http://schemas.microsoft.com/office/drawing/2014/main" id="{20E97E95-E396-4485-AB18-4DF834162C35}"/>
               </a:ext>
             </a:extLst>
           </p:cNvPr>
@@ -4584,7 +4584,7 @@
                 <a:ea typeface="Aptos"/>
                 <a:cs typeface="Aptos"/>
               </a:rPr>
-              <a:t>A1 and A2 are aggregate development evidence; they are not Selection or Final confirmation.</a:t>
+              <a:t>A1 and A2 are summary development evidence; they are not Selection or Final confirmation.</a:t>
             </a:r>
           </a:p>
         </p:txBody>
@@ -4592,7 +4592,7 @@
     </p:spTree>
     <p:extLst>
       <p:ext uri="{BB962C8B-B14F-4D97-AF65-F5344CB8AC3E}">
-        <p14:creationId xmlns:p14="http://schemas.microsoft.com/office/powerpoint/2010/main" val="405203498"/>
+        <p14:creationId xmlns:p14="http://schemas.microsoft.com/office/powerpoint/2010/main" val="1634509882"/>
       </p:ext>
     </p:extLst>
   </p:cSld>
@@ -4623,7 +4623,7 @@
           <p:cNvPr id="13" name="eyebrow">
             <a:extLst xmlns:a="http://schemas.openxmlformats.org/drawingml/2006/main">
               <a:ext uri="{FF2B5EF4-FFF2-40B4-BE49-F238E27FC236}">
-                <a16:creationId xmlns:a16="http://schemas.microsoft.com/office/drawing/2014/main" id="{7D7B2FED-9B59-4674-AA4C-CFED7EBA126F}"/>
+                <a16:creationId xmlns:a16="http://schemas.microsoft.com/office/drawing/2014/main" id="{F0056D54-A775-4B0B-BE22-A8D2B955B856}"/>
               </a:ext>
             </a:extLst>
           </p:cNvPr>
@@ -4679,7 +4679,7 @@
           <p:cNvPr id="2" name="title">
             <a:extLst xmlns:a="http://schemas.openxmlformats.org/drawingml/2006/main">
               <a:ext uri="{FF2B5EF4-FFF2-40B4-BE49-F238E27FC236}">
-                <a16:creationId xmlns:a16="http://schemas.microsoft.com/office/drawing/2014/main" id="{CF65C2CF-045C-4501-AA72-162E12728F66}"/>
+                <a16:creationId xmlns:a16="http://schemas.microsoft.com/office/drawing/2014/main" id="{C42F8535-67E6-4001-9083-4654DD4DA8B2}"/>
               </a:ext>
             </a:extLst>
           </p:cNvPr>
@@ -4735,7 +4735,7 @@
           <p:cNvPr id="3" name="slide-number">
             <a:extLst xmlns:a="http://schemas.openxmlformats.org/drawingml/2006/main">
               <a:ext uri="{FF2B5EF4-FFF2-40B4-BE49-F238E27FC236}">
-                <a16:creationId xmlns:a16="http://schemas.microsoft.com/office/drawing/2014/main" id="{79E671F2-2B4B-4A19-B2EC-F3C0088A2985}"/>
+                <a16:creationId xmlns:a16="http://schemas.microsoft.com/office/drawing/2014/main" id="{92B6B347-B499-4085-B66E-AD08C237B96D}"/>
               </a:ext>
             </a:extLst>
           </p:cNvPr>
@@ -4791,7 +4791,7 @@
           <p:cNvPr id="4" name="subtitle">
             <a:extLst xmlns:a="http://schemas.openxmlformats.org/drawingml/2006/main">
               <a:ext uri="{FF2B5EF4-FFF2-40B4-BE49-F238E27FC236}">
-                <a16:creationId xmlns:a16="http://schemas.microsoft.com/office/drawing/2014/main" id="{606FE6F4-217D-463C-BC57-0E530C726FDA}"/>
+                <a16:creationId xmlns:a16="http://schemas.microsoft.com/office/drawing/2014/main" id="{9502B991-A28A-41D2-B4AD-0F32ED0ED029}"/>
               </a:ext>
             </a:extLst>
           </p:cNvPr>
@@ -4851,7 +4851,7 @@
           <p:nvPr/>
         </p:nvPicPr>
         <p:blipFill>
-          <a:blip xmlns:r="http://schemas.openxmlformats.org/officeDocument/2006/relationships" xmlns:a="http://schemas.openxmlformats.org/drawingml/2006/main" r:embed="Rd1c42a884b954d79"/>
+          <a:blip xmlns:r="http://schemas.openxmlformats.org/officeDocument/2006/relationships" xmlns:a="http://schemas.openxmlformats.org/drawingml/2006/main" r:embed="R37862da9bdfc4130"/>
           <a:stretch xmlns:a="http://schemas.openxmlformats.org/drawingml/2006/main"/>
         </p:blipFill>
         <p:spPr>
@@ -4869,7 +4869,7 @@
           <p:cNvPr id="6" name="primary-arms">
             <a:extLst xmlns:a="http://schemas.openxmlformats.org/drawingml/2006/main">
               <a:ext uri="{FF2B5EF4-FFF2-40B4-BE49-F238E27FC236}">
-                <a16:creationId xmlns:a16="http://schemas.microsoft.com/office/drawing/2014/main" id="{A11AAEB3-E5C7-4BD0-AD9D-C120B9E5F076}"/>
+                <a16:creationId xmlns:a16="http://schemas.microsoft.com/office/drawing/2014/main" id="{8BCB024F-378C-404A-8727-B51ADF1C8BE8}"/>
               </a:ext>
             </a:extLst>
           </p:cNvPr>
@@ -4904,7 +4904,7 @@
           <p:cNvPr id="7" name="primary-title">
             <a:extLst xmlns:a="http://schemas.openxmlformats.org/drawingml/2006/main">
               <a:ext uri="{FF2B5EF4-FFF2-40B4-BE49-F238E27FC236}">
-                <a16:creationId xmlns:a16="http://schemas.microsoft.com/office/drawing/2014/main" id="{C120CB96-3C9F-45EB-B142-C177D59F3469}"/>
+                <a16:creationId xmlns:a16="http://schemas.microsoft.com/office/drawing/2014/main" id="{4703BD3D-BECC-4208-93AC-FD352303B6D5}"/>
               </a:ext>
             </a:extLst>
           </p:cNvPr>
@@ -4960,7 +4960,7 @@
           <p:cNvPr id="8" name="primary-list">
             <a:extLst xmlns:a="http://schemas.openxmlformats.org/drawingml/2006/main">
               <a:ext uri="{FF2B5EF4-FFF2-40B4-BE49-F238E27FC236}">
-                <a16:creationId xmlns:a16="http://schemas.microsoft.com/office/drawing/2014/main" id="{AB30D20F-1A34-4BCA-9334-0289501985FC}"/>
+                <a16:creationId xmlns:a16="http://schemas.microsoft.com/office/drawing/2014/main" id="{9DCF0D9E-1D1C-4475-871D-E795CA8D0DBE}"/>
               </a:ext>
             </a:extLst>
           </p:cNvPr>
@@ -5062,7 +5062,7 @@
           <p:cNvPr id="9" name="diagnostic-arms">
             <a:extLst xmlns:a="http://schemas.openxmlformats.org/drawingml/2006/main">
               <a:ext uri="{FF2B5EF4-FFF2-40B4-BE49-F238E27FC236}">
-                <a16:creationId xmlns:a16="http://schemas.microsoft.com/office/drawing/2014/main" id="{504A6B21-1E6B-4038-8F1D-E742A06F8EA0}"/>
+                <a16:creationId xmlns:a16="http://schemas.microsoft.com/office/drawing/2014/main" id="{A0D2C8A6-6C15-4493-BDEB-BFFD4AA47B76}"/>
               </a:ext>
             </a:extLst>
           </p:cNvPr>
@@ -5097,7 +5097,7 @@
           <p:cNvPr id="10" name="diagnostic-note">
             <a:extLst xmlns:a="http://schemas.openxmlformats.org/drawingml/2006/main">
               <a:ext uri="{FF2B5EF4-FFF2-40B4-BE49-F238E27FC236}">
-                <a16:creationId xmlns:a16="http://schemas.microsoft.com/office/drawing/2014/main" id="{5C6B7B7B-31D9-4637-875F-19F87A165F75}"/>
+                <a16:creationId xmlns:a16="http://schemas.microsoft.com/office/drawing/2014/main" id="{5129E820-38F2-449D-B5FC-96015692F5E6}"/>
               </a:ext>
             </a:extLst>
           </p:cNvPr>
@@ -5109,7 +5109,7 @@
         <p:spPr>
           <a:xfrm xmlns:a="http://schemas.openxmlformats.org/drawingml/2006/main">
             <a:off x="8239125" y="4581525"/>
-            <a:ext cx="2476500" cy="533400"/>
+            <a:ext cx="2571750" cy="533400"/>
           </a:xfrm>
           <a:prstGeom xmlns:a="http://schemas.openxmlformats.org/drawingml/2006/main" prst="rect">
             <a:avLst/>
@@ -5143,7 +5143,7 @@
                 <a:ea typeface="Aptos"/>
                 <a:cs typeface="Aptos"/>
               </a:rPr>
-              <a:t>ARM-01 and ARM-02 stay as non-advancing diagnostic evidence.</a:t>
+              <a:t>ARM-01 and ARM-02 are retained for interpretation but do not advance.</a:t>
             </a:r>
           </a:p>
         </p:txBody>
@@ -5175,7 +5175,7 @@
           <p:cNvPr id="12" name="footer">
             <a:extLst xmlns:a="http://schemas.openxmlformats.org/drawingml/2006/main">
               <a:ext uri="{FF2B5EF4-FFF2-40B4-BE49-F238E27FC236}">
-                <a16:creationId xmlns:a16="http://schemas.microsoft.com/office/drawing/2014/main" id="{FB3A9E14-4C15-4BB5-BB6C-E0656F6B445E}"/>
+                <a16:creationId xmlns:a16="http://schemas.microsoft.com/office/drawing/2014/main" id="{BEED6B6F-FB7B-4D93-97C4-5AC33F109A48}"/>
               </a:ext>
             </a:extLst>
           </p:cNvPr>
@@ -5229,7 +5229,7 @@
     </p:spTree>
     <p:extLst>
       <p:ext uri="{BB962C8B-B14F-4D97-AF65-F5344CB8AC3E}">
-        <p14:creationId xmlns:p14="http://schemas.microsoft.com/office/powerpoint/2010/main" val="1269841433"/>
+        <p14:creationId xmlns:p14="http://schemas.microsoft.com/office/powerpoint/2010/main" val="955081008"/>
       </p:ext>
     </p:extLst>
   </p:cSld>
@@ -5260,7 +5260,7 @@
           <p:cNvPr id="17" name="eyebrow">
             <a:extLst xmlns:a="http://schemas.openxmlformats.org/drawingml/2006/main">
               <a:ext uri="{FF2B5EF4-FFF2-40B4-BE49-F238E27FC236}">
-                <a16:creationId xmlns:a16="http://schemas.microsoft.com/office/drawing/2014/main" id="{712DD964-676E-4659-874A-054C0BFD060F}"/>
+                <a16:creationId xmlns:a16="http://schemas.microsoft.com/office/drawing/2014/main" id="{CC0EC711-6656-4C13-923A-A84E30ACB9DE}"/>
               </a:ext>
             </a:extLst>
           </p:cNvPr>
@@ -5316,7 +5316,7 @@
           <p:cNvPr id="2" name="title">
             <a:extLst xmlns:a="http://schemas.openxmlformats.org/drawingml/2006/main">
               <a:ext uri="{FF2B5EF4-FFF2-40B4-BE49-F238E27FC236}">
-                <a16:creationId xmlns:a16="http://schemas.microsoft.com/office/drawing/2014/main" id="{5A0C5B1D-52F9-4B84-99ED-766AFBCB2EF6}"/>
+                <a16:creationId xmlns:a16="http://schemas.microsoft.com/office/drawing/2014/main" id="{13B34C4D-5996-4CAC-8CDB-D024695474B8}"/>
               </a:ext>
             </a:extLst>
           </p:cNvPr>
@@ -5372,7 +5372,7 @@
           <p:cNvPr id="3" name="slide-number">
             <a:extLst xmlns:a="http://schemas.openxmlformats.org/drawingml/2006/main">
               <a:ext uri="{FF2B5EF4-FFF2-40B4-BE49-F238E27FC236}">
-                <a16:creationId xmlns:a16="http://schemas.microsoft.com/office/drawing/2014/main" id="{FF581739-A4F5-470E-A4D7-131E618E948F}"/>
+                <a16:creationId xmlns:a16="http://schemas.microsoft.com/office/drawing/2014/main" id="{9A6F541B-DB78-4E7E-8226-8858AE843B22}"/>
               </a:ext>
             </a:extLst>
           </p:cNvPr>
@@ -5428,7 +5428,7 @@
           <p:cNvPr id="4" name="subtitle">
             <a:extLst xmlns:a="http://schemas.openxmlformats.org/drawingml/2006/main">
               <a:ext uri="{FF2B5EF4-FFF2-40B4-BE49-F238E27FC236}">
-                <a16:creationId xmlns:a16="http://schemas.microsoft.com/office/drawing/2014/main" id="{CB20AD7A-5B26-4CE2-94F3-4ECD4FEB11C5}"/>
+                <a16:creationId xmlns:a16="http://schemas.microsoft.com/office/drawing/2014/main" id="{2CB04B60-F57D-4B31-949C-27585273EDB7}"/>
               </a:ext>
             </a:extLst>
           </p:cNvPr>
@@ -5474,7 +5474,7 @@
                 <a:ea typeface="Aptos"/>
                 <a:cs typeface="Aptos"/>
               </a:rPr>
-              <a:t>The current work tests transfer and fixed-union controls before any production decision.</a:t>
+              <a:t>The current work tests transfer and fixed combination controls before any production decision.</a:t>
             </a:r>
           </a:p>
         </p:txBody>
@@ -5484,7 +5484,7 @@
           <p:cNvPr id="5" name="launch-status">
             <a:extLst xmlns:a="http://schemas.openxmlformats.org/drawingml/2006/main">
               <a:ext uri="{FF2B5EF4-FFF2-40B4-BE49-F238E27FC236}">
-                <a16:creationId xmlns:a16="http://schemas.microsoft.com/office/drawing/2014/main" id="{A427DDFE-3563-48A5-A811-5C4F4BC0CAB3}"/>
+                <a16:creationId xmlns:a16="http://schemas.microsoft.com/office/drawing/2014/main" id="{3D4B89DC-84A9-4CE9-B4BF-E362B79417A1}"/>
               </a:ext>
             </a:extLst>
           </p:cNvPr>
@@ -5519,7 +5519,7 @@
           <p:cNvPr id="6" name="operation-count">
             <a:extLst xmlns:a="http://schemas.openxmlformats.org/drawingml/2006/main">
               <a:ext uri="{FF2B5EF4-FFF2-40B4-BE49-F238E27FC236}">
-                <a16:creationId xmlns:a16="http://schemas.microsoft.com/office/drawing/2014/main" id="{697C5712-7E27-4660-889D-28687B4B6DB1}"/>
+                <a16:creationId xmlns:a16="http://schemas.microsoft.com/office/drawing/2014/main" id="{5898D9A0-46B0-49BE-A7CD-99692330E664}"/>
               </a:ext>
             </a:extLst>
           </p:cNvPr>
@@ -5575,7 +5575,7 @@
           <p:cNvPr id="7" name="operation-label">
             <a:extLst xmlns:a="http://schemas.openxmlformats.org/drawingml/2006/main">
               <a:ext uri="{FF2B5EF4-FFF2-40B4-BE49-F238E27FC236}">
-                <a16:creationId xmlns:a16="http://schemas.microsoft.com/office/drawing/2014/main" id="{0210F4BC-BB5C-4AB5-B08C-5A36FE87CE7A}"/>
+                <a16:creationId xmlns:a16="http://schemas.microsoft.com/office/drawing/2014/main" id="{3DC9C30A-F300-40BC-A9E1-30685DE24B64}"/>
               </a:ext>
             </a:extLst>
           </p:cNvPr>
@@ -5654,7 +5654,7 @@
           <p:cNvPr id="8" name="measurement-scope">
             <a:extLst xmlns:a="http://schemas.openxmlformats.org/drawingml/2006/main">
               <a:ext uri="{FF2B5EF4-FFF2-40B4-BE49-F238E27FC236}">
-                <a16:creationId xmlns:a16="http://schemas.microsoft.com/office/drawing/2014/main" id="{4BA0ED49-FCA8-4BEC-BE91-9E71B1A323BC}"/>
+                <a16:creationId xmlns:a16="http://schemas.microsoft.com/office/drawing/2014/main" id="{F2CE8D6E-70B5-47F5-B2E5-C32B8C9A7929}"/>
               </a:ext>
             </a:extLst>
           </p:cNvPr>
@@ -5689,7 +5689,7 @@
           <p:cNvPr id="9" name="scope-title">
             <a:extLst xmlns:a="http://schemas.openxmlformats.org/drawingml/2006/main">
               <a:ext uri="{FF2B5EF4-FFF2-40B4-BE49-F238E27FC236}">
-                <a16:creationId xmlns:a16="http://schemas.microsoft.com/office/drawing/2014/main" id="{E8FD4885-0477-4731-A846-07750D7B073D}"/>
+                <a16:creationId xmlns:a16="http://schemas.microsoft.com/office/drawing/2014/main" id="{92EB034D-0DF4-4313-A0C0-4FAD67598986}"/>
               </a:ext>
             </a:extLst>
           </p:cNvPr>
@@ -5745,7 +5745,7 @@
           <p:cNvPr id="10" name="scope-body">
             <a:extLst xmlns:a="http://schemas.openxmlformats.org/drawingml/2006/main">
               <a:ext uri="{FF2B5EF4-FFF2-40B4-BE49-F238E27FC236}">
-                <a16:creationId xmlns:a16="http://schemas.microsoft.com/office/drawing/2014/main" id="{4081FACB-3B85-4A72-B3DE-D7614295D5E1}"/>
+                <a16:creationId xmlns:a16="http://schemas.microsoft.com/office/drawing/2014/main" id="{C89A3EF8-2667-4F69-8C2B-63D0A1CF22E4}"/>
               </a:ext>
             </a:extLst>
           </p:cNvPr>
@@ -5757,7 +5757,7 @@
         <p:spPr>
           <a:xfrm xmlns:a="http://schemas.openxmlformats.org/drawingml/2006/main">
             <a:off x="3905250" y="3086100"/>
-            <a:ext cx="2762250" cy="904875"/>
+            <a:ext cx="2857500" cy="904875"/>
           </a:xfrm>
           <a:prstGeom xmlns:a="http://schemas.openxmlformats.org/drawingml/2006/main" prst="rect">
             <a:avLst/>
@@ -5814,7 +5814,7 @@
                 <a:ea typeface="Aptos"/>
                 <a:cs typeface="Aptos"/>
               </a:rPr>
-              <a:t>- 5 fixed-union controls</a:t>
+              <a:t>- 5 fixed combination controls</a:t>
             </a:r>
           </a:p>
           <a:p xmlns:a="http://schemas.openxmlformats.org/drawingml/2006/main">
@@ -5847,7 +5847,7 @@
           <p:cNvPr id="11" name="decision-boundary">
             <a:extLst xmlns:a="http://schemas.openxmlformats.org/drawingml/2006/main">
               <a:ext uri="{FF2B5EF4-FFF2-40B4-BE49-F238E27FC236}">
-                <a16:creationId xmlns:a16="http://schemas.microsoft.com/office/drawing/2014/main" id="{0D12ED45-25FB-4A5E-8516-05DAC6AA6F37}"/>
+                <a16:creationId xmlns:a16="http://schemas.microsoft.com/office/drawing/2014/main" id="{F15C4A6D-0D6B-49BC-9A49-312E6808354A}"/>
               </a:ext>
             </a:extLst>
           </p:cNvPr>
@@ -5882,7 +5882,7 @@
           <p:cNvPr id="12" name="boundary-title">
             <a:extLst xmlns:a="http://schemas.openxmlformats.org/drawingml/2006/main">
               <a:ext uri="{FF2B5EF4-FFF2-40B4-BE49-F238E27FC236}">
-                <a16:creationId xmlns:a16="http://schemas.microsoft.com/office/drawing/2014/main" id="{16131031-335C-4821-948E-51AB00B131BE}"/>
+                <a16:creationId xmlns:a16="http://schemas.microsoft.com/office/drawing/2014/main" id="{DD8D29AB-5250-44FB-BDB6-3197FA7FCD11}"/>
               </a:ext>
             </a:extLst>
           </p:cNvPr>
@@ -5938,7 +5938,7 @@
           <p:cNvPr id="13" name="boundary-body">
             <a:extLst xmlns:a="http://schemas.openxmlformats.org/drawingml/2006/main">
               <a:ext uri="{FF2B5EF4-FFF2-40B4-BE49-F238E27FC236}">
-                <a16:creationId xmlns:a16="http://schemas.microsoft.com/office/drawing/2014/main" id="{A44DE1B2-8038-41AD-946A-A4674922418D}"/>
+                <a16:creationId xmlns:a16="http://schemas.microsoft.com/office/drawing/2014/main" id="{5A3A06AC-78A2-453A-AECD-3F452717E212}"/>
               </a:ext>
             </a:extLst>
           </p:cNvPr>
@@ -6040,7 +6040,7 @@
           <p:cNvPr id="14" name="next-step">
             <a:extLst xmlns:a="http://schemas.openxmlformats.org/drawingml/2006/main">
               <a:ext uri="{FF2B5EF4-FFF2-40B4-BE49-F238E27FC236}">
-                <a16:creationId xmlns:a16="http://schemas.microsoft.com/office/drawing/2014/main" id="{E0FA7E4D-A895-4599-8C1E-445908334EFF}"/>
+                <a16:creationId xmlns:a16="http://schemas.microsoft.com/office/drawing/2014/main" id="{57A085CD-DBE6-4D37-A57C-11FDE1D808D2}"/>
               </a:ext>
             </a:extLst>
           </p:cNvPr>
@@ -6086,7 +6086,7 @@
                 <a:ea typeface="Aptos"/>
                 <a:cs typeface="Aptos"/>
               </a:rPr>
-              <a:t>Next valid update: collected packages, owner-local evaluation, coverage check, and independent result audit.</a:t>
+              <a:t>Next valid update: collected packages, protected local evaluation, completeness check, and independent result audit.</a:t>
             </a:r>
           </a:p>
         </p:txBody>
@@ -6118,7 +6118,7 @@
           <p:cNvPr id="16" name="footer">
             <a:extLst xmlns:a="http://schemas.openxmlformats.org/drawingml/2006/main">
               <a:ext uri="{FF2B5EF4-FFF2-40B4-BE49-F238E27FC236}">
-                <a16:creationId xmlns:a16="http://schemas.microsoft.com/office/drawing/2014/main" id="{06E6F4B0-29DC-42C3-BBCC-10ED51DB6232}"/>
+                <a16:creationId xmlns:a16="http://schemas.microsoft.com/office/drawing/2014/main" id="{7BF838F4-C9E4-4026-BF15-F55B89C83729}"/>
               </a:ext>
             </a:extLst>
           </p:cNvPr>
@@ -6164,7 +6164,7 @@
                 <a:ea typeface="Aptos"/>
                 <a:cs typeface="Aptos"/>
               </a:rPr>
-              <a:t>A4 remains locked pending valid A3 aggregate evidence and audit.</a:t>
+              <a:t>A4 remains locked pending valid A3 summary evidence and audit.</a:t>
             </a:r>
           </a:p>
         </p:txBody>
@@ -6172,7 +6172,7 @@
     </p:spTree>
     <p:extLst>
       <p:ext uri="{BB962C8B-B14F-4D97-AF65-F5344CB8AC3E}">
-        <p14:creationId xmlns:p14="http://schemas.microsoft.com/office/powerpoint/2010/main" val="215183294"/>
+        <p14:creationId xmlns:p14="http://schemas.microsoft.com/office/powerpoint/2010/main" val="1077972275"/>
       </p:ext>
     </p:extLst>
   </p:cSld>

</xml_diff>

<commit_message>
docs(presentation): refresh A3 operational progress
</commit_message>
<xml_diff>
--- a/docs/presentation/progress/ArmIndex_Progress_A0_A3_2026-08-18.pptx
+++ b/docs/presentation/progress/ArmIndex_Progress_A0_A3_2026-08-18.pptx
@@ -2,18 +2,18 @@
 <file path=ppt/presentation.xml><?xml version="1.0" encoding="utf-8"?>
 <p:presentation xmlns:p="http://schemas.openxmlformats.org/presentationml/2006/main">
   <p:sldMasterIdLst>
-    <p:sldMasterId xmlns:r="http://schemas.openxmlformats.org/officeDocument/2006/relationships" id="2147483648" r:id="Re6c2297d0eb84070"/>
+    <p:sldMasterId xmlns:r="http://schemas.openxmlformats.org/officeDocument/2006/relationships" id="2147483648" r:id="R2fc37f6cda664f23"/>
   </p:sldMasterIdLst>
   <p:notesMasterIdLst>
-    <p:notesMasterId xmlns:r="http://schemas.openxmlformats.org/officeDocument/2006/relationships" r:id="Rb37c3ee2936149be"/>
+    <p:notesMasterId xmlns:r="http://schemas.openxmlformats.org/officeDocument/2006/relationships" r:id="Rf36a2d66714a443b"/>
   </p:notesMasterIdLst>
   <p:sldIdLst>
-    <p:sldId xmlns:r="http://schemas.openxmlformats.org/officeDocument/2006/relationships" id="256" r:id="Rd9f63e6335c54b41"/>
-    <p:sldId xmlns:r="http://schemas.openxmlformats.org/officeDocument/2006/relationships" id="257" r:id="R16b889707cdc4aa1"/>
-    <p:sldId xmlns:r="http://schemas.openxmlformats.org/officeDocument/2006/relationships" id="258" r:id="Rba27820a2cfd4baf"/>
-    <p:sldId xmlns:r="http://schemas.openxmlformats.org/officeDocument/2006/relationships" id="259" r:id="R51d98030b4184e49"/>
-    <p:sldId xmlns:r="http://schemas.openxmlformats.org/officeDocument/2006/relationships" id="260" r:id="Rb700f4cdef1742ea"/>
-    <p:sldId xmlns:r="http://schemas.openxmlformats.org/officeDocument/2006/relationships" id="261" r:id="R73ea5de64857482a"/>
+    <p:sldId xmlns:r="http://schemas.openxmlformats.org/officeDocument/2006/relationships" id="256" r:id="Ra5892d78d5a04582"/>
+    <p:sldId xmlns:r="http://schemas.openxmlformats.org/officeDocument/2006/relationships" id="257" r:id="Rb0494f8ee9b24a7b"/>
+    <p:sldId xmlns:r="http://schemas.openxmlformats.org/officeDocument/2006/relationships" id="258" r:id="Racf5dfe2c0204f48"/>
+    <p:sldId xmlns:r="http://schemas.openxmlformats.org/officeDocument/2006/relationships" id="259" r:id="Rc429f90c446f4f72"/>
+    <p:sldId xmlns:r="http://schemas.openxmlformats.org/officeDocument/2006/relationships" id="260" r:id="Rb21f619cc39445b0"/>
+    <p:sldId xmlns:r="http://schemas.openxmlformats.org/officeDocument/2006/relationships" id="261" r:id="R1260f6e7bb9846f6"/>
   </p:sldIdLst>
   <p:sldSz cx="12192000" cy="6858000"/>
   <p:notesSz cx="6858000" cy="9144000"/>
@@ -902,7 +902,7 @@
           <a:lstStyle xmlns:a="http://schemas.openxmlformats.org/drawingml/2006/main"/>
           <a:p xmlns:a="http://schemas.openxmlformats.org/drawingml/2006/main">
             <a:r>
-              <a:t>Stage 028 has launched all nine transfer operations and five fixed combination-control operations.</a:t>
+              <a:t>Stage 028 launched all nine transfer operations and five fixed combination-control operations. Twelve return receipts are collected; two fixed controls remain active.</a:t>
             </a:r>
           </a:p>
           <a:p xmlns:a="http://schemas.openxmlformats.org/drawingml/2006/main">
@@ -995,7 +995,7 @@
   </p:cSld>
   <p:clrMap bg1="lt1" tx1="dk1" bg2="lt2" tx2="dk2" accent1="accent1" accent2="accent2" accent3="accent3" accent4="accent4" accent5="accent5" accent6="accent6" hlink="hlink" folHlink="folHlink"/>
   <p:sldLayoutIdLst>
-    <p:sldLayoutId xmlns:r="http://schemas.openxmlformats.org/officeDocument/2006/relationships" id="2147483649" r:id="R2608f01dfe83423f"/>
+    <p:sldLayoutId xmlns:r="http://schemas.openxmlformats.org/officeDocument/2006/relationships" id="2147483649" r:id="R8010f8a2427d48f9"/>
   </p:sldLayoutIdLst>
   <p:txStyles>
     <p:titleStyle>
@@ -1546,7 +1546,7 @@
           <p:cNvPr id="9" name="eyebrow">
             <a:extLst xmlns:a="http://schemas.openxmlformats.org/drawingml/2006/main">
               <a:ext uri="{FF2B5EF4-FFF2-40B4-BE49-F238E27FC236}">
-                <a16:creationId xmlns:a16="http://schemas.microsoft.com/office/drawing/2014/main" id="{7C61F593-3AC4-495D-8A37-E7E48CD90958}"/>
+                <a16:creationId xmlns:a16="http://schemas.microsoft.com/office/drawing/2014/main" id="{38DAB0A1-23EC-492E-BA52-0A0EF4328C6E}"/>
               </a:ext>
             </a:extLst>
           </p:cNvPr>
@@ -1602,7 +1602,7 @@
           <p:cNvPr id="2" name="title">
             <a:extLst xmlns:a="http://schemas.openxmlformats.org/drawingml/2006/main">
               <a:ext uri="{FF2B5EF4-FFF2-40B4-BE49-F238E27FC236}">
-                <a16:creationId xmlns:a16="http://schemas.microsoft.com/office/drawing/2014/main" id="{90E70C68-40EA-443E-B319-F8186F750049}"/>
+                <a16:creationId xmlns:a16="http://schemas.microsoft.com/office/drawing/2014/main" id="{05062DEA-FF4A-4B27-BEAA-28239DF672DB}"/>
               </a:ext>
             </a:extLst>
           </p:cNvPr>
@@ -1658,7 +1658,7 @@
           <p:cNvPr id="3" name="subtitle">
             <a:extLst xmlns:a="http://schemas.openxmlformats.org/drawingml/2006/main">
               <a:ext uri="{FF2B5EF4-FFF2-40B4-BE49-F238E27FC236}">
-                <a16:creationId xmlns:a16="http://schemas.microsoft.com/office/drawing/2014/main" id="{2EA7CAB0-C2A6-461D-BA38-3D76C8118ED0}"/>
+                <a16:creationId xmlns:a16="http://schemas.microsoft.com/office/drawing/2014/main" id="{7F6CE460-AC25-408A-91E4-9437E18596CB}"/>
               </a:ext>
             </a:extLst>
           </p:cNvPr>
@@ -1714,7 +1714,7 @@
           <p:cNvPr id="4" name="status-surface">
             <a:extLst xmlns:a="http://schemas.openxmlformats.org/drawingml/2006/main">
               <a:ext uri="{FF2B5EF4-FFF2-40B4-BE49-F238E27FC236}">
-                <a16:creationId xmlns:a16="http://schemas.microsoft.com/office/drawing/2014/main" id="{5D1293DE-83F2-45F7-A5A0-CDF390256EBE}"/>
+                <a16:creationId xmlns:a16="http://schemas.microsoft.com/office/drawing/2014/main" id="{80B556A2-0CBD-4549-B588-F660667B8100}"/>
               </a:ext>
             </a:extLst>
           </p:cNvPr>
@@ -1749,7 +1749,7 @@
           <p:cNvPr id="5" name="status">
             <a:extLst xmlns:a="http://schemas.openxmlformats.org/drawingml/2006/main">
               <a:ext uri="{FF2B5EF4-FFF2-40B4-BE49-F238E27FC236}">
-                <a16:creationId xmlns:a16="http://schemas.microsoft.com/office/drawing/2014/main" id="{0DB1EE79-5E72-4DC4-A5F9-F241B2125D49}"/>
+                <a16:creationId xmlns:a16="http://schemas.microsoft.com/office/drawing/2014/main" id="{9CA221FC-5A07-49F3-8E86-7D9A2179CC4F}"/>
               </a:ext>
             </a:extLst>
           </p:cNvPr>
@@ -1805,7 +1805,7 @@
           <p:cNvPr id="6" name="date">
             <a:extLst xmlns:a="http://schemas.openxmlformats.org/drawingml/2006/main">
               <a:ext uri="{FF2B5EF4-FFF2-40B4-BE49-F238E27FC236}">
-                <a16:creationId xmlns:a16="http://schemas.microsoft.com/office/drawing/2014/main" id="{79EA2513-2950-42F4-B9B1-FE2A3FE3F9B8}"/>
+                <a16:creationId xmlns:a16="http://schemas.microsoft.com/office/drawing/2014/main" id="{5D96904E-8F75-432A-A135-CA3B627BBA6E}"/>
               </a:ext>
             </a:extLst>
           </p:cNvPr>
@@ -1851,7 +1851,7 @@
                 <a:ea typeface="Aptos"/>
                 <a:cs typeface="Aptos"/>
               </a:rPr>
-              <a:t>18 August 2026</a:t>
+              <a:t>19 August 2026</a:t>
             </a:r>
           </a:p>
         </p:txBody>
@@ -1883,7 +1883,7 @@
           <p:cNvPr id="8" name="footer">
             <a:extLst xmlns:a="http://schemas.openxmlformats.org/drawingml/2006/main">
               <a:ext uri="{FF2B5EF4-FFF2-40B4-BE49-F238E27FC236}">
-                <a16:creationId xmlns:a16="http://schemas.microsoft.com/office/drawing/2014/main" id="{21B4399E-52D3-4E8C-98E9-2FE042B46A73}"/>
+                <a16:creationId xmlns:a16="http://schemas.microsoft.com/office/drawing/2014/main" id="{CD20C955-4E2C-4355-88C9-2834950D803E}"/>
               </a:ext>
             </a:extLst>
           </p:cNvPr>
@@ -1937,7 +1937,7 @@
     </p:spTree>
     <p:extLst>
       <p:ext uri="{BB962C8B-B14F-4D97-AF65-F5344CB8AC3E}">
-        <p14:creationId xmlns:p14="http://schemas.microsoft.com/office/powerpoint/2010/main" val="2028285412"/>
+        <p14:creationId xmlns:p14="http://schemas.microsoft.com/office/powerpoint/2010/main" val="1509370549"/>
       </p:ext>
     </p:extLst>
   </p:cSld>
@@ -1968,7 +1968,7 @@
           <p:cNvPr id="28" name="eyebrow">
             <a:extLst xmlns:a="http://schemas.openxmlformats.org/drawingml/2006/main">
               <a:ext uri="{FF2B5EF4-FFF2-40B4-BE49-F238E27FC236}">
-                <a16:creationId xmlns:a16="http://schemas.microsoft.com/office/drawing/2014/main" id="{7E053F67-A3A4-43BA-927E-A556281D734D}"/>
+                <a16:creationId xmlns:a16="http://schemas.microsoft.com/office/drawing/2014/main" id="{69AA129C-8F98-454E-AB2C-D81EEE1D8BDA}"/>
               </a:ext>
             </a:extLst>
           </p:cNvPr>
@@ -2024,7 +2024,7 @@
           <p:cNvPr id="2" name="title">
             <a:extLst xmlns:a="http://schemas.openxmlformats.org/drawingml/2006/main">
               <a:ext uri="{FF2B5EF4-FFF2-40B4-BE49-F238E27FC236}">
-                <a16:creationId xmlns:a16="http://schemas.microsoft.com/office/drawing/2014/main" id="{9B20B250-5E4E-4B00-824F-3765FE0B1883}"/>
+                <a16:creationId xmlns:a16="http://schemas.microsoft.com/office/drawing/2014/main" id="{4F2C4DCA-FD6D-42BC-A791-94A525E31630}"/>
               </a:ext>
             </a:extLst>
           </p:cNvPr>
@@ -2080,7 +2080,7 @@
           <p:cNvPr id="3" name="slide-number">
             <a:extLst xmlns:a="http://schemas.openxmlformats.org/drawingml/2006/main">
               <a:ext uri="{FF2B5EF4-FFF2-40B4-BE49-F238E27FC236}">
-                <a16:creationId xmlns:a16="http://schemas.microsoft.com/office/drawing/2014/main" id="{87521AA9-4D9D-48C6-98DE-23A7FA40BDAA}"/>
+                <a16:creationId xmlns:a16="http://schemas.microsoft.com/office/drawing/2014/main" id="{6D6E483D-92C0-4A6E-99FA-2534392E5E02}"/>
               </a:ext>
             </a:extLst>
           </p:cNvPr>
@@ -2136,7 +2136,7 @@
           <p:cNvPr id="4" name="subtitle">
             <a:extLst xmlns:a="http://schemas.openxmlformats.org/drawingml/2006/main">
               <a:ext uri="{FF2B5EF4-FFF2-40B4-BE49-F238E27FC236}">
-                <a16:creationId xmlns:a16="http://schemas.microsoft.com/office/drawing/2014/main" id="{C801B6C9-45EA-477B-8760-0AC1AAEC3821}"/>
+                <a16:creationId xmlns:a16="http://schemas.microsoft.com/office/drawing/2014/main" id="{969869FB-9D08-4910-BEF6-DE0DAD9B57D0}"/>
               </a:ext>
             </a:extLst>
           </p:cNvPr>
@@ -2192,7 +2192,7 @@
           <p:cNvPr id="5" name="phase-A0">
             <a:extLst xmlns:a="http://schemas.openxmlformats.org/drawingml/2006/main">
               <a:ext uri="{FF2B5EF4-FFF2-40B4-BE49-F238E27FC236}">
-                <a16:creationId xmlns:a16="http://schemas.microsoft.com/office/drawing/2014/main" id="{C6D34D9C-521D-46C6-AEE6-95F9181A54C6}"/>
+                <a16:creationId xmlns:a16="http://schemas.microsoft.com/office/drawing/2014/main" id="{24232039-80B2-4A84-B3FB-837F6291FBAF}"/>
               </a:ext>
             </a:extLst>
           </p:cNvPr>
@@ -2227,7 +2227,7 @@
           <p:cNvPr id="6" name="phase-tag-A0">
             <a:extLst xmlns:a="http://schemas.openxmlformats.org/drawingml/2006/main">
               <a:ext uri="{FF2B5EF4-FFF2-40B4-BE49-F238E27FC236}">
-                <a16:creationId xmlns:a16="http://schemas.microsoft.com/office/drawing/2014/main" id="{710B905C-381C-4A0F-B221-83DE06327259}"/>
+                <a16:creationId xmlns:a16="http://schemas.microsoft.com/office/drawing/2014/main" id="{5F0D2015-1C00-4986-9B7A-0E187662BB56}"/>
               </a:ext>
             </a:extLst>
           </p:cNvPr>
@@ -2262,7 +2262,7 @@
           <p:cNvPr id="7" name="phase-label-A0">
             <a:extLst xmlns:a="http://schemas.openxmlformats.org/drawingml/2006/main">
               <a:ext uri="{FF2B5EF4-FFF2-40B4-BE49-F238E27FC236}">
-                <a16:creationId xmlns:a16="http://schemas.microsoft.com/office/drawing/2014/main" id="{63CD5A6E-9C39-4029-9E8D-BC5217FB6AAB}"/>
+                <a16:creationId xmlns:a16="http://schemas.microsoft.com/office/drawing/2014/main" id="{1152F89A-750F-40E0-8164-547643969E96}"/>
               </a:ext>
             </a:extLst>
           </p:cNvPr>
@@ -2318,7 +2318,7 @@
           <p:cNvPr id="8" name="phase-state-A0">
             <a:extLst xmlns:a="http://schemas.openxmlformats.org/drawingml/2006/main">
               <a:ext uri="{FF2B5EF4-FFF2-40B4-BE49-F238E27FC236}">
-                <a16:creationId xmlns:a16="http://schemas.microsoft.com/office/drawing/2014/main" id="{4E151FE5-21FA-453C-BB83-7CCBA288EA5E}"/>
+                <a16:creationId xmlns:a16="http://schemas.microsoft.com/office/drawing/2014/main" id="{6D27E6DE-E9F6-4200-A1E5-2A7236E40EA8}"/>
               </a:ext>
             </a:extLst>
           </p:cNvPr>
@@ -2374,7 +2374,7 @@
           <p:cNvPr id="9" name="phase-A1">
             <a:extLst xmlns:a="http://schemas.openxmlformats.org/drawingml/2006/main">
               <a:ext uri="{FF2B5EF4-FFF2-40B4-BE49-F238E27FC236}">
-                <a16:creationId xmlns:a16="http://schemas.microsoft.com/office/drawing/2014/main" id="{A3A25283-DCAE-4E58-BAC8-BF9860FAB0FF}"/>
+                <a16:creationId xmlns:a16="http://schemas.microsoft.com/office/drawing/2014/main" id="{FFFACB24-6A39-4CCC-B344-77455C3CAB67}"/>
               </a:ext>
             </a:extLst>
           </p:cNvPr>
@@ -2409,7 +2409,7 @@
           <p:cNvPr id="10" name="phase-tag-A1">
             <a:extLst xmlns:a="http://schemas.openxmlformats.org/drawingml/2006/main">
               <a:ext uri="{FF2B5EF4-FFF2-40B4-BE49-F238E27FC236}">
-                <a16:creationId xmlns:a16="http://schemas.microsoft.com/office/drawing/2014/main" id="{5D769FB2-FE58-4D54-9CE0-2B4307A2D4F5}"/>
+                <a16:creationId xmlns:a16="http://schemas.microsoft.com/office/drawing/2014/main" id="{A1F42978-5557-4C3A-84BF-722BD3848BD3}"/>
               </a:ext>
             </a:extLst>
           </p:cNvPr>
@@ -2444,7 +2444,7 @@
           <p:cNvPr id="11" name="phase-label-A1">
             <a:extLst xmlns:a="http://schemas.openxmlformats.org/drawingml/2006/main">
               <a:ext uri="{FF2B5EF4-FFF2-40B4-BE49-F238E27FC236}">
-                <a16:creationId xmlns:a16="http://schemas.microsoft.com/office/drawing/2014/main" id="{04482D31-D182-48C8-BCDA-7A80568772EE}"/>
+                <a16:creationId xmlns:a16="http://schemas.microsoft.com/office/drawing/2014/main" id="{B8C95387-7C49-438E-BFDE-A3E3AA5F36AC}"/>
               </a:ext>
             </a:extLst>
           </p:cNvPr>
@@ -2500,7 +2500,7 @@
           <p:cNvPr id="12" name="phase-state-A1">
             <a:extLst xmlns:a="http://schemas.openxmlformats.org/drawingml/2006/main">
               <a:ext uri="{FF2B5EF4-FFF2-40B4-BE49-F238E27FC236}">
-                <a16:creationId xmlns:a16="http://schemas.microsoft.com/office/drawing/2014/main" id="{B588BECA-5DF7-4065-BF4F-051B2216005A}"/>
+                <a16:creationId xmlns:a16="http://schemas.microsoft.com/office/drawing/2014/main" id="{4E75045C-D309-4FC2-87DC-FE9B365447C9}"/>
               </a:ext>
             </a:extLst>
           </p:cNvPr>
@@ -2556,7 +2556,7 @@
           <p:cNvPr id="13" name="phase-A2">
             <a:extLst xmlns:a="http://schemas.openxmlformats.org/drawingml/2006/main">
               <a:ext uri="{FF2B5EF4-FFF2-40B4-BE49-F238E27FC236}">
-                <a16:creationId xmlns:a16="http://schemas.microsoft.com/office/drawing/2014/main" id="{A4D82DFB-5095-4EA5-AF04-8CB484481FDF}"/>
+                <a16:creationId xmlns:a16="http://schemas.microsoft.com/office/drawing/2014/main" id="{F58C981F-2401-47FD-BDFB-B8B659DC0AD4}"/>
               </a:ext>
             </a:extLst>
           </p:cNvPr>
@@ -2591,7 +2591,7 @@
           <p:cNvPr id="14" name="phase-tag-A2">
             <a:extLst xmlns:a="http://schemas.openxmlformats.org/drawingml/2006/main">
               <a:ext uri="{FF2B5EF4-FFF2-40B4-BE49-F238E27FC236}">
-                <a16:creationId xmlns:a16="http://schemas.microsoft.com/office/drawing/2014/main" id="{758CFE84-8024-453D-A69B-7B68BCA4A526}"/>
+                <a16:creationId xmlns:a16="http://schemas.microsoft.com/office/drawing/2014/main" id="{DED21040-24BC-4D75-BCA6-835F6AF881F7}"/>
               </a:ext>
             </a:extLst>
           </p:cNvPr>
@@ -2626,7 +2626,7 @@
           <p:cNvPr id="15" name="phase-label-A2">
             <a:extLst xmlns:a="http://schemas.openxmlformats.org/drawingml/2006/main">
               <a:ext uri="{FF2B5EF4-FFF2-40B4-BE49-F238E27FC236}">
-                <a16:creationId xmlns:a16="http://schemas.microsoft.com/office/drawing/2014/main" id="{333F6DBC-9808-48EC-8A10-70EC78A00859}"/>
+                <a16:creationId xmlns:a16="http://schemas.microsoft.com/office/drawing/2014/main" id="{D573002F-CD13-423B-A4C0-423132A3ECC9}"/>
               </a:ext>
             </a:extLst>
           </p:cNvPr>
@@ -2682,7 +2682,7 @@
           <p:cNvPr id="16" name="phase-state-A2">
             <a:extLst xmlns:a="http://schemas.openxmlformats.org/drawingml/2006/main">
               <a:ext uri="{FF2B5EF4-FFF2-40B4-BE49-F238E27FC236}">
-                <a16:creationId xmlns:a16="http://schemas.microsoft.com/office/drawing/2014/main" id="{95E90F60-6AB8-475A-891F-752B4B73E694}"/>
+                <a16:creationId xmlns:a16="http://schemas.microsoft.com/office/drawing/2014/main" id="{5C49A7B4-7290-44E2-B822-EDB86FE8832B}"/>
               </a:ext>
             </a:extLst>
           </p:cNvPr>
@@ -2738,7 +2738,7 @@
           <p:cNvPr id="17" name="phase-A3">
             <a:extLst xmlns:a="http://schemas.openxmlformats.org/drawingml/2006/main">
               <a:ext uri="{FF2B5EF4-FFF2-40B4-BE49-F238E27FC236}">
-                <a16:creationId xmlns:a16="http://schemas.microsoft.com/office/drawing/2014/main" id="{F0B293A1-5DC4-4C77-82A8-F9F48909F480}"/>
+                <a16:creationId xmlns:a16="http://schemas.microsoft.com/office/drawing/2014/main" id="{503F4F00-12B9-4654-8160-9F67C59A42E8}"/>
               </a:ext>
             </a:extLst>
           </p:cNvPr>
@@ -2773,7 +2773,7 @@
           <p:cNvPr id="18" name="phase-tag-A3">
             <a:extLst xmlns:a="http://schemas.openxmlformats.org/drawingml/2006/main">
               <a:ext uri="{FF2B5EF4-FFF2-40B4-BE49-F238E27FC236}">
-                <a16:creationId xmlns:a16="http://schemas.microsoft.com/office/drawing/2014/main" id="{6510490D-478B-4DEB-923A-A9EC2E4B21A7}"/>
+                <a16:creationId xmlns:a16="http://schemas.microsoft.com/office/drawing/2014/main" id="{DF51DDA9-59A8-463A-AF27-AF56CAE85583}"/>
               </a:ext>
             </a:extLst>
           </p:cNvPr>
@@ -2808,7 +2808,7 @@
           <p:cNvPr id="19" name="phase-label-A3">
             <a:extLst xmlns:a="http://schemas.openxmlformats.org/drawingml/2006/main">
               <a:ext uri="{FF2B5EF4-FFF2-40B4-BE49-F238E27FC236}">
-                <a16:creationId xmlns:a16="http://schemas.microsoft.com/office/drawing/2014/main" id="{86516C77-C192-4A7E-88CF-3B6DE9290153}"/>
+                <a16:creationId xmlns:a16="http://schemas.microsoft.com/office/drawing/2014/main" id="{EEE0137C-759D-4EC1-807F-275736435E46}"/>
               </a:ext>
             </a:extLst>
           </p:cNvPr>
@@ -2864,7 +2864,7 @@
           <p:cNvPr id="20" name="phase-state-A3">
             <a:extLst xmlns:a="http://schemas.openxmlformats.org/drawingml/2006/main">
               <a:ext uri="{FF2B5EF4-FFF2-40B4-BE49-F238E27FC236}">
-                <a16:creationId xmlns:a16="http://schemas.microsoft.com/office/drawing/2014/main" id="{11A21B3D-21F4-4DBE-B5FC-5A0E36DB6B94}"/>
+                <a16:creationId xmlns:a16="http://schemas.microsoft.com/office/drawing/2014/main" id="{2053DDD0-C3E8-445B-ACD6-23D17FE056C3}"/>
               </a:ext>
             </a:extLst>
           </p:cNvPr>
@@ -2920,7 +2920,7 @@
           <p:cNvPr id="21" name="a0-status">
             <a:extLst xmlns:a="http://schemas.openxmlformats.org/drawingml/2006/main">
               <a:ext uri="{FF2B5EF4-FFF2-40B4-BE49-F238E27FC236}">
-                <a16:creationId xmlns:a16="http://schemas.microsoft.com/office/drawing/2014/main" id="{9B5AB2AB-E681-41F7-94F7-24586D186997}"/>
+                <a16:creationId xmlns:a16="http://schemas.microsoft.com/office/drawing/2014/main" id="{9712263C-AA9B-4FCE-B6FC-D044C300B4DA}"/>
               </a:ext>
             </a:extLst>
           </p:cNvPr>
@@ -2976,7 +2976,7 @@
           <p:cNvPr id="22" name="a1-status">
             <a:extLst xmlns:a="http://schemas.openxmlformats.org/drawingml/2006/main">
               <a:ext uri="{FF2B5EF4-FFF2-40B4-BE49-F238E27FC236}">
-                <a16:creationId xmlns:a16="http://schemas.microsoft.com/office/drawing/2014/main" id="{F304984E-32EE-41DB-958D-1943BF3173E5}"/>
+                <a16:creationId xmlns:a16="http://schemas.microsoft.com/office/drawing/2014/main" id="{77B7BC59-78D0-46E1-BE2C-65D304989A21}"/>
               </a:ext>
             </a:extLst>
           </p:cNvPr>
@@ -3032,7 +3032,7 @@
           <p:cNvPr id="23" name="a2-status">
             <a:extLst xmlns:a="http://schemas.openxmlformats.org/drawingml/2006/main">
               <a:ext uri="{FF2B5EF4-FFF2-40B4-BE49-F238E27FC236}">
-                <a16:creationId xmlns:a16="http://schemas.microsoft.com/office/drawing/2014/main" id="{6381427F-946F-4D02-A2CD-87C96FEB684A}"/>
+                <a16:creationId xmlns:a16="http://schemas.microsoft.com/office/drawing/2014/main" id="{F1861E8B-33A7-44D9-AB8C-67ACDD865AC7}"/>
               </a:ext>
             </a:extLst>
           </p:cNvPr>
@@ -3088,7 +3088,7 @@
           <p:cNvPr id="24" name="a3-status">
             <a:extLst xmlns:a="http://schemas.openxmlformats.org/drawingml/2006/main">
               <a:ext uri="{FF2B5EF4-FFF2-40B4-BE49-F238E27FC236}">
-                <a16:creationId xmlns:a16="http://schemas.microsoft.com/office/drawing/2014/main" id="{C399E9FC-DCE0-484F-BE1E-4591B9966187}"/>
+                <a16:creationId xmlns:a16="http://schemas.microsoft.com/office/drawing/2014/main" id="{9A25E700-A454-4078-B8AB-EDE15DA9FB27}"/>
               </a:ext>
             </a:extLst>
           </p:cNvPr>
@@ -3100,7 +3100,7 @@
         <p:spPr>
           <a:xfrm xmlns:a="http://schemas.openxmlformats.org/drawingml/2006/main">
             <a:off x="8420100" y="4095750"/>
-            <a:ext cx="1809750" cy="238125"/>
+            <a:ext cx="2000250" cy="238125"/>
           </a:xfrm>
           <a:prstGeom xmlns:a="http://schemas.openxmlformats.org/drawingml/2006/main" prst="rect">
             <a:avLst/>
@@ -3116,7 +3116,7 @@
           <a:lstStyle xmlns:a="http://schemas.openxmlformats.org/drawingml/2006/main"/>
           <a:p xmlns:a="http://schemas.openxmlformats.org/drawingml/2006/main">
             <a:pPr>
-              <a:defRPr sz="1350">
+              <a:defRPr sz="1275">
                 <a:solidFill>
                   <a:srgbClr val="A15C00"/>
                 </a:solidFill>
@@ -3126,7 +3126,7 @@
               </a:defRPr>
             </a:pPr>
             <a:r>
-              <a:rPr sz="1350">
+              <a:rPr sz="1275">
                 <a:solidFill>
                   <a:srgbClr val="A15C00"/>
                 </a:solidFill>
@@ -3134,7 +3134,7 @@
                 <a:ea typeface="Aptos"/>
                 <a:cs typeface="Aptos"/>
               </a:rPr>
-              <a:t>14 operations launched</a:t>
+              <a:t>12 returned / 2 active</a:t>
             </a:r>
           </a:p>
         </p:txBody>
@@ -3144,7 +3144,7 @@
           <p:cNvPr id="25" name="takeaway">
             <a:extLst xmlns:a="http://schemas.openxmlformats.org/drawingml/2006/main">
               <a:ext uri="{FF2B5EF4-FFF2-40B4-BE49-F238E27FC236}">
-                <a16:creationId xmlns:a16="http://schemas.microsoft.com/office/drawing/2014/main" id="{409C3E15-5705-4F92-86A2-FD706FCE8C48}"/>
+                <a16:creationId xmlns:a16="http://schemas.microsoft.com/office/drawing/2014/main" id="{F25F86FE-428D-4AB1-BEEC-6B42730808F0}"/>
               </a:ext>
             </a:extLst>
           </p:cNvPr>
@@ -3222,7 +3222,7 @@
           <p:cNvPr id="27" name="footer">
             <a:extLst xmlns:a="http://schemas.openxmlformats.org/drawingml/2006/main">
               <a:ext uri="{FF2B5EF4-FFF2-40B4-BE49-F238E27FC236}">
-                <a16:creationId xmlns:a16="http://schemas.microsoft.com/office/drawing/2014/main" id="{D276D4F5-0928-4E03-826C-11F2432AA766}"/>
+                <a16:creationId xmlns:a16="http://schemas.microsoft.com/office/drawing/2014/main" id="{0808523F-A736-4768-BEC6-79E4DB610DCA}"/>
               </a:ext>
             </a:extLst>
           </p:cNvPr>
@@ -3276,7 +3276,7 @@
     </p:spTree>
     <p:extLst>
       <p:ext uri="{BB962C8B-B14F-4D97-AF65-F5344CB8AC3E}">
-        <p14:creationId xmlns:p14="http://schemas.microsoft.com/office/powerpoint/2010/main" val="1023579802"/>
+        <p14:creationId xmlns:p14="http://schemas.microsoft.com/office/powerpoint/2010/main" val="1231359672"/>
       </p:ext>
     </p:extLst>
   </p:cSld>
@@ -3307,7 +3307,7 @@
           <p:cNvPr id="12" name="eyebrow">
             <a:extLst xmlns:a="http://schemas.openxmlformats.org/drawingml/2006/main">
               <a:ext uri="{FF2B5EF4-FFF2-40B4-BE49-F238E27FC236}">
-                <a16:creationId xmlns:a16="http://schemas.microsoft.com/office/drawing/2014/main" id="{DA7D3B62-8BEF-4506-94E1-CD2EA7F4712B}"/>
+                <a16:creationId xmlns:a16="http://schemas.microsoft.com/office/drawing/2014/main" id="{5B77BC88-1DBE-40B1-A023-51370CC2D9A2}"/>
               </a:ext>
             </a:extLst>
           </p:cNvPr>
@@ -3363,7 +3363,7 @@
           <p:cNvPr id="2" name="title">
             <a:extLst xmlns:a="http://schemas.openxmlformats.org/drawingml/2006/main">
               <a:ext uri="{FF2B5EF4-FFF2-40B4-BE49-F238E27FC236}">
-                <a16:creationId xmlns:a16="http://schemas.microsoft.com/office/drawing/2014/main" id="{0E2C75F5-3A39-4B15-AE28-8134FC834A14}"/>
+                <a16:creationId xmlns:a16="http://schemas.microsoft.com/office/drawing/2014/main" id="{5D536F1A-7A01-41D8-A9EB-169DCED0E50E}"/>
               </a:ext>
             </a:extLst>
           </p:cNvPr>
@@ -3419,7 +3419,7 @@
           <p:cNvPr id="3" name="slide-number">
             <a:extLst xmlns:a="http://schemas.openxmlformats.org/drawingml/2006/main">
               <a:ext uri="{FF2B5EF4-FFF2-40B4-BE49-F238E27FC236}">
-                <a16:creationId xmlns:a16="http://schemas.microsoft.com/office/drawing/2014/main" id="{E828A765-2259-4E07-8B75-1DE5A85BDB93}"/>
+                <a16:creationId xmlns:a16="http://schemas.microsoft.com/office/drawing/2014/main" id="{D6CA6780-F0D2-48DB-B515-7F33DAEC1167}"/>
               </a:ext>
             </a:extLst>
           </p:cNvPr>
@@ -3475,7 +3475,7 @@
           <p:cNvPr id="4" name="subtitle">
             <a:extLst xmlns:a="http://schemas.openxmlformats.org/drawingml/2006/main">
               <a:ext uri="{FF2B5EF4-FFF2-40B4-BE49-F238E27FC236}">
-                <a16:creationId xmlns:a16="http://schemas.microsoft.com/office/drawing/2014/main" id="{49618571-AE83-4906-83CF-FB7394758C7C}"/>
+                <a16:creationId xmlns:a16="http://schemas.microsoft.com/office/drawing/2014/main" id="{DDEEB814-4B15-424B-93DD-214BDF8241B3}"/>
               </a:ext>
             </a:extLst>
           </p:cNvPr>
@@ -3531,7 +3531,7 @@
           <p:cNvPr id="5" name="method-summary">
             <a:extLst xmlns:a="http://schemas.openxmlformats.org/drawingml/2006/main">
               <a:ext uri="{FF2B5EF4-FFF2-40B4-BE49-F238E27FC236}">
-                <a16:creationId xmlns:a16="http://schemas.microsoft.com/office/drawing/2014/main" id="{55194ECD-0EC2-4F75-989C-2B46BCB97B23}"/>
+                <a16:creationId xmlns:a16="http://schemas.microsoft.com/office/drawing/2014/main" id="{0A8266CC-3FB5-43DF-A27F-A686953AB2C9}"/>
               </a:ext>
             </a:extLst>
           </p:cNvPr>
@@ -3566,7 +3566,7 @@
           <p:cNvPr id="6" name="why-title">
             <a:extLst xmlns:a="http://schemas.openxmlformats.org/drawingml/2006/main">
               <a:ext uri="{FF2B5EF4-FFF2-40B4-BE49-F238E27FC236}">
-                <a16:creationId xmlns:a16="http://schemas.microsoft.com/office/drawing/2014/main" id="{5CF48102-51F8-47F5-8177-82CC65085E34}"/>
+                <a16:creationId xmlns:a16="http://schemas.microsoft.com/office/drawing/2014/main" id="{DD72D1D3-CA6B-4C12-A285-7636405BB179}"/>
               </a:ext>
             </a:extLst>
           </p:cNvPr>
@@ -3622,7 +3622,7 @@
           <p:cNvPr id="7" name="why-body">
             <a:extLst xmlns:a="http://schemas.openxmlformats.org/drawingml/2006/main">
               <a:ext uri="{FF2B5EF4-FFF2-40B4-BE49-F238E27FC236}">
-                <a16:creationId xmlns:a16="http://schemas.microsoft.com/office/drawing/2014/main" id="{BBD397A4-6F6A-4466-AC97-B0318712A939}"/>
+                <a16:creationId xmlns:a16="http://schemas.microsoft.com/office/drawing/2014/main" id="{E1B5208D-BD15-47E4-837D-678667FD7850}"/>
               </a:ext>
             </a:extLst>
           </p:cNvPr>
@@ -3728,7 +3728,7 @@
           <p:nvPr/>
         </p:nvPicPr>
         <p:blipFill>
-          <a:blip xmlns:r="http://schemas.openxmlformats.org/officeDocument/2006/relationships" xmlns:a="http://schemas.openxmlformats.org/drawingml/2006/main" r:embed="R479c4423627a4d98"/>
+          <a:blip xmlns:r="http://schemas.openxmlformats.org/officeDocument/2006/relationships" xmlns:a="http://schemas.openxmlformats.org/drawingml/2006/main" r:embed="R968d5be4c196411f"/>
           <a:stretch xmlns:a="http://schemas.openxmlformats.org/drawingml/2006/main"/>
         </p:blipFill>
         <p:spPr>
@@ -3746,7 +3746,7 @@
           <p:cNvPr id="9" name="figure-caption">
             <a:extLst xmlns:a="http://schemas.openxmlformats.org/drawingml/2006/main">
               <a:ext uri="{FF2B5EF4-FFF2-40B4-BE49-F238E27FC236}">
-                <a16:creationId xmlns:a16="http://schemas.microsoft.com/office/drawing/2014/main" id="{C70A39BD-51E6-4F87-9576-3046B41D205A}"/>
+                <a16:creationId xmlns:a16="http://schemas.microsoft.com/office/drawing/2014/main" id="{ADFA22F1-B9D0-4E36-83E9-EA8DEA4E18D7}"/>
               </a:ext>
             </a:extLst>
           </p:cNvPr>
@@ -3824,7 +3824,7 @@
           <p:cNvPr id="11" name="footer">
             <a:extLst xmlns:a="http://schemas.openxmlformats.org/drawingml/2006/main">
               <a:ext uri="{FF2B5EF4-FFF2-40B4-BE49-F238E27FC236}">
-                <a16:creationId xmlns:a16="http://schemas.microsoft.com/office/drawing/2014/main" id="{DA74C406-F296-4078-A9C5-BB6077BFFB97}"/>
+                <a16:creationId xmlns:a16="http://schemas.microsoft.com/office/drawing/2014/main" id="{24513A4B-E478-43E1-9A78-4BF3007F62E9}"/>
               </a:ext>
             </a:extLst>
           </p:cNvPr>
@@ -3878,7 +3878,7 @@
     </p:spTree>
     <p:extLst>
       <p:ext uri="{BB962C8B-B14F-4D97-AF65-F5344CB8AC3E}">
-        <p14:creationId xmlns:p14="http://schemas.microsoft.com/office/powerpoint/2010/main" val="1103555335"/>
+        <p14:creationId xmlns:p14="http://schemas.microsoft.com/office/powerpoint/2010/main" val="1925926083"/>
       </p:ext>
     </p:extLst>
   </p:cSld>
@@ -3909,7 +3909,7 @@
           <p:cNvPr id="14" name="eyebrow">
             <a:extLst xmlns:a="http://schemas.openxmlformats.org/drawingml/2006/main">
               <a:ext uri="{FF2B5EF4-FFF2-40B4-BE49-F238E27FC236}">
-                <a16:creationId xmlns:a16="http://schemas.microsoft.com/office/drawing/2014/main" id="{3A104A06-6FE4-4AB9-A5B1-347FFACEBD7F}"/>
+                <a16:creationId xmlns:a16="http://schemas.microsoft.com/office/drawing/2014/main" id="{AC459C4B-5F93-42CE-9889-FA4BE2FC444A}"/>
               </a:ext>
             </a:extLst>
           </p:cNvPr>
@@ -3965,7 +3965,7 @@
           <p:cNvPr id="2" name="title">
             <a:extLst xmlns:a="http://schemas.openxmlformats.org/drawingml/2006/main">
               <a:ext uri="{FF2B5EF4-FFF2-40B4-BE49-F238E27FC236}">
-                <a16:creationId xmlns:a16="http://schemas.microsoft.com/office/drawing/2014/main" id="{079910FB-6F21-432A-8848-85E1619F58B4}"/>
+                <a16:creationId xmlns:a16="http://schemas.microsoft.com/office/drawing/2014/main" id="{A4E1EB2C-336C-4574-8AC2-2F39B6E0615C}"/>
               </a:ext>
             </a:extLst>
           </p:cNvPr>
@@ -4021,7 +4021,7 @@
           <p:cNvPr id="3" name="slide-number">
             <a:extLst xmlns:a="http://schemas.openxmlformats.org/drawingml/2006/main">
               <a:ext uri="{FF2B5EF4-FFF2-40B4-BE49-F238E27FC236}">
-                <a16:creationId xmlns:a16="http://schemas.microsoft.com/office/drawing/2014/main" id="{309C2EAB-B61F-4CB8-B5B4-1997E425F29F}"/>
+                <a16:creationId xmlns:a16="http://schemas.microsoft.com/office/drawing/2014/main" id="{807E0306-27F8-49EB-9AFB-D24FDFE17DF8}"/>
               </a:ext>
             </a:extLst>
           </p:cNvPr>
@@ -4077,7 +4077,7 @@
           <p:cNvPr id="4" name="subtitle">
             <a:extLst xmlns:a="http://schemas.openxmlformats.org/drawingml/2006/main">
               <a:ext uri="{FF2B5EF4-FFF2-40B4-BE49-F238E27FC236}">
-                <a16:creationId xmlns:a16="http://schemas.microsoft.com/office/drawing/2014/main" id="{95328FB8-2DDC-4031-AB26-59D4194A049A}"/>
+                <a16:creationId xmlns:a16="http://schemas.microsoft.com/office/drawing/2014/main" id="{E2F2119B-AE32-4BC3-9B89-70052280F3E3}"/>
               </a:ext>
             </a:extLst>
           </p:cNvPr>
@@ -4133,7 +4133,7 @@
           <p:cNvPr id="5" name="a1-summary">
             <a:extLst xmlns:a="http://schemas.openxmlformats.org/drawingml/2006/main">
               <a:ext uri="{FF2B5EF4-FFF2-40B4-BE49-F238E27FC236}">
-                <a16:creationId xmlns:a16="http://schemas.microsoft.com/office/drawing/2014/main" id="{0A2D781D-8228-4293-B765-ABD478245BC3}"/>
+                <a16:creationId xmlns:a16="http://schemas.microsoft.com/office/drawing/2014/main" id="{B2773C31-43F1-4DE6-87D0-AAF6FF1C1367}"/>
               </a:ext>
             </a:extLst>
           </p:cNvPr>
@@ -4168,7 +4168,7 @@
           <p:cNvPr id="6" name="a1-label">
             <a:extLst xmlns:a="http://schemas.openxmlformats.org/drawingml/2006/main">
               <a:ext uri="{FF2B5EF4-FFF2-40B4-BE49-F238E27FC236}">
-                <a16:creationId xmlns:a16="http://schemas.microsoft.com/office/drawing/2014/main" id="{28F7052F-2CDC-4C25-A5B3-9E2178D01C02}"/>
+                <a16:creationId xmlns:a16="http://schemas.microsoft.com/office/drawing/2014/main" id="{4B475B60-69DD-467B-8E25-EAA4063A020A}"/>
               </a:ext>
             </a:extLst>
           </p:cNvPr>
@@ -4224,7 +4224,7 @@
           <p:cNvPr id="7" name="a1-value">
             <a:extLst xmlns:a="http://schemas.openxmlformats.org/drawingml/2006/main">
               <a:ext uri="{FF2B5EF4-FFF2-40B4-BE49-F238E27FC236}">
-                <a16:creationId xmlns:a16="http://schemas.microsoft.com/office/drawing/2014/main" id="{688D72FE-BB08-4FBF-A06D-D41E0C872F1C}"/>
+                <a16:creationId xmlns:a16="http://schemas.microsoft.com/office/drawing/2014/main" id="{4195320A-1CD7-494B-89BE-16A916F88B0A}"/>
               </a:ext>
             </a:extLst>
           </p:cNvPr>
@@ -4330,7 +4330,7 @@
           <p:nvPr/>
         </p:nvPicPr>
         <p:blipFill>
-          <a:blip xmlns:r="http://schemas.openxmlformats.org/officeDocument/2006/relationships" xmlns:a="http://schemas.openxmlformats.org/drawingml/2006/main" r:embed="Rce95fc5feef94bdf"/>
+          <a:blip xmlns:r="http://schemas.openxmlformats.org/officeDocument/2006/relationships" xmlns:a="http://schemas.openxmlformats.org/drawingml/2006/main" r:embed="R89de161d128246c6"/>
           <a:stretch xmlns:a="http://schemas.openxmlformats.org/drawingml/2006/main"/>
         </p:blipFill>
         <p:spPr>
@@ -4348,7 +4348,7 @@
           <p:cNvPr id="9" name="a2-accounting-label">
             <a:extLst xmlns:a="http://schemas.openxmlformats.org/drawingml/2006/main">
               <a:ext uri="{FF2B5EF4-FFF2-40B4-BE49-F238E27FC236}">
-                <a16:creationId xmlns:a16="http://schemas.microsoft.com/office/drawing/2014/main" id="{960CBB41-198A-477B-B2BF-D8A767279343}"/>
+                <a16:creationId xmlns:a16="http://schemas.microsoft.com/office/drawing/2014/main" id="{5A0F7AA2-81F5-4208-A499-18E6372BC663}"/>
               </a:ext>
             </a:extLst>
           </p:cNvPr>
@@ -4404,7 +4404,7 @@
           <p:cNvPr id="10" name="a2-accounting">
             <a:extLst xmlns:a="http://schemas.openxmlformats.org/drawingml/2006/main">
               <a:ext uri="{FF2B5EF4-FFF2-40B4-BE49-F238E27FC236}">
-                <a16:creationId xmlns:a16="http://schemas.microsoft.com/office/drawing/2014/main" id="{B64A465E-60CE-4136-A85E-D10FA7731306}"/>
+                <a16:creationId xmlns:a16="http://schemas.microsoft.com/office/drawing/2014/main" id="{AFC21FC8-F3B2-4D8E-A07B-62BAE89DC3D4}"/>
               </a:ext>
             </a:extLst>
           </p:cNvPr>
@@ -4460,7 +4460,7 @@
           <p:cNvPr id="11" name="a2-caption">
             <a:extLst xmlns:a="http://schemas.openxmlformats.org/drawingml/2006/main">
               <a:ext uri="{FF2B5EF4-FFF2-40B4-BE49-F238E27FC236}">
-                <a16:creationId xmlns:a16="http://schemas.microsoft.com/office/drawing/2014/main" id="{1762E263-C72B-4A13-B583-F68E0C27E1BD}"/>
+                <a16:creationId xmlns:a16="http://schemas.microsoft.com/office/drawing/2014/main" id="{C88366DE-2AEF-4E99-A0AB-683C384F0D93}"/>
               </a:ext>
             </a:extLst>
           </p:cNvPr>
@@ -4538,7 +4538,7 @@
           <p:cNvPr id="13" name="footer">
             <a:extLst xmlns:a="http://schemas.openxmlformats.org/drawingml/2006/main">
               <a:ext uri="{FF2B5EF4-FFF2-40B4-BE49-F238E27FC236}">
-                <a16:creationId xmlns:a16="http://schemas.microsoft.com/office/drawing/2014/main" id="{20E97E95-E396-4485-AB18-4DF834162C35}"/>
+                <a16:creationId xmlns:a16="http://schemas.microsoft.com/office/drawing/2014/main" id="{31C4E179-48E0-4932-9EAF-C94C30731876}"/>
               </a:ext>
             </a:extLst>
           </p:cNvPr>
@@ -4592,7 +4592,7 @@
     </p:spTree>
     <p:extLst>
       <p:ext uri="{BB962C8B-B14F-4D97-AF65-F5344CB8AC3E}">
-        <p14:creationId xmlns:p14="http://schemas.microsoft.com/office/powerpoint/2010/main" val="1634509882"/>
+        <p14:creationId xmlns:p14="http://schemas.microsoft.com/office/powerpoint/2010/main" val="502526796"/>
       </p:ext>
     </p:extLst>
   </p:cSld>
@@ -4623,7 +4623,7 @@
           <p:cNvPr id="13" name="eyebrow">
             <a:extLst xmlns:a="http://schemas.openxmlformats.org/drawingml/2006/main">
               <a:ext uri="{FF2B5EF4-FFF2-40B4-BE49-F238E27FC236}">
-                <a16:creationId xmlns:a16="http://schemas.microsoft.com/office/drawing/2014/main" id="{F0056D54-A775-4B0B-BE22-A8D2B955B856}"/>
+                <a16:creationId xmlns:a16="http://schemas.microsoft.com/office/drawing/2014/main" id="{61A7BFB5-611B-4CAF-A854-FA69D224C453}"/>
               </a:ext>
             </a:extLst>
           </p:cNvPr>
@@ -4679,7 +4679,7 @@
           <p:cNvPr id="2" name="title">
             <a:extLst xmlns:a="http://schemas.openxmlformats.org/drawingml/2006/main">
               <a:ext uri="{FF2B5EF4-FFF2-40B4-BE49-F238E27FC236}">
-                <a16:creationId xmlns:a16="http://schemas.microsoft.com/office/drawing/2014/main" id="{C42F8535-67E6-4001-9083-4654DD4DA8B2}"/>
+                <a16:creationId xmlns:a16="http://schemas.microsoft.com/office/drawing/2014/main" id="{13DA72C3-5DDD-475A-B496-11809F504005}"/>
               </a:ext>
             </a:extLst>
           </p:cNvPr>
@@ -4735,7 +4735,7 @@
           <p:cNvPr id="3" name="slide-number">
             <a:extLst xmlns:a="http://schemas.openxmlformats.org/drawingml/2006/main">
               <a:ext uri="{FF2B5EF4-FFF2-40B4-BE49-F238E27FC236}">
-                <a16:creationId xmlns:a16="http://schemas.microsoft.com/office/drawing/2014/main" id="{92B6B347-B499-4085-B66E-AD08C237B96D}"/>
+                <a16:creationId xmlns:a16="http://schemas.microsoft.com/office/drawing/2014/main" id="{BA1EA2C4-D3F3-4E9E-BCF6-EAF00B481583}"/>
               </a:ext>
             </a:extLst>
           </p:cNvPr>
@@ -4791,7 +4791,7 @@
           <p:cNvPr id="4" name="subtitle">
             <a:extLst xmlns:a="http://schemas.openxmlformats.org/drawingml/2006/main">
               <a:ext uri="{FF2B5EF4-FFF2-40B4-BE49-F238E27FC236}">
-                <a16:creationId xmlns:a16="http://schemas.microsoft.com/office/drawing/2014/main" id="{9502B991-A28A-41D2-B4AD-0F32ED0ED029}"/>
+                <a16:creationId xmlns:a16="http://schemas.microsoft.com/office/drawing/2014/main" id="{D235DFB0-7CBF-4CCC-8968-6F95423DD411}"/>
               </a:ext>
             </a:extLst>
           </p:cNvPr>
@@ -4851,7 +4851,7 @@
           <p:nvPr/>
         </p:nvPicPr>
         <p:blipFill>
-          <a:blip xmlns:r="http://schemas.openxmlformats.org/officeDocument/2006/relationships" xmlns:a="http://schemas.openxmlformats.org/drawingml/2006/main" r:embed="R37862da9bdfc4130"/>
+          <a:blip xmlns:r="http://schemas.openxmlformats.org/officeDocument/2006/relationships" xmlns:a="http://schemas.openxmlformats.org/drawingml/2006/main" r:embed="Rb7f7e00002da4542"/>
           <a:stretch xmlns:a="http://schemas.openxmlformats.org/drawingml/2006/main"/>
         </p:blipFill>
         <p:spPr>
@@ -4869,7 +4869,7 @@
           <p:cNvPr id="6" name="primary-arms">
             <a:extLst xmlns:a="http://schemas.openxmlformats.org/drawingml/2006/main">
               <a:ext uri="{FF2B5EF4-FFF2-40B4-BE49-F238E27FC236}">
-                <a16:creationId xmlns:a16="http://schemas.microsoft.com/office/drawing/2014/main" id="{8BCB024F-378C-404A-8727-B51ADF1C8BE8}"/>
+                <a16:creationId xmlns:a16="http://schemas.microsoft.com/office/drawing/2014/main" id="{1E5DC4EE-0E26-46A0-A40E-03CFFFDE0C46}"/>
               </a:ext>
             </a:extLst>
           </p:cNvPr>
@@ -4904,7 +4904,7 @@
           <p:cNvPr id="7" name="primary-title">
             <a:extLst xmlns:a="http://schemas.openxmlformats.org/drawingml/2006/main">
               <a:ext uri="{FF2B5EF4-FFF2-40B4-BE49-F238E27FC236}">
-                <a16:creationId xmlns:a16="http://schemas.microsoft.com/office/drawing/2014/main" id="{4703BD3D-BECC-4208-93AC-FD352303B6D5}"/>
+                <a16:creationId xmlns:a16="http://schemas.microsoft.com/office/drawing/2014/main" id="{3C13D3FC-4FEC-47FF-8809-EFCD9CC74C0C}"/>
               </a:ext>
             </a:extLst>
           </p:cNvPr>
@@ -4960,7 +4960,7 @@
           <p:cNvPr id="8" name="primary-list">
             <a:extLst xmlns:a="http://schemas.openxmlformats.org/drawingml/2006/main">
               <a:ext uri="{FF2B5EF4-FFF2-40B4-BE49-F238E27FC236}">
-                <a16:creationId xmlns:a16="http://schemas.microsoft.com/office/drawing/2014/main" id="{9DCF0D9E-1D1C-4475-871D-E795CA8D0DBE}"/>
+                <a16:creationId xmlns:a16="http://schemas.microsoft.com/office/drawing/2014/main" id="{DA301B08-7F90-4EC3-B21B-FABD6D3F642F}"/>
               </a:ext>
             </a:extLst>
           </p:cNvPr>
@@ -5062,7 +5062,7 @@
           <p:cNvPr id="9" name="diagnostic-arms">
             <a:extLst xmlns:a="http://schemas.openxmlformats.org/drawingml/2006/main">
               <a:ext uri="{FF2B5EF4-FFF2-40B4-BE49-F238E27FC236}">
-                <a16:creationId xmlns:a16="http://schemas.microsoft.com/office/drawing/2014/main" id="{A0D2C8A6-6C15-4493-BDEB-BFFD4AA47B76}"/>
+                <a16:creationId xmlns:a16="http://schemas.microsoft.com/office/drawing/2014/main" id="{AE3865F5-8B48-4EE9-87DE-5B95AE62F48A}"/>
               </a:ext>
             </a:extLst>
           </p:cNvPr>
@@ -5097,7 +5097,7 @@
           <p:cNvPr id="10" name="diagnostic-note">
             <a:extLst xmlns:a="http://schemas.openxmlformats.org/drawingml/2006/main">
               <a:ext uri="{FF2B5EF4-FFF2-40B4-BE49-F238E27FC236}">
-                <a16:creationId xmlns:a16="http://schemas.microsoft.com/office/drawing/2014/main" id="{5129E820-38F2-449D-B5FC-96015692F5E6}"/>
+                <a16:creationId xmlns:a16="http://schemas.microsoft.com/office/drawing/2014/main" id="{ADCF7A38-D0BE-4FCA-B04D-9F354F671C80}"/>
               </a:ext>
             </a:extLst>
           </p:cNvPr>
@@ -5175,7 +5175,7 @@
           <p:cNvPr id="12" name="footer">
             <a:extLst xmlns:a="http://schemas.openxmlformats.org/drawingml/2006/main">
               <a:ext uri="{FF2B5EF4-FFF2-40B4-BE49-F238E27FC236}">
-                <a16:creationId xmlns:a16="http://schemas.microsoft.com/office/drawing/2014/main" id="{BEED6B6F-FB7B-4D93-97C4-5AC33F109A48}"/>
+                <a16:creationId xmlns:a16="http://schemas.microsoft.com/office/drawing/2014/main" id="{7DBA5D60-CE99-4713-8D9A-0F575FF6831D}"/>
               </a:ext>
             </a:extLst>
           </p:cNvPr>
@@ -5229,7 +5229,7 @@
     </p:spTree>
     <p:extLst>
       <p:ext uri="{BB962C8B-B14F-4D97-AF65-F5344CB8AC3E}">
-        <p14:creationId xmlns:p14="http://schemas.microsoft.com/office/powerpoint/2010/main" val="955081008"/>
+        <p14:creationId xmlns:p14="http://schemas.microsoft.com/office/powerpoint/2010/main" val="10305247"/>
       </p:ext>
     </p:extLst>
   </p:cSld>
@@ -5260,7 +5260,7 @@
           <p:cNvPr id="17" name="eyebrow">
             <a:extLst xmlns:a="http://schemas.openxmlformats.org/drawingml/2006/main">
               <a:ext uri="{FF2B5EF4-FFF2-40B4-BE49-F238E27FC236}">
-                <a16:creationId xmlns:a16="http://schemas.microsoft.com/office/drawing/2014/main" id="{CC0EC711-6656-4C13-923A-A84E30ACB9DE}"/>
+                <a16:creationId xmlns:a16="http://schemas.microsoft.com/office/drawing/2014/main" id="{7FDC5672-A973-4EE9-9978-A5F65295A391}"/>
               </a:ext>
             </a:extLst>
           </p:cNvPr>
@@ -5316,7 +5316,7 @@
           <p:cNvPr id="2" name="title">
             <a:extLst xmlns:a="http://schemas.openxmlformats.org/drawingml/2006/main">
               <a:ext uri="{FF2B5EF4-FFF2-40B4-BE49-F238E27FC236}">
-                <a16:creationId xmlns:a16="http://schemas.microsoft.com/office/drawing/2014/main" id="{13B34C4D-5996-4CAC-8CDB-D024695474B8}"/>
+                <a16:creationId xmlns:a16="http://schemas.microsoft.com/office/drawing/2014/main" id="{9F49F084-37EE-4FC9-AED9-14DBDFCA800D}"/>
               </a:ext>
             </a:extLst>
           </p:cNvPr>
@@ -5372,7 +5372,7 @@
           <p:cNvPr id="3" name="slide-number">
             <a:extLst xmlns:a="http://schemas.openxmlformats.org/drawingml/2006/main">
               <a:ext uri="{FF2B5EF4-FFF2-40B4-BE49-F238E27FC236}">
-                <a16:creationId xmlns:a16="http://schemas.microsoft.com/office/drawing/2014/main" id="{9A6F541B-DB78-4E7E-8226-8858AE843B22}"/>
+                <a16:creationId xmlns:a16="http://schemas.microsoft.com/office/drawing/2014/main" id="{E73421E6-14AC-4FD8-97FF-21B9F38126C1}"/>
               </a:ext>
             </a:extLst>
           </p:cNvPr>
@@ -5428,7 +5428,7 @@
           <p:cNvPr id="4" name="subtitle">
             <a:extLst xmlns:a="http://schemas.openxmlformats.org/drawingml/2006/main">
               <a:ext uri="{FF2B5EF4-FFF2-40B4-BE49-F238E27FC236}">
-                <a16:creationId xmlns:a16="http://schemas.microsoft.com/office/drawing/2014/main" id="{2CB04B60-F57D-4B31-949C-27585273EDB7}"/>
+                <a16:creationId xmlns:a16="http://schemas.microsoft.com/office/drawing/2014/main" id="{C3202E89-021F-45FC-9F4C-2AF52C257D30}"/>
               </a:ext>
             </a:extLst>
           </p:cNvPr>
@@ -5484,7 +5484,7 @@
           <p:cNvPr id="5" name="launch-status">
             <a:extLst xmlns:a="http://schemas.openxmlformats.org/drawingml/2006/main">
               <a:ext uri="{FF2B5EF4-FFF2-40B4-BE49-F238E27FC236}">
-                <a16:creationId xmlns:a16="http://schemas.microsoft.com/office/drawing/2014/main" id="{3D4B89DC-84A9-4CE9-B4BF-E362B79417A1}"/>
+                <a16:creationId xmlns:a16="http://schemas.microsoft.com/office/drawing/2014/main" id="{72F9D27B-227F-4961-A8D3-679106BA092B}"/>
               </a:ext>
             </a:extLst>
           </p:cNvPr>
@@ -5519,7 +5519,7 @@
           <p:cNvPr id="6" name="operation-count">
             <a:extLst xmlns:a="http://schemas.openxmlformats.org/drawingml/2006/main">
               <a:ext uri="{FF2B5EF4-FFF2-40B4-BE49-F238E27FC236}">
-                <a16:creationId xmlns:a16="http://schemas.microsoft.com/office/drawing/2014/main" id="{5898D9A0-46B0-49BE-A7CD-99692330E664}"/>
+                <a16:creationId xmlns:a16="http://schemas.microsoft.com/office/drawing/2014/main" id="{B78391D5-1EA6-4328-B08C-EC6B113E7E3C}"/>
               </a:ext>
             </a:extLst>
           </p:cNvPr>
@@ -5575,7 +5575,7 @@
           <p:cNvPr id="7" name="operation-label">
             <a:extLst xmlns:a="http://schemas.openxmlformats.org/drawingml/2006/main">
               <a:ext uri="{FF2B5EF4-FFF2-40B4-BE49-F238E27FC236}">
-                <a16:creationId xmlns:a16="http://schemas.microsoft.com/office/drawing/2014/main" id="{3DC9C30A-F300-40BC-A9E1-30685DE24B64}"/>
+                <a16:creationId xmlns:a16="http://schemas.microsoft.com/office/drawing/2014/main" id="{36EE13DD-A06D-41CF-A5DB-445AC91D83B3}"/>
               </a:ext>
             </a:extLst>
           </p:cNvPr>
@@ -5587,7 +5587,7 @@
         <p:spPr>
           <a:xfrm xmlns:a="http://schemas.openxmlformats.org/drawingml/2006/main">
             <a:off x="971550" y="3333750"/>
-            <a:ext cx="1809750" cy="552450"/>
+            <a:ext cx="1809750" cy="685800"/>
           </a:xfrm>
           <a:prstGeom xmlns:a="http://schemas.openxmlformats.org/drawingml/2006/main" prst="rect">
             <a:avLst/>
@@ -5603,7 +5603,7 @@
           <a:lstStyle xmlns:a="http://schemas.openxmlformats.org/drawingml/2006/main"/>
           <a:p xmlns:a="http://schemas.openxmlformats.org/drawingml/2006/main">
             <a:pPr>
-              <a:defRPr sz="1575" b="1">
+              <a:defRPr sz="1350" b="1">
                 <a:solidFill>
                   <a:srgbClr val="14213D"/>
                 </a:solidFill>
@@ -5613,7 +5613,7 @@
               </a:defRPr>
             </a:pPr>
             <a:r>
-              <a:rPr sz="1575" b="1">
+              <a:rPr sz="1350" b="1">
                 <a:solidFill>
                   <a:srgbClr val="14213D"/>
                 </a:solidFill>
@@ -5626,7 +5626,7 @@
           </a:p>
           <a:p xmlns:a="http://schemas.openxmlformats.org/drawingml/2006/main">
             <a:pPr>
-              <a:defRPr sz="1575" b="1">
+              <a:defRPr sz="1350" b="1">
                 <a:solidFill>
                   <a:srgbClr val="14213D"/>
                 </a:solidFill>
@@ -5636,7 +5636,7 @@
               </a:defRPr>
             </a:pPr>
             <a:r>
-              <a:rPr sz="1575" b="1">
+              <a:rPr sz="1350" b="1">
                 <a:solidFill>
                   <a:srgbClr val="14213D"/>
                 </a:solidFill>
@@ -5644,7 +5644,7 @@
                 <a:ea typeface="Aptos"/>
                 <a:cs typeface="Aptos"/>
               </a:rPr>
-              <a:t>in stage 028</a:t>
+              <a:t>12 returned | 2 active</a:t>
             </a:r>
           </a:p>
         </p:txBody>
@@ -5654,7 +5654,7 @@
           <p:cNvPr id="8" name="measurement-scope">
             <a:extLst xmlns:a="http://schemas.openxmlformats.org/drawingml/2006/main">
               <a:ext uri="{FF2B5EF4-FFF2-40B4-BE49-F238E27FC236}">
-                <a16:creationId xmlns:a16="http://schemas.microsoft.com/office/drawing/2014/main" id="{F2CE8D6E-70B5-47F5-B2E5-C32B8C9A7929}"/>
+                <a16:creationId xmlns:a16="http://schemas.microsoft.com/office/drawing/2014/main" id="{5CF3E471-49BF-47B2-8C57-1E137CC6B7EF}"/>
               </a:ext>
             </a:extLst>
           </p:cNvPr>
@@ -5689,7 +5689,7 @@
           <p:cNvPr id="9" name="scope-title">
             <a:extLst xmlns:a="http://schemas.openxmlformats.org/drawingml/2006/main">
               <a:ext uri="{FF2B5EF4-FFF2-40B4-BE49-F238E27FC236}">
-                <a16:creationId xmlns:a16="http://schemas.microsoft.com/office/drawing/2014/main" id="{92EB034D-0DF4-4313-A0C0-4FAD67598986}"/>
+                <a16:creationId xmlns:a16="http://schemas.microsoft.com/office/drawing/2014/main" id="{9BDDED50-EB50-47CC-AEED-D118404A73B3}"/>
               </a:ext>
             </a:extLst>
           </p:cNvPr>
@@ -5745,7 +5745,7 @@
           <p:cNvPr id="10" name="scope-body">
             <a:extLst xmlns:a="http://schemas.openxmlformats.org/drawingml/2006/main">
               <a:ext uri="{FF2B5EF4-FFF2-40B4-BE49-F238E27FC236}">
-                <a16:creationId xmlns:a16="http://schemas.microsoft.com/office/drawing/2014/main" id="{C89A3EF8-2667-4F69-8C2B-63D0A1CF22E4}"/>
+                <a16:creationId xmlns:a16="http://schemas.microsoft.com/office/drawing/2014/main" id="{09E0AB47-C56B-45D0-9842-0197B18212BE}"/>
               </a:ext>
             </a:extLst>
           </p:cNvPr>
@@ -5847,7 +5847,7 @@
           <p:cNvPr id="11" name="decision-boundary">
             <a:extLst xmlns:a="http://schemas.openxmlformats.org/drawingml/2006/main">
               <a:ext uri="{FF2B5EF4-FFF2-40B4-BE49-F238E27FC236}">
-                <a16:creationId xmlns:a16="http://schemas.microsoft.com/office/drawing/2014/main" id="{F15C4A6D-0D6B-49BC-9A49-312E6808354A}"/>
+                <a16:creationId xmlns:a16="http://schemas.microsoft.com/office/drawing/2014/main" id="{DDD06F3F-D6B8-4200-A227-004B84D19D61}"/>
               </a:ext>
             </a:extLst>
           </p:cNvPr>
@@ -5882,7 +5882,7 @@
           <p:cNvPr id="12" name="boundary-title">
             <a:extLst xmlns:a="http://schemas.openxmlformats.org/drawingml/2006/main">
               <a:ext uri="{FF2B5EF4-FFF2-40B4-BE49-F238E27FC236}">
-                <a16:creationId xmlns:a16="http://schemas.microsoft.com/office/drawing/2014/main" id="{DD8D29AB-5250-44FB-BDB6-3197FA7FCD11}"/>
+                <a16:creationId xmlns:a16="http://schemas.microsoft.com/office/drawing/2014/main" id="{076A602C-40C3-48A9-AE4A-B422F3DED54B}"/>
               </a:ext>
             </a:extLst>
           </p:cNvPr>
@@ -5938,7 +5938,7 @@
           <p:cNvPr id="13" name="boundary-body">
             <a:extLst xmlns:a="http://schemas.openxmlformats.org/drawingml/2006/main">
               <a:ext uri="{FF2B5EF4-FFF2-40B4-BE49-F238E27FC236}">
-                <a16:creationId xmlns:a16="http://schemas.microsoft.com/office/drawing/2014/main" id="{5A3A06AC-78A2-453A-AECD-3F452717E212}"/>
+                <a16:creationId xmlns:a16="http://schemas.microsoft.com/office/drawing/2014/main" id="{C99CFB79-C5C8-4854-AD94-E363627DBCF8}"/>
               </a:ext>
             </a:extLst>
           </p:cNvPr>
@@ -6040,7 +6040,7 @@
           <p:cNvPr id="14" name="next-step">
             <a:extLst xmlns:a="http://schemas.openxmlformats.org/drawingml/2006/main">
               <a:ext uri="{FF2B5EF4-FFF2-40B4-BE49-F238E27FC236}">
-                <a16:creationId xmlns:a16="http://schemas.microsoft.com/office/drawing/2014/main" id="{57A085CD-DBE6-4D37-A57C-11FDE1D808D2}"/>
+                <a16:creationId xmlns:a16="http://schemas.microsoft.com/office/drawing/2014/main" id="{0833689E-E0A3-484B-8BBA-E812509C0FA7}"/>
               </a:ext>
             </a:extLst>
           </p:cNvPr>
@@ -6118,7 +6118,7 @@
           <p:cNvPr id="16" name="footer">
             <a:extLst xmlns:a="http://schemas.openxmlformats.org/drawingml/2006/main">
               <a:ext uri="{FF2B5EF4-FFF2-40B4-BE49-F238E27FC236}">
-                <a16:creationId xmlns:a16="http://schemas.microsoft.com/office/drawing/2014/main" id="{7BF838F4-C9E4-4026-BF15-F55B89C83729}"/>
+                <a16:creationId xmlns:a16="http://schemas.microsoft.com/office/drawing/2014/main" id="{BDE799F1-09E4-475B-8C4B-C56398336AE9}"/>
               </a:ext>
             </a:extLst>
           </p:cNvPr>
@@ -6172,7 +6172,7 @@
     </p:spTree>
     <p:extLst>
       <p:ext uri="{BB962C8B-B14F-4D97-AF65-F5344CB8AC3E}">
-        <p14:creationId xmlns:p14="http://schemas.microsoft.com/office/powerpoint/2010/main" val="1077972275"/>
+        <p14:creationId xmlns:p14="http://schemas.microsoft.com/office/powerpoint/2010/main" val="1864972259"/>
       </p:ext>
     </p:extLst>
   </p:cSld>

</xml_diff>

<commit_message>
docs(a3): publish audited transfer closeout
</commit_message>
<xml_diff>
--- a/docs/presentation/progress/ArmIndex_Progress_A0_A3_2026-08-18.pptx
+++ b/docs/presentation/progress/ArmIndex_Progress_A0_A3_2026-08-18.pptx
@@ -2,18 +2,18 @@
 <file path=ppt/presentation.xml><?xml version="1.0" encoding="utf-8"?>
 <p:presentation xmlns:p="http://schemas.openxmlformats.org/presentationml/2006/main">
   <p:sldMasterIdLst>
-    <p:sldMasterId xmlns:r="http://schemas.openxmlformats.org/officeDocument/2006/relationships" id="2147483648" r:id="R2fc37f6cda664f23"/>
+    <p:sldMasterId xmlns:r="http://schemas.openxmlformats.org/officeDocument/2006/relationships" id="2147483648" r:id="R954c53ffbe624fd6"/>
   </p:sldMasterIdLst>
   <p:notesMasterIdLst>
-    <p:notesMasterId xmlns:r="http://schemas.openxmlformats.org/officeDocument/2006/relationships" r:id="Rf36a2d66714a443b"/>
+    <p:notesMasterId xmlns:r="http://schemas.openxmlformats.org/officeDocument/2006/relationships" r:id="Rfd013402eaea4fef"/>
   </p:notesMasterIdLst>
   <p:sldIdLst>
-    <p:sldId xmlns:r="http://schemas.openxmlformats.org/officeDocument/2006/relationships" id="256" r:id="Ra5892d78d5a04582"/>
-    <p:sldId xmlns:r="http://schemas.openxmlformats.org/officeDocument/2006/relationships" id="257" r:id="Rb0494f8ee9b24a7b"/>
-    <p:sldId xmlns:r="http://schemas.openxmlformats.org/officeDocument/2006/relationships" id="258" r:id="Racf5dfe2c0204f48"/>
-    <p:sldId xmlns:r="http://schemas.openxmlformats.org/officeDocument/2006/relationships" id="259" r:id="Rc429f90c446f4f72"/>
-    <p:sldId xmlns:r="http://schemas.openxmlformats.org/officeDocument/2006/relationships" id="260" r:id="Rb21f619cc39445b0"/>
-    <p:sldId xmlns:r="http://schemas.openxmlformats.org/officeDocument/2006/relationships" id="261" r:id="R1260f6e7bb9846f6"/>
+    <p:sldId xmlns:r="http://schemas.openxmlformats.org/officeDocument/2006/relationships" id="256" r:id="Rd2879cc881c74f24"/>
+    <p:sldId xmlns:r="http://schemas.openxmlformats.org/officeDocument/2006/relationships" id="257" r:id="R83993af7f1e246b0"/>
+    <p:sldId xmlns:r="http://schemas.openxmlformats.org/officeDocument/2006/relationships" id="258" r:id="Re58d52d5342a4e61"/>
+    <p:sldId xmlns:r="http://schemas.openxmlformats.org/officeDocument/2006/relationships" id="259" r:id="R6e79fb408dd643b4"/>
+    <p:sldId xmlns:r="http://schemas.openxmlformats.org/officeDocument/2006/relationships" id="260" r:id="R0f1b66d6d40641b6"/>
+    <p:sldId xmlns:r="http://schemas.openxmlformats.org/officeDocument/2006/relationships" id="261" r:id="Raacbbdba4154440d"/>
   </p:sldIdLst>
   <p:sldSz cx="12192000" cy="6858000"/>
   <p:notesSz cx="6858000" cy="9144000"/>
@@ -452,7 +452,7 @@
           </a:p>
           <a:p xmlns:a="http://schemas.openxmlformats.org/drawingml/2006/main">
             <a:r>
-              <a:t>This update reports completed evidence through A2 and the current operational state of A3. It does not present A3 results.</a:t>
+              <a:t>This update reports completed evidence through A3. The A3 result is aggregate-safe development evidence; it does not open production transfer, Selection, or Final.</a:t>
             </a:r>
           </a:p>
           <a:p xmlns:a="http://schemas.openxmlformats.org/drawingml/2006/main">
@@ -902,17 +902,22 @@
           <a:lstStyle xmlns:a="http://schemas.openxmlformats.org/drawingml/2006/main"/>
           <a:p xmlns:a="http://schemas.openxmlformats.org/drawingml/2006/main">
             <a:r>
-              <a:t>Stage 028 launched all nine transfer operations and five fixed combination-control operations. Twelve return receipts are collected; two fixed controls remain active.</a:t>
-            </a:r>
-          </a:p>
-          <a:p xmlns:a="http://schemas.openxmlformats.org/drawingml/2006/main">
-            <a:r>
-              <a:t>Launch is an operational fact, not a performance result. The next valid conclusion requires completed evidence collection, protected local evaluation, completeness checks, and a result-integrity audit.</a:t>
-            </a:r>
-          </a:p>
-          <a:p xmlns:a="http://schemas.openxmlformats.org/drawingml/2006/main">
-            <a:r>
-              <a:t>A4 has no current authorization to proceed.</a:t>
+              <a:t>All 14 authorized operations completed on Train-250 and passed an independent aggregate-only result-integrity audit.</a:t>
+            </a:r>
+          </a:p>
+          <a:p xmlns:a="http://schemas.openxmlformats.org/drawingml/2006/main">
+            <a:r>
+              <a:t>The transfer heatmap shows adapter-dependent quality. The strongest fixed control is top-two RRF-60; the all-primary union is lower on the development workload.</a:t>
+            </a:r>
+          </a:p>
+          <a:p xmlns:a="http://schemas.openxmlformats.org/drawingml/2006/main">
+            <a:r>
+              <a:t>HarnessOpt compiled three complete batches into one effective action signature, so the valid conclusion is a flat-surface stop rather than an adaptive improvement claim.</a:t>
+            </a:r>
+          </a:p>
+          <a:p xmlns:a="http://schemas.openxmlformats.org/drawingml/2006/main">
+            <a:r>
+              <a:t>A4 readiness is prepared contractually, but Selection and Final remain closed.</a:t>
             </a:r>
           </a:p>
           <a:p xmlns:a="http://schemas.openxmlformats.org/drawingml/2006/main">
@@ -922,12 +927,17 @@
           </a:p>
           <a:p xmlns:a="http://schemas.openxmlformats.org/drawingml/2006/main">
             <a:r>
-              <a:t>docs/goal/A3_TRANSFER_COMPLEMENTARITY_AND_HARNESSOPT_goal_003.md</a:t>
-            </a:r>
-          </a:p>
-          <a:p xmlns:a="http://schemas.openxmlformats.org/drawingml/2006/main">
-            <a:r>
-              <a:t>../04_Owner_Stores/armindex/a3/a3-goal003-20260818-028-launch-receipts/ (aggregate receipt count only)</a:t>
+              <a:t>docs/progress_report/update_A3_19AUG2026.md</a:t>
+            </a:r>
+          </a:p>
+          <a:p xmlns:a="http://schemas.openxmlformats.org/drawingml/2006/main">
+            <a:r>
+              <a:t>docs/progress_report/figures/a3-transfer-recall-heatmap-20260819.png</a:t>
+            </a:r>
+          </a:p>
+          <a:p xmlns:a="http://schemas.openxmlformats.org/drawingml/2006/main">
+            <a:r>
+              <a:t>docs/progress_report/A3_transfer_matrix_eda_20260819.csv</a:t>
             </a:r>
           </a:p>
         </p:txBody>
@@ -995,7 +1005,7 @@
   </p:cSld>
   <p:clrMap bg1="lt1" tx1="dk1" bg2="lt2" tx2="dk2" accent1="accent1" accent2="accent2" accent3="accent3" accent4="accent4" accent5="accent5" accent6="accent6" hlink="hlink" folHlink="folHlink"/>
   <p:sldLayoutIdLst>
-    <p:sldLayoutId xmlns:r="http://schemas.openxmlformats.org/officeDocument/2006/relationships" id="2147483649" r:id="R8010f8a2427d48f9"/>
+    <p:sldLayoutId xmlns:r="http://schemas.openxmlformats.org/officeDocument/2006/relationships" id="2147483649" r:id="Rf991cc871b764457"/>
   </p:sldLayoutIdLst>
   <p:txStyles>
     <p:titleStyle>
@@ -1546,7 +1556,7 @@
           <p:cNvPr id="9" name="eyebrow">
             <a:extLst xmlns:a="http://schemas.openxmlformats.org/drawingml/2006/main">
               <a:ext uri="{FF2B5EF4-FFF2-40B4-BE49-F238E27FC236}">
-                <a16:creationId xmlns:a16="http://schemas.microsoft.com/office/drawing/2014/main" id="{38DAB0A1-23EC-492E-BA52-0A0EF4328C6E}"/>
+                <a16:creationId xmlns:a16="http://schemas.microsoft.com/office/drawing/2014/main" id="{4BBC93A3-1F1D-48CD-AFC4-11EB03C71645}"/>
               </a:ext>
             </a:extLst>
           </p:cNvPr>
@@ -1602,7 +1612,7 @@
           <p:cNvPr id="2" name="title">
             <a:extLst xmlns:a="http://schemas.openxmlformats.org/drawingml/2006/main">
               <a:ext uri="{FF2B5EF4-FFF2-40B4-BE49-F238E27FC236}">
-                <a16:creationId xmlns:a16="http://schemas.microsoft.com/office/drawing/2014/main" id="{05062DEA-FF4A-4B27-BEAA-28239DF672DB}"/>
+                <a16:creationId xmlns:a16="http://schemas.microsoft.com/office/drawing/2014/main" id="{313D6C5B-A178-4A16-92E5-E8DD7BFEEB2D}"/>
               </a:ext>
             </a:extLst>
           </p:cNvPr>
@@ -1658,7 +1668,7 @@
           <p:cNvPr id="3" name="subtitle">
             <a:extLst xmlns:a="http://schemas.openxmlformats.org/drawingml/2006/main">
               <a:ext uri="{FF2B5EF4-FFF2-40B4-BE49-F238E27FC236}">
-                <a16:creationId xmlns:a16="http://schemas.microsoft.com/office/drawing/2014/main" id="{7F6CE460-AC25-408A-91E4-9437E18596CB}"/>
+                <a16:creationId xmlns:a16="http://schemas.microsoft.com/office/drawing/2014/main" id="{A23D1CFF-CE13-4E9B-9107-7C4141958F07}"/>
               </a:ext>
             </a:extLst>
           </p:cNvPr>
@@ -1714,7 +1724,7 @@
           <p:cNvPr id="4" name="status-surface">
             <a:extLst xmlns:a="http://schemas.openxmlformats.org/drawingml/2006/main">
               <a:ext uri="{FF2B5EF4-FFF2-40B4-BE49-F238E27FC236}">
-                <a16:creationId xmlns:a16="http://schemas.microsoft.com/office/drawing/2014/main" id="{80B556A2-0CBD-4549-B588-F660667B8100}"/>
+                <a16:creationId xmlns:a16="http://schemas.microsoft.com/office/drawing/2014/main" id="{198FEA0B-259B-435C-8ABD-9AACAAE987B1}"/>
               </a:ext>
             </a:extLst>
           </p:cNvPr>
@@ -1749,7 +1759,7 @@
           <p:cNvPr id="5" name="status">
             <a:extLst xmlns:a="http://schemas.openxmlformats.org/drawingml/2006/main">
               <a:ext uri="{FF2B5EF4-FFF2-40B4-BE49-F238E27FC236}">
-                <a16:creationId xmlns:a16="http://schemas.microsoft.com/office/drawing/2014/main" id="{9CA221FC-5A07-49F3-8E86-7D9A2179CC4F}"/>
+                <a16:creationId xmlns:a16="http://schemas.microsoft.com/office/drawing/2014/main" id="{FD98D035-E8C1-4986-9CD6-A3E84FADC04D}"/>
               </a:ext>
             </a:extLst>
           </p:cNvPr>
@@ -1795,7 +1805,7 @@
                 <a:ea typeface="Aptos"/>
                 <a:cs typeface="Aptos"/>
               </a:rPr>
-              <a:t>A0-A2 complete | A3 measurement in progress | No A3 result yet</a:t>
+              <a:t>A0-A3 complete | Result audit passed | A4 remains gated</a:t>
             </a:r>
           </a:p>
         </p:txBody>
@@ -1805,7 +1815,7 @@
           <p:cNvPr id="6" name="date">
             <a:extLst xmlns:a="http://schemas.openxmlformats.org/drawingml/2006/main">
               <a:ext uri="{FF2B5EF4-FFF2-40B4-BE49-F238E27FC236}">
-                <a16:creationId xmlns:a16="http://schemas.microsoft.com/office/drawing/2014/main" id="{5D96904E-8F75-432A-A135-CA3B627BBA6E}"/>
+                <a16:creationId xmlns:a16="http://schemas.microsoft.com/office/drawing/2014/main" id="{A67844BC-1173-45C1-9119-647E2BB1C880}"/>
               </a:ext>
             </a:extLst>
           </p:cNvPr>
@@ -1883,7 +1893,7 @@
           <p:cNvPr id="8" name="footer">
             <a:extLst xmlns:a="http://schemas.openxmlformats.org/drawingml/2006/main">
               <a:ext uri="{FF2B5EF4-FFF2-40B4-BE49-F238E27FC236}">
-                <a16:creationId xmlns:a16="http://schemas.microsoft.com/office/drawing/2014/main" id="{CD20C955-4E2C-4355-88C9-2834950D803E}"/>
+                <a16:creationId xmlns:a16="http://schemas.microsoft.com/office/drawing/2014/main" id="{C2F3F4C7-DDC3-4420-9582-AEEB57985A3D}"/>
               </a:ext>
             </a:extLst>
           </p:cNvPr>
@@ -1937,7 +1947,7 @@
     </p:spTree>
     <p:extLst>
       <p:ext uri="{BB962C8B-B14F-4D97-AF65-F5344CB8AC3E}">
-        <p14:creationId xmlns:p14="http://schemas.microsoft.com/office/powerpoint/2010/main" val="1509370549"/>
+        <p14:creationId xmlns:p14="http://schemas.microsoft.com/office/powerpoint/2010/main" val="1228188905"/>
       </p:ext>
     </p:extLst>
   </p:cSld>
@@ -1968,7 +1978,7 @@
           <p:cNvPr id="28" name="eyebrow">
             <a:extLst xmlns:a="http://schemas.openxmlformats.org/drawingml/2006/main">
               <a:ext uri="{FF2B5EF4-FFF2-40B4-BE49-F238E27FC236}">
-                <a16:creationId xmlns:a16="http://schemas.microsoft.com/office/drawing/2014/main" id="{69AA129C-8F98-454E-AB2C-D81EEE1D8BDA}"/>
+                <a16:creationId xmlns:a16="http://schemas.microsoft.com/office/drawing/2014/main" id="{41E1FAC1-5FC9-4B21-B6E9-87F7E7389C5D}"/>
               </a:ext>
             </a:extLst>
           </p:cNvPr>
@@ -2024,7 +2034,7 @@
           <p:cNvPr id="2" name="title">
             <a:extLst xmlns:a="http://schemas.openxmlformats.org/drawingml/2006/main">
               <a:ext uri="{FF2B5EF4-FFF2-40B4-BE49-F238E27FC236}">
-                <a16:creationId xmlns:a16="http://schemas.microsoft.com/office/drawing/2014/main" id="{4F2C4DCA-FD6D-42BC-A791-94A525E31630}"/>
+                <a16:creationId xmlns:a16="http://schemas.microsoft.com/office/drawing/2014/main" id="{6734D9DF-3C39-4DFB-AAD8-704770E8C8B1}"/>
               </a:ext>
             </a:extLst>
           </p:cNvPr>
@@ -2080,7 +2090,7 @@
           <p:cNvPr id="3" name="slide-number">
             <a:extLst xmlns:a="http://schemas.openxmlformats.org/drawingml/2006/main">
               <a:ext uri="{FF2B5EF4-FFF2-40B4-BE49-F238E27FC236}">
-                <a16:creationId xmlns:a16="http://schemas.microsoft.com/office/drawing/2014/main" id="{6D6E483D-92C0-4A6E-99FA-2534392E5E02}"/>
+                <a16:creationId xmlns:a16="http://schemas.microsoft.com/office/drawing/2014/main" id="{29718F6F-5CB0-4DCE-98DA-B1308EFC4193}"/>
               </a:ext>
             </a:extLst>
           </p:cNvPr>
@@ -2136,7 +2146,7 @@
           <p:cNvPr id="4" name="subtitle">
             <a:extLst xmlns:a="http://schemas.openxmlformats.org/drawingml/2006/main">
               <a:ext uri="{FF2B5EF4-FFF2-40B4-BE49-F238E27FC236}">
-                <a16:creationId xmlns:a16="http://schemas.microsoft.com/office/drawing/2014/main" id="{969869FB-9D08-4910-BEF6-DE0DAD9B57D0}"/>
+                <a16:creationId xmlns:a16="http://schemas.microsoft.com/office/drawing/2014/main" id="{5CCC0C1A-4966-4E8A-AE06-C30462B3841B}"/>
               </a:ext>
             </a:extLst>
           </p:cNvPr>
@@ -2192,7 +2202,7 @@
           <p:cNvPr id="5" name="phase-A0">
             <a:extLst xmlns:a="http://schemas.openxmlformats.org/drawingml/2006/main">
               <a:ext uri="{FF2B5EF4-FFF2-40B4-BE49-F238E27FC236}">
-                <a16:creationId xmlns:a16="http://schemas.microsoft.com/office/drawing/2014/main" id="{24232039-80B2-4A84-B3FB-837F6291FBAF}"/>
+                <a16:creationId xmlns:a16="http://schemas.microsoft.com/office/drawing/2014/main" id="{A7EE8B7D-009D-493F-9D08-01D10A19B5F7}"/>
               </a:ext>
             </a:extLst>
           </p:cNvPr>
@@ -2227,7 +2237,7 @@
           <p:cNvPr id="6" name="phase-tag-A0">
             <a:extLst xmlns:a="http://schemas.openxmlformats.org/drawingml/2006/main">
               <a:ext uri="{FF2B5EF4-FFF2-40B4-BE49-F238E27FC236}">
-                <a16:creationId xmlns:a16="http://schemas.microsoft.com/office/drawing/2014/main" id="{5F0D2015-1C00-4986-9B7A-0E187662BB56}"/>
+                <a16:creationId xmlns:a16="http://schemas.microsoft.com/office/drawing/2014/main" id="{395786E7-A630-4A60-A573-524A0DD785A5}"/>
               </a:ext>
             </a:extLst>
           </p:cNvPr>
@@ -2262,7 +2272,7 @@
           <p:cNvPr id="7" name="phase-label-A0">
             <a:extLst xmlns:a="http://schemas.openxmlformats.org/drawingml/2006/main">
               <a:ext uri="{FF2B5EF4-FFF2-40B4-BE49-F238E27FC236}">
-                <a16:creationId xmlns:a16="http://schemas.microsoft.com/office/drawing/2014/main" id="{1152F89A-750F-40E0-8164-547643969E96}"/>
+                <a16:creationId xmlns:a16="http://schemas.microsoft.com/office/drawing/2014/main" id="{E1479488-3527-4204-B50F-F6DEF17835C4}"/>
               </a:ext>
             </a:extLst>
           </p:cNvPr>
@@ -2318,7 +2328,7 @@
           <p:cNvPr id="8" name="phase-state-A0">
             <a:extLst xmlns:a="http://schemas.openxmlformats.org/drawingml/2006/main">
               <a:ext uri="{FF2B5EF4-FFF2-40B4-BE49-F238E27FC236}">
-                <a16:creationId xmlns:a16="http://schemas.microsoft.com/office/drawing/2014/main" id="{6D27E6DE-E9F6-4200-A1E5-2A7236E40EA8}"/>
+                <a16:creationId xmlns:a16="http://schemas.microsoft.com/office/drawing/2014/main" id="{69BF0AEA-C23F-474B-BE0D-573A34672444}"/>
               </a:ext>
             </a:extLst>
           </p:cNvPr>
@@ -2374,7 +2384,7 @@
           <p:cNvPr id="9" name="phase-A1">
             <a:extLst xmlns:a="http://schemas.openxmlformats.org/drawingml/2006/main">
               <a:ext uri="{FF2B5EF4-FFF2-40B4-BE49-F238E27FC236}">
-                <a16:creationId xmlns:a16="http://schemas.microsoft.com/office/drawing/2014/main" id="{FFFACB24-6A39-4CCC-B344-77455C3CAB67}"/>
+                <a16:creationId xmlns:a16="http://schemas.microsoft.com/office/drawing/2014/main" id="{F927D657-0AAB-42BC-AC54-FCD5FE23E699}"/>
               </a:ext>
             </a:extLst>
           </p:cNvPr>
@@ -2409,7 +2419,7 @@
           <p:cNvPr id="10" name="phase-tag-A1">
             <a:extLst xmlns:a="http://schemas.openxmlformats.org/drawingml/2006/main">
               <a:ext uri="{FF2B5EF4-FFF2-40B4-BE49-F238E27FC236}">
-                <a16:creationId xmlns:a16="http://schemas.microsoft.com/office/drawing/2014/main" id="{A1F42978-5557-4C3A-84BF-722BD3848BD3}"/>
+                <a16:creationId xmlns:a16="http://schemas.microsoft.com/office/drawing/2014/main" id="{E667870D-508C-47AF-98CD-D25B00D6B1C3}"/>
               </a:ext>
             </a:extLst>
           </p:cNvPr>
@@ -2444,7 +2454,7 @@
           <p:cNvPr id="11" name="phase-label-A1">
             <a:extLst xmlns:a="http://schemas.openxmlformats.org/drawingml/2006/main">
               <a:ext uri="{FF2B5EF4-FFF2-40B4-BE49-F238E27FC236}">
-                <a16:creationId xmlns:a16="http://schemas.microsoft.com/office/drawing/2014/main" id="{B8C95387-7C49-438E-BFDE-A3E3AA5F36AC}"/>
+                <a16:creationId xmlns:a16="http://schemas.microsoft.com/office/drawing/2014/main" id="{D4207132-EFA3-4591-8A58-579F99614746}"/>
               </a:ext>
             </a:extLst>
           </p:cNvPr>
@@ -2500,7 +2510,7 @@
           <p:cNvPr id="12" name="phase-state-A1">
             <a:extLst xmlns:a="http://schemas.openxmlformats.org/drawingml/2006/main">
               <a:ext uri="{FF2B5EF4-FFF2-40B4-BE49-F238E27FC236}">
-                <a16:creationId xmlns:a16="http://schemas.microsoft.com/office/drawing/2014/main" id="{4E75045C-D309-4FC2-87DC-FE9B365447C9}"/>
+                <a16:creationId xmlns:a16="http://schemas.microsoft.com/office/drawing/2014/main" id="{5554B772-07FB-4645-8569-8C31BDD1347C}"/>
               </a:ext>
             </a:extLst>
           </p:cNvPr>
@@ -2556,7 +2566,7 @@
           <p:cNvPr id="13" name="phase-A2">
             <a:extLst xmlns:a="http://schemas.openxmlformats.org/drawingml/2006/main">
               <a:ext uri="{FF2B5EF4-FFF2-40B4-BE49-F238E27FC236}">
-                <a16:creationId xmlns:a16="http://schemas.microsoft.com/office/drawing/2014/main" id="{F58C981F-2401-47FD-BDFB-B8B659DC0AD4}"/>
+                <a16:creationId xmlns:a16="http://schemas.microsoft.com/office/drawing/2014/main" id="{BAF425E0-DE1E-4636-93B1-B422888E304F}"/>
               </a:ext>
             </a:extLst>
           </p:cNvPr>
@@ -2591,7 +2601,7 @@
           <p:cNvPr id="14" name="phase-tag-A2">
             <a:extLst xmlns:a="http://schemas.openxmlformats.org/drawingml/2006/main">
               <a:ext uri="{FF2B5EF4-FFF2-40B4-BE49-F238E27FC236}">
-                <a16:creationId xmlns:a16="http://schemas.microsoft.com/office/drawing/2014/main" id="{DED21040-24BC-4D75-BCA6-835F6AF881F7}"/>
+                <a16:creationId xmlns:a16="http://schemas.microsoft.com/office/drawing/2014/main" id="{8CDCCF76-E3ED-4249-85C9-CE6E704834EE}"/>
               </a:ext>
             </a:extLst>
           </p:cNvPr>
@@ -2626,7 +2636,7 @@
           <p:cNvPr id="15" name="phase-label-A2">
             <a:extLst xmlns:a="http://schemas.openxmlformats.org/drawingml/2006/main">
               <a:ext uri="{FF2B5EF4-FFF2-40B4-BE49-F238E27FC236}">
-                <a16:creationId xmlns:a16="http://schemas.microsoft.com/office/drawing/2014/main" id="{D573002F-CD13-423B-A4C0-423132A3ECC9}"/>
+                <a16:creationId xmlns:a16="http://schemas.microsoft.com/office/drawing/2014/main" id="{51227C61-B03B-4732-A7B0-48128D6EFAC1}"/>
               </a:ext>
             </a:extLst>
           </p:cNvPr>
@@ -2682,7 +2692,7 @@
           <p:cNvPr id="16" name="phase-state-A2">
             <a:extLst xmlns:a="http://schemas.openxmlformats.org/drawingml/2006/main">
               <a:ext uri="{FF2B5EF4-FFF2-40B4-BE49-F238E27FC236}">
-                <a16:creationId xmlns:a16="http://schemas.microsoft.com/office/drawing/2014/main" id="{5C49A7B4-7290-44E2-B822-EDB86FE8832B}"/>
+                <a16:creationId xmlns:a16="http://schemas.microsoft.com/office/drawing/2014/main" id="{BA7F023F-30F5-4F94-B2EB-CA75B7E31293}"/>
               </a:ext>
             </a:extLst>
           </p:cNvPr>
@@ -2738,7 +2748,7 @@
           <p:cNvPr id="17" name="phase-A3">
             <a:extLst xmlns:a="http://schemas.openxmlformats.org/drawingml/2006/main">
               <a:ext uri="{FF2B5EF4-FFF2-40B4-BE49-F238E27FC236}">
-                <a16:creationId xmlns:a16="http://schemas.microsoft.com/office/drawing/2014/main" id="{503F4F00-12B9-4654-8160-9F67C59A42E8}"/>
+                <a16:creationId xmlns:a16="http://schemas.microsoft.com/office/drawing/2014/main" id="{3A673458-3BAB-408C-9B2C-C9FF84D02A4C}"/>
               </a:ext>
             </a:extLst>
           </p:cNvPr>
@@ -2773,7 +2783,7 @@
           <p:cNvPr id="18" name="phase-tag-A3">
             <a:extLst xmlns:a="http://schemas.openxmlformats.org/drawingml/2006/main">
               <a:ext uri="{FF2B5EF4-FFF2-40B4-BE49-F238E27FC236}">
-                <a16:creationId xmlns:a16="http://schemas.microsoft.com/office/drawing/2014/main" id="{DF51DDA9-59A8-463A-AF27-AF56CAE85583}"/>
+                <a16:creationId xmlns:a16="http://schemas.microsoft.com/office/drawing/2014/main" id="{88D6F383-977E-42E4-B654-47DB7C255095}"/>
               </a:ext>
             </a:extLst>
           </p:cNvPr>
@@ -2808,7 +2818,7 @@
           <p:cNvPr id="19" name="phase-label-A3">
             <a:extLst xmlns:a="http://schemas.openxmlformats.org/drawingml/2006/main">
               <a:ext uri="{FF2B5EF4-FFF2-40B4-BE49-F238E27FC236}">
-                <a16:creationId xmlns:a16="http://schemas.microsoft.com/office/drawing/2014/main" id="{EEE0137C-759D-4EC1-807F-275736435E46}"/>
+                <a16:creationId xmlns:a16="http://schemas.microsoft.com/office/drawing/2014/main" id="{2E2145A9-E524-4F5E-BBB7-9696CA9586E6}"/>
               </a:ext>
             </a:extLst>
           </p:cNvPr>
@@ -2864,7 +2874,7 @@
           <p:cNvPr id="20" name="phase-state-A3">
             <a:extLst xmlns:a="http://schemas.openxmlformats.org/drawingml/2006/main">
               <a:ext uri="{FF2B5EF4-FFF2-40B4-BE49-F238E27FC236}">
-                <a16:creationId xmlns:a16="http://schemas.microsoft.com/office/drawing/2014/main" id="{2053DDD0-C3E8-445B-ACD6-23D17FE056C3}"/>
+                <a16:creationId xmlns:a16="http://schemas.microsoft.com/office/drawing/2014/main" id="{550BE36E-6A6F-4EEA-A752-6F6E50A25BCF}"/>
               </a:ext>
             </a:extLst>
           </p:cNvPr>
@@ -2920,7 +2930,7 @@
           <p:cNvPr id="21" name="a0-status">
             <a:extLst xmlns:a="http://schemas.openxmlformats.org/drawingml/2006/main">
               <a:ext uri="{FF2B5EF4-FFF2-40B4-BE49-F238E27FC236}">
-                <a16:creationId xmlns:a16="http://schemas.microsoft.com/office/drawing/2014/main" id="{9712263C-AA9B-4FCE-B6FC-D044C300B4DA}"/>
+                <a16:creationId xmlns:a16="http://schemas.microsoft.com/office/drawing/2014/main" id="{90D41F63-03CF-422B-9417-A44DD510B9BC}"/>
               </a:ext>
             </a:extLst>
           </p:cNvPr>
@@ -2976,7 +2986,7 @@
           <p:cNvPr id="22" name="a1-status">
             <a:extLst xmlns:a="http://schemas.openxmlformats.org/drawingml/2006/main">
               <a:ext uri="{FF2B5EF4-FFF2-40B4-BE49-F238E27FC236}">
-                <a16:creationId xmlns:a16="http://schemas.microsoft.com/office/drawing/2014/main" id="{77B7BC59-78D0-46E1-BE2C-65D304989A21}"/>
+                <a16:creationId xmlns:a16="http://schemas.microsoft.com/office/drawing/2014/main" id="{B0966C0C-748B-43CA-8690-D65904D57935}"/>
               </a:ext>
             </a:extLst>
           </p:cNvPr>
@@ -3032,7 +3042,7 @@
           <p:cNvPr id="23" name="a2-status">
             <a:extLst xmlns:a="http://schemas.openxmlformats.org/drawingml/2006/main">
               <a:ext uri="{FF2B5EF4-FFF2-40B4-BE49-F238E27FC236}">
-                <a16:creationId xmlns:a16="http://schemas.microsoft.com/office/drawing/2014/main" id="{F1861E8B-33A7-44D9-AB8C-67ACDD865AC7}"/>
+                <a16:creationId xmlns:a16="http://schemas.microsoft.com/office/drawing/2014/main" id="{F572A7DC-3615-464E-96EE-3B4F775927FB}"/>
               </a:ext>
             </a:extLst>
           </p:cNvPr>
@@ -3088,7 +3098,7 @@
           <p:cNvPr id="24" name="a3-status">
             <a:extLst xmlns:a="http://schemas.openxmlformats.org/drawingml/2006/main">
               <a:ext uri="{FF2B5EF4-FFF2-40B4-BE49-F238E27FC236}">
-                <a16:creationId xmlns:a16="http://schemas.microsoft.com/office/drawing/2014/main" id="{9A25E700-A454-4078-B8AB-EDE15DA9FB27}"/>
+                <a16:creationId xmlns:a16="http://schemas.microsoft.com/office/drawing/2014/main" id="{30BC53F9-63C6-407A-814F-1897A100AF81}"/>
               </a:ext>
             </a:extLst>
           </p:cNvPr>
@@ -3116,25 +3126,25 @@
           <a:lstStyle xmlns:a="http://schemas.openxmlformats.org/drawingml/2006/main"/>
           <a:p xmlns:a="http://schemas.openxmlformats.org/drawingml/2006/main">
             <a:pPr>
-              <a:defRPr sz="1275">
-                <a:solidFill>
-                  <a:srgbClr val="A15C00"/>
-                </a:solidFill>
-                <a:latin typeface="Aptos"/>
-                <a:ea typeface="Aptos"/>
-                <a:cs typeface="Aptos"/>
-              </a:defRPr>
-            </a:pPr>
-            <a:r>
-              <a:rPr sz="1275">
-                <a:solidFill>
-                  <a:srgbClr val="A15C00"/>
-                </a:solidFill>
-                <a:latin typeface="Aptos"/>
-                <a:ea typeface="Aptos"/>
-                <a:cs typeface="Aptos"/>
-              </a:rPr>
-              <a:t>12 returned / 2 active</a:t>
+              <a:defRPr sz="1350">
+                <a:solidFill>
+                  <a:srgbClr val="2A6F4E"/>
+                </a:solidFill>
+                <a:latin typeface="Aptos"/>
+                <a:ea typeface="Aptos"/>
+                <a:cs typeface="Aptos"/>
+              </a:defRPr>
+            </a:pPr>
+            <a:r>
+              <a:rPr sz="1350">
+                <a:solidFill>
+                  <a:srgbClr val="2A6F4E"/>
+                </a:solidFill>
+                <a:latin typeface="Aptos"/>
+                <a:ea typeface="Aptos"/>
+                <a:cs typeface="Aptos"/>
+              </a:rPr>
+              <a:t>audit passed</a:t>
             </a:r>
           </a:p>
         </p:txBody>
@@ -3144,7 +3154,7 @@
           <p:cNvPr id="25" name="takeaway">
             <a:extLst xmlns:a="http://schemas.openxmlformats.org/drawingml/2006/main">
               <a:ext uri="{FF2B5EF4-FFF2-40B4-BE49-F238E27FC236}">
-                <a16:creationId xmlns:a16="http://schemas.microsoft.com/office/drawing/2014/main" id="{F25F86FE-428D-4AB1-BEEC-6B42730808F0}"/>
+                <a16:creationId xmlns:a16="http://schemas.microsoft.com/office/drawing/2014/main" id="{17B816A2-83BA-4C25-B1B2-B60DFCEB8BED}"/>
               </a:ext>
             </a:extLst>
           </p:cNvPr>
@@ -3222,7 +3232,7 @@
           <p:cNvPr id="27" name="footer">
             <a:extLst xmlns:a="http://schemas.openxmlformats.org/drawingml/2006/main">
               <a:ext uri="{FF2B5EF4-FFF2-40B4-BE49-F238E27FC236}">
-                <a16:creationId xmlns:a16="http://schemas.microsoft.com/office/drawing/2014/main" id="{0808523F-A736-4768-BEC6-79E4DB610DCA}"/>
+                <a16:creationId xmlns:a16="http://schemas.microsoft.com/office/drawing/2014/main" id="{BF62EB60-1897-4AF7-9B4B-CAE2DCC19647}"/>
               </a:ext>
             </a:extLst>
           </p:cNvPr>
@@ -3276,7 +3286,7 @@
     </p:spTree>
     <p:extLst>
       <p:ext uri="{BB962C8B-B14F-4D97-AF65-F5344CB8AC3E}">
-        <p14:creationId xmlns:p14="http://schemas.microsoft.com/office/powerpoint/2010/main" val="1231359672"/>
+        <p14:creationId xmlns:p14="http://schemas.microsoft.com/office/powerpoint/2010/main" val="1705211241"/>
       </p:ext>
     </p:extLst>
   </p:cSld>
@@ -3307,7 +3317,7 @@
           <p:cNvPr id="12" name="eyebrow">
             <a:extLst xmlns:a="http://schemas.openxmlformats.org/drawingml/2006/main">
               <a:ext uri="{FF2B5EF4-FFF2-40B4-BE49-F238E27FC236}">
-                <a16:creationId xmlns:a16="http://schemas.microsoft.com/office/drawing/2014/main" id="{5B77BC88-1DBE-40B1-A023-51370CC2D9A2}"/>
+                <a16:creationId xmlns:a16="http://schemas.microsoft.com/office/drawing/2014/main" id="{F6024F6E-1486-4AEC-964E-D071A186BFB6}"/>
               </a:ext>
             </a:extLst>
           </p:cNvPr>
@@ -3363,7 +3373,7 @@
           <p:cNvPr id="2" name="title">
             <a:extLst xmlns:a="http://schemas.openxmlformats.org/drawingml/2006/main">
               <a:ext uri="{FF2B5EF4-FFF2-40B4-BE49-F238E27FC236}">
-                <a16:creationId xmlns:a16="http://schemas.microsoft.com/office/drawing/2014/main" id="{5D536F1A-7A01-41D8-A9EB-169DCED0E50E}"/>
+                <a16:creationId xmlns:a16="http://schemas.microsoft.com/office/drawing/2014/main" id="{470B3A54-9AEC-44EB-8C29-96C4205A24F3}"/>
               </a:ext>
             </a:extLst>
           </p:cNvPr>
@@ -3419,7 +3429,7 @@
           <p:cNvPr id="3" name="slide-number">
             <a:extLst xmlns:a="http://schemas.openxmlformats.org/drawingml/2006/main">
               <a:ext uri="{FF2B5EF4-FFF2-40B4-BE49-F238E27FC236}">
-                <a16:creationId xmlns:a16="http://schemas.microsoft.com/office/drawing/2014/main" id="{D6CA6780-F0D2-48DB-B515-7F33DAEC1167}"/>
+                <a16:creationId xmlns:a16="http://schemas.microsoft.com/office/drawing/2014/main" id="{56228C05-06D2-4FA4-954B-D5A4605E1370}"/>
               </a:ext>
             </a:extLst>
           </p:cNvPr>
@@ -3475,7 +3485,7 @@
           <p:cNvPr id="4" name="subtitle">
             <a:extLst xmlns:a="http://schemas.openxmlformats.org/drawingml/2006/main">
               <a:ext uri="{FF2B5EF4-FFF2-40B4-BE49-F238E27FC236}">
-                <a16:creationId xmlns:a16="http://schemas.microsoft.com/office/drawing/2014/main" id="{DDEEB814-4B15-424B-93DD-214BDF8241B3}"/>
+                <a16:creationId xmlns:a16="http://schemas.microsoft.com/office/drawing/2014/main" id="{638324D5-55B9-45A8-8961-AE3833426071}"/>
               </a:ext>
             </a:extLst>
           </p:cNvPr>
@@ -3531,7 +3541,7 @@
           <p:cNvPr id="5" name="method-summary">
             <a:extLst xmlns:a="http://schemas.openxmlformats.org/drawingml/2006/main">
               <a:ext uri="{FF2B5EF4-FFF2-40B4-BE49-F238E27FC236}">
-                <a16:creationId xmlns:a16="http://schemas.microsoft.com/office/drawing/2014/main" id="{0A8266CC-3FB5-43DF-A27F-A686953AB2C9}"/>
+                <a16:creationId xmlns:a16="http://schemas.microsoft.com/office/drawing/2014/main" id="{6D8FBD64-2081-41A4-9EBC-FC1215A5525C}"/>
               </a:ext>
             </a:extLst>
           </p:cNvPr>
@@ -3566,7 +3576,7 @@
           <p:cNvPr id="6" name="why-title">
             <a:extLst xmlns:a="http://schemas.openxmlformats.org/drawingml/2006/main">
               <a:ext uri="{FF2B5EF4-FFF2-40B4-BE49-F238E27FC236}">
-                <a16:creationId xmlns:a16="http://schemas.microsoft.com/office/drawing/2014/main" id="{DD72D1D3-CA6B-4C12-A285-7636405BB179}"/>
+                <a16:creationId xmlns:a16="http://schemas.microsoft.com/office/drawing/2014/main" id="{569ACADD-5792-4CF0-BAC3-4CA1C24092F9}"/>
               </a:ext>
             </a:extLst>
           </p:cNvPr>
@@ -3622,7 +3632,7 @@
           <p:cNvPr id="7" name="why-body">
             <a:extLst xmlns:a="http://schemas.openxmlformats.org/drawingml/2006/main">
               <a:ext uri="{FF2B5EF4-FFF2-40B4-BE49-F238E27FC236}">
-                <a16:creationId xmlns:a16="http://schemas.microsoft.com/office/drawing/2014/main" id="{E1B5208D-BD15-47E4-837D-678667FD7850}"/>
+                <a16:creationId xmlns:a16="http://schemas.microsoft.com/office/drawing/2014/main" id="{F8996674-5562-4759-8D03-29D3EE184F2A}"/>
               </a:ext>
             </a:extLst>
           </p:cNvPr>
@@ -3728,7 +3738,7 @@
           <p:nvPr/>
         </p:nvPicPr>
         <p:blipFill>
-          <a:blip xmlns:r="http://schemas.openxmlformats.org/officeDocument/2006/relationships" xmlns:a="http://schemas.openxmlformats.org/drawingml/2006/main" r:embed="R968d5be4c196411f"/>
+          <a:blip xmlns:r="http://schemas.openxmlformats.org/officeDocument/2006/relationships" xmlns:a="http://schemas.openxmlformats.org/drawingml/2006/main" r:embed="Rc996a7c4296e4212"/>
           <a:stretch xmlns:a="http://schemas.openxmlformats.org/drawingml/2006/main"/>
         </p:blipFill>
         <p:spPr>
@@ -3746,7 +3756,7 @@
           <p:cNvPr id="9" name="figure-caption">
             <a:extLst xmlns:a="http://schemas.openxmlformats.org/drawingml/2006/main">
               <a:ext uri="{FF2B5EF4-FFF2-40B4-BE49-F238E27FC236}">
-                <a16:creationId xmlns:a16="http://schemas.microsoft.com/office/drawing/2014/main" id="{ADFA22F1-B9D0-4E36-83E9-EA8DEA4E18D7}"/>
+                <a16:creationId xmlns:a16="http://schemas.microsoft.com/office/drawing/2014/main" id="{335DA086-A0BC-44DB-BA5A-A1C9B4373CFB}"/>
               </a:ext>
             </a:extLst>
           </p:cNvPr>
@@ -3824,7 +3834,7 @@
           <p:cNvPr id="11" name="footer">
             <a:extLst xmlns:a="http://schemas.openxmlformats.org/drawingml/2006/main">
               <a:ext uri="{FF2B5EF4-FFF2-40B4-BE49-F238E27FC236}">
-                <a16:creationId xmlns:a16="http://schemas.microsoft.com/office/drawing/2014/main" id="{24513A4B-E478-43E1-9A78-4BF3007F62E9}"/>
+                <a16:creationId xmlns:a16="http://schemas.microsoft.com/office/drawing/2014/main" id="{D8804A1C-A8A7-4615-9E81-67A258E8BF70}"/>
               </a:ext>
             </a:extLst>
           </p:cNvPr>
@@ -3878,7 +3888,7 @@
     </p:spTree>
     <p:extLst>
       <p:ext uri="{BB962C8B-B14F-4D97-AF65-F5344CB8AC3E}">
-        <p14:creationId xmlns:p14="http://schemas.microsoft.com/office/powerpoint/2010/main" val="1925926083"/>
+        <p14:creationId xmlns:p14="http://schemas.microsoft.com/office/powerpoint/2010/main" val="792774407"/>
       </p:ext>
     </p:extLst>
   </p:cSld>
@@ -3909,7 +3919,7 @@
           <p:cNvPr id="14" name="eyebrow">
             <a:extLst xmlns:a="http://schemas.openxmlformats.org/drawingml/2006/main">
               <a:ext uri="{FF2B5EF4-FFF2-40B4-BE49-F238E27FC236}">
-                <a16:creationId xmlns:a16="http://schemas.microsoft.com/office/drawing/2014/main" id="{AC459C4B-5F93-42CE-9889-FA4BE2FC444A}"/>
+                <a16:creationId xmlns:a16="http://schemas.microsoft.com/office/drawing/2014/main" id="{62AD9293-B195-4F03-95CB-7853362700DA}"/>
               </a:ext>
             </a:extLst>
           </p:cNvPr>
@@ -3965,7 +3975,7 @@
           <p:cNvPr id="2" name="title">
             <a:extLst xmlns:a="http://schemas.openxmlformats.org/drawingml/2006/main">
               <a:ext uri="{FF2B5EF4-FFF2-40B4-BE49-F238E27FC236}">
-                <a16:creationId xmlns:a16="http://schemas.microsoft.com/office/drawing/2014/main" id="{A4E1EB2C-336C-4574-8AC2-2F39B6E0615C}"/>
+                <a16:creationId xmlns:a16="http://schemas.microsoft.com/office/drawing/2014/main" id="{5D82A125-2741-489A-BA91-0686E491620A}"/>
               </a:ext>
             </a:extLst>
           </p:cNvPr>
@@ -4021,7 +4031,7 @@
           <p:cNvPr id="3" name="slide-number">
             <a:extLst xmlns:a="http://schemas.openxmlformats.org/drawingml/2006/main">
               <a:ext uri="{FF2B5EF4-FFF2-40B4-BE49-F238E27FC236}">
-                <a16:creationId xmlns:a16="http://schemas.microsoft.com/office/drawing/2014/main" id="{807E0306-27F8-49EB-9AFB-D24FDFE17DF8}"/>
+                <a16:creationId xmlns:a16="http://schemas.microsoft.com/office/drawing/2014/main" id="{7007CDFF-9E2A-4BBB-923C-C058AB340292}"/>
               </a:ext>
             </a:extLst>
           </p:cNvPr>
@@ -4077,7 +4087,7 @@
           <p:cNvPr id="4" name="subtitle">
             <a:extLst xmlns:a="http://schemas.openxmlformats.org/drawingml/2006/main">
               <a:ext uri="{FF2B5EF4-FFF2-40B4-BE49-F238E27FC236}">
-                <a16:creationId xmlns:a16="http://schemas.microsoft.com/office/drawing/2014/main" id="{E2F2119B-AE32-4BC3-9B89-70052280F3E3}"/>
+                <a16:creationId xmlns:a16="http://schemas.microsoft.com/office/drawing/2014/main" id="{D5219F11-E5F1-428F-961C-A27060E9C0B4}"/>
               </a:ext>
             </a:extLst>
           </p:cNvPr>
@@ -4133,7 +4143,7 @@
           <p:cNvPr id="5" name="a1-summary">
             <a:extLst xmlns:a="http://schemas.openxmlformats.org/drawingml/2006/main">
               <a:ext uri="{FF2B5EF4-FFF2-40B4-BE49-F238E27FC236}">
-                <a16:creationId xmlns:a16="http://schemas.microsoft.com/office/drawing/2014/main" id="{B2773C31-43F1-4DE6-87D0-AAF6FF1C1367}"/>
+                <a16:creationId xmlns:a16="http://schemas.microsoft.com/office/drawing/2014/main" id="{64CA85E6-2E0A-4C99-8F0A-55B8E57EEB97}"/>
               </a:ext>
             </a:extLst>
           </p:cNvPr>
@@ -4168,7 +4178,7 @@
           <p:cNvPr id="6" name="a1-label">
             <a:extLst xmlns:a="http://schemas.openxmlformats.org/drawingml/2006/main">
               <a:ext uri="{FF2B5EF4-FFF2-40B4-BE49-F238E27FC236}">
-                <a16:creationId xmlns:a16="http://schemas.microsoft.com/office/drawing/2014/main" id="{4B475B60-69DD-467B-8E25-EAA4063A020A}"/>
+                <a16:creationId xmlns:a16="http://schemas.microsoft.com/office/drawing/2014/main" id="{A1619035-B9DE-4DFA-8FD1-1A7C70F31E7D}"/>
               </a:ext>
             </a:extLst>
           </p:cNvPr>
@@ -4224,7 +4234,7 @@
           <p:cNvPr id="7" name="a1-value">
             <a:extLst xmlns:a="http://schemas.openxmlformats.org/drawingml/2006/main">
               <a:ext uri="{FF2B5EF4-FFF2-40B4-BE49-F238E27FC236}">
-                <a16:creationId xmlns:a16="http://schemas.microsoft.com/office/drawing/2014/main" id="{4195320A-1CD7-494B-89BE-16A916F88B0A}"/>
+                <a16:creationId xmlns:a16="http://schemas.microsoft.com/office/drawing/2014/main" id="{0B6E2558-AFAF-422F-BD19-D39790C19EA4}"/>
               </a:ext>
             </a:extLst>
           </p:cNvPr>
@@ -4330,7 +4340,7 @@
           <p:nvPr/>
         </p:nvPicPr>
         <p:blipFill>
-          <a:blip xmlns:r="http://schemas.openxmlformats.org/officeDocument/2006/relationships" xmlns:a="http://schemas.openxmlformats.org/drawingml/2006/main" r:embed="R89de161d128246c6"/>
+          <a:blip xmlns:r="http://schemas.openxmlformats.org/officeDocument/2006/relationships" xmlns:a="http://schemas.openxmlformats.org/drawingml/2006/main" r:embed="R094d15b831db4236"/>
           <a:stretch xmlns:a="http://schemas.openxmlformats.org/drawingml/2006/main"/>
         </p:blipFill>
         <p:spPr>
@@ -4348,7 +4358,7 @@
           <p:cNvPr id="9" name="a2-accounting-label">
             <a:extLst xmlns:a="http://schemas.openxmlformats.org/drawingml/2006/main">
               <a:ext uri="{FF2B5EF4-FFF2-40B4-BE49-F238E27FC236}">
-                <a16:creationId xmlns:a16="http://schemas.microsoft.com/office/drawing/2014/main" id="{5A0F7AA2-81F5-4208-A499-18E6372BC663}"/>
+                <a16:creationId xmlns:a16="http://schemas.microsoft.com/office/drawing/2014/main" id="{25CC0BE3-E54B-4ACA-BCD6-B6534AB199F8}"/>
               </a:ext>
             </a:extLst>
           </p:cNvPr>
@@ -4404,7 +4414,7 @@
           <p:cNvPr id="10" name="a2-accounting">
             <a:extLst xmlns:a="http://schemas.openxmlformats.org/drawingml/2006/main">
               <a:ext uri="{FF2B5EF4-FFF2-40B4-BE49-F238E27FC236}">
-                <a16:creationId xmlns:a16="http://schemas.microsoft.com/office/drawing/2014/main" id="{AFC21FC8-F3B2-4D8E-A07B-62BAE89DC3D4}"/>
+                <a16:creationId xmlns:a16="http://schemas.microsoft.com/office/drawing/2014/main" id="{29D6CA68-2DA0-4556-91F7-FA65C8557050}"/>
               </a:ext>
             </a:extLst>
           </p:cNvPr>
@@ -4460,7 +4470,7 @@
           <p:cNvPr id="11" name="a2-caption">
             <a:extLst xmlns:a="http://schemas.openxmlformats.org/drawingml/2006/main">
               <a:ext uri="{FF2B5EF4-FFF2-40B4-BE49-F238E27FC236}">
-                <a16:creationId xmlns:a16="http://schemas.microsoft.com/office/drawing/2014/main" id="{C88366DE-2AEF-4E99-A0AB-683C384F0D93}"/>
+                <a16:creationId xmlns:a16="http://schemas.microsoft.com/office/drawing/2014/main" id="{298937EA-7FFA-4F22-97D2-38F0DD58D0A9}"/>
               </a:ext>
             </a:extLst>
           </p:cNvPr>
@@ -4538,7 +4548,7 @@
           <p:cNvPr id="13" name="footer">
             <a:extLst xmlns:a="http://schemas.openxmlformats.org/drawingml/2006/main">
               <a:ext uri="{FF2B5EF4-FFF2-40B4-BE49-F238E27FC236}">
-                <a16:creationId xmlns:a16="http://schemas.microsoft.com/office/drawing/2014/main" id="{31C4E179-48E0-4932-9EAF-C94C30731876}"/>
+                <a16:creationId xmlns:a16="http://schemas.microsoft.com/office/drawing/2014/main" id="{D0146A8C-900B-4BA2-A05F-618248181C2E}"/>
               </a:ext>
             </a:extLst>
           </p:cNvPr>
@@ -4592,7 +4602,7 @@
     </p:spTree>
     <p:extLst>
       <p:ext uri="{BB962C8B-B14F-4D97-AF65-F5344CB8AC3E}">
-        <p14:creationId xmlns:p14="http://schemas.microsoft.com/office/powerpoint/2010/main" val="502526796"/>
+        <p14:creationId xmlns:p14="http://schemas.microsoft.com/office/powerpoint/2010/main" val="1554209323"/>
       </p:ext>
     </p:extLst>
   </p:cSld>
@@ -4623,7 +4633,7 @@
           <p:cNvPr id="13" name="eyebrow">
             <a:extLst xmlns:a="http://schemas.openxmlformats.org/drawingml/2006/main">
               <a:ext uri="{FF2B5EF4-FFF2-40B4-BE49-F238E27FC236}">
-                <a16:creationId xmlns:a16="http://schemas.microsoft.com/office/drawing/2014/main" id="{61A7BFB5-611B-4CAF-A854-FA69D224C453}"/>
+                <a16:creationId xmlns:a16="http://schemas.microsoft.com/office/drawing/2014/main" id="{310D6AF6-E515-471A-983F-1C3E71876FA7}"/>
               </a:ext>
             </a:extLst>
           </p:cNvPr>
@@ -4679,7 +4689,7 @@
           <p:cNvPr id="2" name="title">
             <a:extLst xmlns:a="http://schemas.openxmlformats.org/drawingml/2006/main">
               <a:ext uri="{FF2B5EF4-FFF2-40B4-BE49-F238E27FC236}">
-                <a16:creationId xmlns:a16="http://schemas.microsoft.com/office/drawing/2014/main" id="{13DA72C3-5DDD-475A-B496-11809F504005}"/>
+                <a16:creationId xmlns:a16="http://schemas.microsoft.com/office/drawing/2014/main" id="{C8E98C3F-B49E-431E-AB95-3696E1175C44}"/>
               </a:ext>
             </a:extLst>
           </p:cNvPr>
@@ -4735,7 +4745,7 @@
           <p:cNvPr id="3" name="slide-number">
             <a:extLst xmlns:a="http://schemas.openxmlformats.org/drawingml/2006/main">
               <a:ext uri="{FF2B5EF4-FFF2-40B4-BE49-F238E27FC236}">
-                <a16:creationId xmlns:a16="http://schemas.microsoft.com/office/drawing/2014/main" id="{BA1EA2C4-D3F3-4E9E-BCF6-EAF00B481583}"/>
+                <a16:creationId xmlns:a16="http://schemas.microsoft.com/office/drawing/2014/main" id="{50C362B9-3AE8-41B0-91AA-42A3BC79CE46}"/>
               </a:ext>
             </a:extLst>
           </p:cNvPr>
@@ -4791,7 +4801,7 @@
           <p:cNvPr id="4" name="subtitle">
             <a:extLst xmlns:a="http://schemas.openxmlformats.org/drawingml/2006/main">
               <a:ext uri="{FF2B5EF4-FFF2-40B4-BE49-F238E27FC236}">
-                <a16:creationId xmlns:a16="http://schemas.microsoft.com/office/drawing/2014/main" id="{D235DFB0-7CBF-4CCC-8968-6F95423DD411}"/>
+                <a16:creationId xmlns:a16="http://schemas.microsoft.com/office/drawing/2014/main" id="{70D76A1A-4AC0-470B-864D-4ADBAEE62A79}"/>
               </a:ext>
             </a:extLst>
           </p:cNvPr>
@@ -4851,7 +4861,7 @@
           <p:nvPr/>
         </p:nvPicPr>
         <p:blipFill>
-          <a:blip xmlns:r="http://schemas.openxmlformats.org/officeDocument/2006/relationships" xmlns:a="http://schemas.openxmlformats.org/drawingml/2006/main" r:embed="Rb7f7e00002da4542"/>
+          <a:blip xmlns:r="http://schemas.openxmlformats.org/officeDocument/2006/relationships" xmlns:a="http://schemas.openxmlformats.org/drawingml/2006/main" r:embed="R495f765a0dfa4dab"/>
           <a:stretch xmlns:a="http://schemas.openxmlformats.org/drawingml/2006/main"/>
         </p:blipFill>
         <p:spPr>
@@ -4869,7 +4879,7 @@
           <p:cNvPr id="6" name="primary-arms">
             <a:extLst xmlns:a="http://schemas.openxmlformats.org/drawingml/2006/main">
               <a:ext uri="{FF2B5EF4-FFF2-40B4-BE49-F238E27FC236}">
-                <a16:creationId xmlns:a16="http://schemas.microsoft.com/office/drawing/2014/main" id="{1E5DC4EE-0E26-46A0-A40E-03CFFFDE0C46}"/>
+                <a16:creationId xmlns:a16="http://schemas.microsoft.com/office/drawing/2014/main" id="{D6E8EF24-1FA9-4E9C-A9DD-BE60681662F1}"/>
               </a:ext>
             </a:extLst>
           </p:cNvPr>
@@ -4904,7 +4914,7 @@
           <p:cNvPr id="7" name="primary-title">
             <a:extLst xmlns:a="http://schemas.openxmlformats.org/drawingml/2006/main">
               <a:ext uri="{FF2B5EF4-FFF2-40B4-BE49-F238E27FC236}">
-                <a16:creationId xmlns:a16="http://schemas.microsoft.com/office/drawing/2014/main" id="{3C13D3FC-4FEC-47FF-8809-EFCD9CC74C0C}"/>
+                <a16:creationId xmlns:a16="http://schemas.microsoft.com/office/drawing/2014/main" id="{5F496B90-CC8F-4EEE-B779-0918B9528DD8}"/>
               </a:ext>
             </a:extLst>
           </p:cNvPr>
@@ -4960,7 +4970,7 @@
           <p:cNvPr id="8" name="primary-list">
             <a:extLst xmlns:a="http://schemas.openxmlformats.org/drawingml/2006/main">
               <a:ext uri="{FF2B5EF4-FFF2-40B4-BE49-F238E27FC236}">
-                <a16:creationId xmlns:a16="http://schemas.microsoft.com/office/drawing/2014/main" id="{DA301B08-7F90-4EC3-B21B-FABD6D3F642F}"/>
+                <a16:creationId xmlns:a16="http://schemas.microsoft.com/office/drawing/2014/main" id="{FD5CE724-09A2-49CA-B83C-D666649FBD9A}"/>
               </a:ext>
             </a:extLst>
           </p:cNvPr>
@@ -5062,7 +5072,7 @@
           <p:cNvPr id="9" name="diagnostic-arms">
             <a:extLst xmlns:a="http://schemas.openxmlformats.org/drawingml/2006/main">
               <a:ext uri="{FF2B5EF4-FFF2-40B4-BE49-F238E27FC236}">
-                <a16:creationId xmlns:a16="http://schemas.microsoft.com/office/drawing/2014/main" id="{AE3865F5-8B48-4EE9-87DE-5B95AE62F48A}"/>
+                <a16:creationId xmlns:a16="http://schemas.microsoft.com/office/drawing/2014/main" id="{003E98AC-6519-455F-AD57-3B319729304C}"/>
               </a:ext>
             </a:extLst>
           </p:cNvPr>
@@ -5097,7 +5107,7 @@
           <p:cNvPr id="10" name="diagnostic-note">
             <a:extLst xmlns:a="http://schemas.openxmlformats.org/drawingml/2006/main">
               <a:ext uri="{FF2B5EF4-FFF2-40B4-BE49-F238E27FC236}">
-                <a16:creationId xmlns:a16="http://schemas.microsoft.com/office/drawing/2014/main" id="{ADCF7A38-D0BE-4FCA-B04D-9F354F671C80}"/>
+                <a16:creationId xmlns:a16="http://schemas.microsoft.com/office/drawing/2014/main" id="{DA9F86D7-139C-4688-A9C2-321CE876F4BE}"/>
               </a:ext>
             </a:extLst>
           </p:cNvPr>
@@ -5175,7 +5185,7 @@
           <p:cNvPr id="12" name="footer">
             <a:extLst xmlns:a="http://schemas.openxmlformats.org/drawingml/2006/main">
               <a:ext uri="{FF2B5EF4-FFF2-40B4-BE49-F238E27FC236}">
-                <a16:creationId xmlns:a16="http://schemas.microsoft.com/office/drawing/2014/main" id="{7DBA5D60-CE99-4713-8D9A-0F575FF6831D}"/>
+                <a16:creationId xmlns:a16="http://schemas.microsoft.com/office/drawing/2014/main" id="{3AC34433-6BD6-4284-9B32-B5FF96E1BAE8}"/>
               </a:ext>
             </a:extLst>
           </p:cNvPr>
@@ -5229,7 +5239,7 @@
     </p:spTree>
     <p:extLst>
       <p:ext uri="{BB962C8B-B14F-4D97-AF65-F5344CB8AC3E}">
-        <p14:creationId xmlns:p14="http://schemas.microsoft.com/office/powerpoint/2010/main" val="10305247"/>
+        <p14:creationId xmlns:p14="http://schemas.microsoft.com/office/powerpoint/2010/main" val="2051086610"/>
       </p:ext>
     </p:extLst>
   </p:cSld>
@@ -5257,10 +5267,10 @@
       </p:grpSpPr>
       <p:sp>
         <p:nvSpPr>
-          <p:cNvPr id="17" name="eyebrow">
-            <a:extLst xmlns:a="http://schemas.openxmlformats.org/drawingml/2006/main">
-              <a:ext uri="{FF2B5EF4-FFF2-40B4-BE49-F238E27FC236}">
-                <a16:creationId xmlns:a16="http://schemas.microsoft.com/office/drawing/2014/main" id="{7FDC5672-A973-4EE9-9978-A5F65295A391}"/>
+          <p:cNvPr id="13" name="eyebrow">
+            <a:extLst xmlns:a="http://schemas.openxmlformats.org/drawingml/2006/main">
+              <a:ext uri="{FF2B5EF4-FFF2-40B4-BE49-F238E27FC236}">
+                <a16:creationId xmlns:a16="http://schemas.microsoft.com/office/drawing/2014/main" id="{7B4BB9F4-F728-44BF-A36A-91C8E0EC7186}"/>
               </a:ext>
             </a:extLst>
           </p:cNvPr>
@@ -5316,7 +5326,7 @@
           <p:cNvPr id="2" name="title">
             <a:extLst xmlns:a="http://schemas.openxmlformats.org/drawingml/2006/main">
               <a:ext uri="{FF2B5EF4-FFF2-40B4-BE49-F238E27FC236}">
-                <a16:creationId xmlns:a16="http://schemas.microsoft.com/office/drawing/2014/main" id="{9F49F084-37EE-4FC9-AED9-14DBDFCA800D}"/>
+                <a16:creationId xmlns:a16="http://schemas.microsoft.com/office/drawing/2014/main" id="{9F5E3E82-0B0D-4195-BE0C-5F0BFD30C0AB}"/>
               </a:ext>
             </a:extLst>
           </p:cNvPr>
@@ -5362,7 +5372,7 @@
                 <a:ea typeface="Aptos"/>
                 <a:cs typeface="Aptos"/>
               </a:rPr>
-              <a:t>A3 is running; conclusions await a result audit</a:t>
+              <a:t>A3 result audit: transfer is adapter-dependent</a:t>
             </a:r>
           </a:p>
         </p:txBody>
@@ -5372,7 +5382,7 @@
           <p:cNvPr id="3" name="slide-number">
             <a:extLst xmlns:a="http://schemas.openxmlformats.org/drawingml/2006/main">
               <a:ext uri="{FF2B5EF4-FFF2-40B4-BE49-F238E27FC236}">
-                <a16:creationId xmlns:a16="http://schemas.microsoft.com/office/drawing/2014/main" id="{E73421E6-14AC-4FD8-97FF-21B9F38126C1}"/>
+                <a16:creationId xmlns:a16="http://schemas.microsoft.com/office/drawing/2014/main" id="{F5F933F2-0866-4FF7-930B-67ED561E9347}"/>
               </a:ext>
             </a:extLst>
           </p:cNvPr>
@@ -5428,7 +5438,7 @@
           <p:cNvPr id="4" name="subtitle">
             <a:extLst xmlns:a="http://schemas.openxmlformats.org/drawingml/2006/main">
               <a:ext uri="{FF2B5EF4-FFF2-40B4-BE49-F238E27FC236}">
-                <a16:creationId xmlns:a16="http://schemas.microsoft.com/office/drawing/2014/main" id="{C3202E89-021F-45FC-9F4C-2AF52C257D30}"/>
+                <a16:creationId xmlns:a16="http://schemas.microsoft.com/office/drawing/2014/main" id="{2FAEB971-9822-4AC3-9C98-D39A05CDDCBF}"/>
               </a:ext>
             </a:extLst>
           </p:cNvPr>
@@ -5474,41 +5484,63 @@
                 <a:ea typeface="Aptos"/>
                 <a:cs typeface="Aptos"/>
               </a:rPr>
-              <a:t>The current work tests transfer and fixed combination controls before any production decision.</a:t>
-            </a:r>
-          </a:p>
-        </p:txBody>
-      </p:sp>
-      <p:sp>
-        <p:nvSpPr>
-          <p:cNvPr id="5" name="launch-status">
-            <a:extLst xmlns:a="http://schemas.openxmlformats.org/drawingml/2006/main">
-              <a:ext uri="{FF2B5EF4-FFF2-40B4-BE49-F238E27FC236}">
-                <a16:creationId xmlns:a16="http://schemas.microsoft.com/office/drawing/2014/main" id="{72F9D27B-227F-4961-A8D3-679106BA092B}"/>
-              </a:ext>
-            </a:extLst>
-          </p:cNvPr>
-          <p:cNvSpPr>
-            <a:spLocks xmlns:a="http://schemas.openxmlformats.org/drawingml/2006/main" noGrp="1"/>
-          </p:cNvSpPr>
-          <p:nvPr/>
-        </p:nvSpPr>
-        <p:spPr>
-          <a:xfrm xmlns:a="http://schemas.openxmlformats.org/drawingml/2006/main">
-            <a:off x="685800" y="2238375"/>
-            <a:ext cx="2571750" cy="2095500"/>
+              <a:t>All 14 Train-250 operations completed; the strongest fixed control is top-two RRF-60.</a:t>
+            </a:r>
+          </a:p>
+        </p:txBody>
+      </p:sp>
+      <p:pic>
+        <p:nvPicPr>
+          <p:cNvPr id="17" name=""/>
+          <p:cNvPicPr>
+            <a:picLocks xmlns:a="http://schemas.openxmlformats.org/drawingml/2006/main" noChangeAspect="1"/>
+          </p:cNvPicPr>
+          <p:nvPr/>
+        </p:nvPicPr>
+        <p:blipFill>
+          <a:blip xmlns:r="http://schemas.openxmlformats.org/officeDocument/2006/relationships" xmlns:a="http://schemas.openxmlformats.org/drawingml/2006/main" r:embed="Rcc91335111264bc6"/>
+          <a:stretch xmlns:a="http://schemas.openxmlformats.org/drawingml/2006/main"/>
+        </p:blipFill>
+        <p:spPr>
+          <a:xfrm xmlns:a="http://schemas.openxmlformats.org/drawingml/2006/main">
+            <a:off x="1417184" y="2047875"/>
+            <a:ext cx="4347482" cy="3381375"/>
+          </a:xfrm>
+          <a:prstGeom xmlns:a="http://schemas.openxmlformats.org/drawingml/2006/main" prst="rect">
+            <a:avLst/>
+          </a:prstGeom>
+        </p:spPr>
+      </p:pic>
+      <p:sp>
+        <p:nvSpPr>
+          <p:cNvPr id="6" name="a3-results">
+            <a:extLst xmlns:a="http://schemas.openxmlformats.org/drawingml/2006/main">
+              <a:ext uri="{FF2B5EF4-FFF2-40B4-BE49-F238E27FC236}">
+                <a16:creationId xmlns:a16="http://schemas.microsoft.com/office/drawing/2014/main" id="{6829A2D3-B6C3-4878-BEB9-E57BB1CEB045}"/>
+              </a:ext>
+            </a:extLst>
+          </p:cNvPr>
+          <p:cNvSpPr>
+            <a:spLocks xmlns:a="http://schemas.openxmlformats.org/drawingml/2006/main" noGrp="1"/>
+          </p:cNvSpPr>
+          <p:nvPr/>
+        </p:nvSpPr>
+        <p:spPr>
+          <a:xfrm xmlns:a="http://schemas.openxmlformats.org/drawingml/2006/main">
+            <a:off x="6858000" y="2047875"/>
+            <a:ext cx="4362450" cy="3381375"/>
           </a:xfrm>
           <a:prstGeom xmlns:a="http://schemas.openxmlformats.org/drawingml/2006/main" prst="roundRect">
             <a:avLst>
-              <a:gd name="adj" fmla="val 3636"/>
+              <a:gd name="adj" fmla="val 2254"/>
             </a:avLst>
           </a:prstGeom>
           <a:solidFill xmlns:a="http://schemas.openxmlformats.org/drawingml/2006/main">
-            <a:srgbClr val="FFF4E5"/>
+            <a:srgbClr val="E7F5F4"/>
           </a:solidFill>
           <a:ln xmlns:a="http://schemas.openxmlformats.org/drawingml/2006/main" w="9525">
             <a:solidFill>
-              <a:srgbClr val="FFF4E5"/>
+              <a:srgbClr val="E7F5F4"/>
             </a:solidFill>
             <a:prstDash val="solid"/>
           </a:ln>
@@ -5516,22 +5548,22 @@
       </p:sp>
       <p:sp>
         <p:nvSpPr>
-          <p:cNvPr id="6" name="operation-count">
-            <a:extLst xmlns:a="http://schemas.openxmlformats.org/drawingml/2006/main">
-              <a:ext uri="{FF2B5EF4-FFF2-40B4-BE49-F238E27FC236}">
-                <a16:creationId xmlns:a16="http://schemas.microsoft.com/office/drawing/2014/main" id="{B78391D5-1EA6-4328-B08C-EC6B113E7E3C}"/>
-              </a:ext>
-            </a:extLst>
-          </p:cNvPr>
-          <p:cNvSpPr>
-            <a:spLocks xmlns:a="http://schemas.openxmlformats.org/drawingml/2006/main" noGrp="1"/>
-          </p:cNvSpPr>
-          <p:nvPr/>
-        </p:nvSpPr>
-        <p:spPr>
-          <a:xfrm xmlns:a="http://schemas.openxmlformats.org/drawingml/2006/main">
-            <a:off x="971550" y="2619375"/>
-            <a:ext cx="1857375" cy="571500"/>
+          <p:cNvPr id="7" name="results-title">
+            <a:extLst xmlns:a="http://schemas.openxmlformats.org/drawingml/2006/main">
+              <a:ext uri="{FF2B5EF4-FFF2-40B4-BE49-F238E27FC236}">
+                <a16:creationId xmlns:a16="http://schemas.microsoft.com/office/drawing/2014/main" id="{9DC8D9E0-C3FB-46ED-B848-4440954DD354}"/>
+              </a:ext>
+            </a:extLst>
+          </p:cNvPr>
+          <p:cNvSpPr>
+            <a:spLocks xmlns:a="http://schemas.openxmlformats.org/drawingml/2006/main" noGrp="1"/>
+          </p:cNvSpPr>
+          <p:nvPr/>
+        </p:nvSpPr>
+        <p:spPr>
+          <a:xfrm xmlns:a="http://schemas.openxmlformats.org/drawingml/2006/main">
+            <a:off x="7143750" y="2352675"/>
+            <a:ext cx="3143250" cy="285750"/>
           </a:xfrm>
           <a:prstGeom xmlns:a="http://schemas.openxmlformats.org/drawingml/2006/main" prst="rect">
             <a:avLst/>
@@ -5547,47 +5579,47 @@
           <a:lstStyle xmlns:a="http://schemas.openxmlformats.org/drawingml/2006/main"/>
           <a:p xmlns:a="http://schemas.openxmlformats.org/drawingml/2006/main">
             <a:pPr>
-              <a:defRPr sz="3525" b="1">
-                <a:solidFill>
-                  <a:srgbClr val="A15C00"/>
-                </a:solidFill>
-                <a:latin typeface="Aptos"/>
-                <a:ea typeface="Aptos"/>
-                <a:cs typeface="Aptos"/>
-              </a:defRPr>
-            </a:pPr>
-            <a:r>
-              <a:rPr sz="3525" b="1">
-                <a:solidFill>
-                  <a:srgbClr val="A15C00"/>
-                </a:solidFill>
-                <a:latin typeface="Aptos"/>
-                <a:ea typeface="Aptos"/>
-                <a:cs typeface="Aptos"/>
-              </a:rPr>
-              <a:t>14 / 14</a:t>
-            </a:r>
-          </a:p>
-        </p:txBody>
-      </p:sp>
-      <p:sp>
-        <p:nvSpPr>
-          <p:cNvPr id="7" name="operation-label">
-            <a:extLst xmlns:a="http://schemas.openxmlformats.org/drawingml/2006/main">
-              <a:ext uri="{FF2B5EF4-FFF2-40B4-BE49-F238E27FC236}">
-                <a16:creationId xmlns:a16="http://schemas.microsoft.com/office/drawing/2014/main" id="{36EE13DD-A06D-41CF-A5DB-445AC91D83B3}"/>
-              </a:ext>
-            </a:extLst>
-          </p:cNvPr>
-          <p:cNvSpPr>
-            <a:spLocks xmlns:a="http://schemas.openxmlformats.org/drawingml/2006/main" noGrp="1"/>
-          </p:cNvSpPr>
-          <p:nvPr/>
-        </p:nvSpPr>
-        <p:spPr>
-          <a:xfrm xmlns:a="http://schemas.openxmlformats.org/drawingml/2006/main">
-            <a:off x="971550" y="3333750"/>
-            <a:ext cx="1809750" cy="685800"/>
+              <a:defRPr sz="1800" b="1">
+                <a:solidFill>
+                  <a:srgbClr val="2A6F4E"/>
+                </a:solidFill>
+                <a:latin typeface="Aptos"/>
+                <a:ea typeface="Aptos"/>
+                <a:cs typeface="Aptos"/>
+              </a:defRPr>
+            </a:pPr>
+            <a:r>
+              <a:rPr sz="1800" b="1">
+                <a:solidFill>
+                  <a:srgbClr val="2A6F4E"/>
+                </a:solidFill>
+                <a:latin typeface="Aptos"/>
+                <a:ea typeface="Aptos"/>
+                <a:cs typeface="Aptos"/>
+              </a:rPr>
+              <a:t>Audited findings</a:t>
+            </a:r>
+          </a:p>
+        </p:txBody>
+      </p:sp>
+      <p:sp>
+        <p:nvSpPr>
+          <p:cNvPr id="8" name="results-body">
+            <a:extLst xmlns:a="http://schemas.openxmlformats.org/drawingml/2006/main">
+              <a:ext uri="{FF2B5EF4-FFF2-40B4-BE49-F238E27FC236}">
+                <a16:creationId xmlns:a16="http://schemas.microsoft.com/office/drawing/2014/main" id="{2415D03E-4733-4DF1-A32A-F8E9195EE622}"/>
+              </a:ext>
+            </a:extLst>
+          </p:cNvPr>
+          <p:cNvSpPr>
+            <a:spLocks xmlns:a="http://schemas.openxmlformats.org/drawingml/2006/main" noGrp="1"/>
+          </p:cNvSpPr>
+          <p:nvPr/>
+        </p:nvSpPr>
+        <p:spPr>
+          <a:xfrm xmlns:a="http://schemas.openxmlformats.org/drawingml/2006/main">
+            <a:off x="7143750" y="2924175"/>
+            <a:ext cx="3714750" cy="1428750"/>
           </a:xfrm>
           <a:prstGeom xmlns:a="http://schemas.openxmlformats.org/drawingml/2006/main" prst="rect">
             <a:avLst/>
@@ -5603,7 +5635,7 @@
           <a:lstStyle xmlns:a="http://schemas.openxmlformats.org/drawingml/2006/main"/>
           <a:p xmlns:a="http://schemas.openxmlformats.org/drawingml/2006/main">
             <a:pPr>
-              <a:defRPr sz="1350" b="1">
+              <a:defRPr sz="1425">
                 <a:solidFill>
                   <a:srgbClr val="14213D"/>
                 </a:solidFill>
@@ -5613,7 +5645,7 @@
               </a:defRPr>
             </a:pPr>
             <a:r>
-              <a:rPr sz="1350" b="1">
+              <a:rPr sz="1425">
                 <a:solidFill>
                   <a:srgbClr val="14213D"/>
                 </a:solidFill>
@@ -5621,12 +5653,12 @@
                 <a:ea typeface="Aptos"/>
                 <a:cs typeface="Aptos"/>
               </a:rPr>
-              <a:t>operations launched</a:t>
+              <a:t>- Best transfer: ARM-05 -&gt; ARM-03, Recall@100 0.419</a:t>
             </a:r>
           </a:p>
           <a:p xmlns:a="http://schemas.openxmlformats.org/drawingml/2006/main">
             <a:pPr>
-              <a:defRPr sz="1350" b="1">
+              <a:defRPr sz="1425">
                 <a:solidFill>
                   <a:srgbClr val="14213D"/>
                 </a:solidFill>
@@ -5636,7 +5668,7 @@
               </a:defRPr>
             </a:pPr>
             <a:r>
-              <a:rPr sz="1350" b="1">
+              <a:rPr sz="1425">
                 <a:solidFill>
                   <a:srgbClr val="14213D"/>
                 </a:solidFill>
@@ -5644,38 +5676,183 @@
                 <a:ea typeface="Aptos"/>
                 <a:cs typeface="Aptos"/>
               </a:rPr>
-              <a:t>12 returned | 2 active</a:t>
-            </a:r>
-          </a:p>
-        </p:txBody>
-      </p:sp>
-      <p:sp>
-        <p:nvSpPr>
-          <p:cNvPr id="8" name="measurement-scope">
-            <a:extLst xmlns:a="http://schemas.openxmlformats.org/drawingml/2006/main">
-              <a:ext uri="{FF2B5EF4-FFF2-40B4-BE49-F238E27FC236}">
-                <a16:creationId xmlns:a16="http://schemas.microsoft.com/office/drawing/2014/main" id="{5CF3E471-49BF-47B2-8C57-1E137CC6B7EF}"/>
-              </a:ext>
-            </a:extLst>
-          </p:cNvPr>
-          <p:cNvSpPr>
-            <a:spLocks xmlns:a="http://schemas.openxmlformats.org/drawingml/2006/main" noGrp="1"/>
-          </p:cNvSpPr>
-          <p:nvPr/>
-        </p:nvSpPr>
-        <p:spPr>
-          <a:xfrm xmlns:a="http://schemas.openxmlformats.org/drawingml/2006/main">
-            <a:off x="3619500" y="2238375"/>
-            <a:ext cx="3429000" cy="2095500"/>
-          </a:xfrm>
-          <a:prstGeom xmlns:a="http://schemas.openxmlformats.org/drawingml/2006/main" prst="roundRect">
-            <a:avLst>
-              <a:gd name="adj" fmla="val 3636"/>
-            </a:avLst>
-          </a:prstGeom>
-          <a:solidFill xmlns:a="http://schemas.openxmlformats.org/drawingml/2006/main">
-            <a:srgbClr val="FFFFFF"/>
-          </a:solidFill>
+              <a:t>- Best fixed control: top-two RRF-60, Recall@100 0.419</a:t>
+            </a:r>
+          </a:p>
+          <a:p xmlns:a="http://schemas.openxmlformats.org/drawingml/2006/main">
+            <a:pPr>
+              <a:defRPr sz="1425">
+                <a:solidFill>
+                  <a:srgbClr val="14213D"/>
+                </a:solidFill>
+                <a:latin typeface="Aptos"/>
+                <a:ea typeface="Aptos"/>
+                <a:cs typeface="Aptos"/>
+              </a:defRPr>
+            </a:pPr>
+            <a:r>
+              <a:rPr sz="1425">
+                <a:solidFill>
+                  <a:srgbClr val="14213D"/>
+                </a:solidFill>
+                <a:latin typeface="Aptos"/>
+                <a:ea typeface="Aptos"/>
+                <a:cs typeface="Aptos"/>
+              </a:rPr>
+              <a:t>- All-primary union: 0.415 Recall@100</a:t>
+            </a:r>
+          </a:p>
+          <a:p xmlns:a="http://schemas.openxmlformats.org/drawingml/2006/main">
+            <a:pPr>
+              <a:defRPr sz="1425">
+                <a:solidFill>
+                  <a:srgbClr val="14213D"/>
+                </a:solidFill>
+                <a:latin typeface="Aptos"/>
+                <a:ea typeface="Aptos"/>
+                <a:cs typeface="Aptos"/>
+              </a:defRPr>
+            </a:pPr>
+            <a:r>
+              <a:rPr sz="1425">
+                <a:solidFill>
+                  <a:srgbClr val="14213D"/>
+                </a:solidFill>
+                <a:latin typeface="Aptos"/>
+                <a:ea typeface="Aptos"/>
+                <a:cs typeface="Aptos"/>
+              </a:rPr>
+              <a:t>- HarnessOpt: flat surface, no adaptive gain</a:t>
+            </a:r>
+          </a:p>
+        </p:txBody>
+      </p:sp>
+      <p:sp>
+        <p:nvSpPr>
+          <p:cNvPr id="9" name="results-boundary">
+            <a:extLst xmlns:a="http://schemas.openxmlformats.org/drawingml/2006/main">
+              <a:ext uri="{FF2B5EF4-FFF2-40B4-BE49-F238E27FC236}">
+                <a16:creationId xmlns:a16="http://schemas.microsoft.com/office/drawing/2014/main" id="{565E2CD6-290A-4D33-B11A-914F795FA05C}"/>
+              </a:ext>
+            </a:extLst>
+          </p:cNvPr>
+          <p:cNvSpPr>
+            <a:spLocks xmlns:a="http://schemas.openxmlformats.org/drawingml/2006/main" noGrp="1"/>
+          </p:cNvSpPr>
+          <p:nvPr/>
+        </p:nvSpPr>
+        <p:spPr>
+          <a:xfrm xmlns:a="http://schemas.openxmlformats.org/drawingml/2006/main">
+            <a:off x="7143750" y="4762500"/>
+            <a:ext cx="3714750" cy="333375"/>
+          </a:xfrm>
+          <a:prstGeom xmlns:a="http://schemas.openxmlformats.org/drawingml/2006/main" prst="rect">
+            <a:avLst/>
+          </a:prstGeom>
+          <a:noFill xmlns:a="http://schemas.openxmlformats.org/drawingml/2006/main"/>
+          <a:ln xmlns:a="http://schemas.openxmlformats.org/drawingml/2006/main" w="0">
+            <a:noFill/>
+            <a:prstDash val="solid"/>
+          </a:ln>
+        </p:spPr>
+        <p:txBody>
+          <a:bodyPr xmlns:a="http://schemas.openxmlformats.org/drawingml/2006/main" anchor="t"/>
+          <a:lstStyle xmlns:a="http://schemas.openxmlformats.org/drawingml/2006/main"/>
+          <a:p xmlns:a="http://schemas.openxmlformats.org/drawingml/2006/main">
+            <a:pPr>
+              <a:defRPr sz="1425" b="1">
+                <a:solidFill>
+                  <a:srgbClr val="0F6CBD"/>
+                </a:solidFill>
+                <a:latin typeface="Aptos"/>
+                <a:ea typeface="Aptos"/>
+                <a:cs typeface="Aptos"/>
+              </a:defRPr>
+            </a:pPr>
+            <a:r>
+              <a:rPr sz="1425" b="1">
+                <a:solidFill>
+                  <a:srgbClr val="0F6CBD"/>
+                </a:solidFill>
+                <a:latin typeface="Aptos"/>
+                <a:ea typeface="Aptos"/>
+                <a:cs typeface="Aptos"/>
+              </a:rPr>
+              <a:t>A4 remains locked; Selection and Final remain closed.</a:t>
+            </a:r>
+          </a:p>
+        </p:txBody>
+      </p:sp>
+      <p:sp>
+        <p:nvSpPr>
+          <p:cNvPr id="10" name="next-step">
+            <a:extLst xmlns:a="http://schemas.openxmlformats.org/drawingml/2006/main">
+              <a:ext uri="{FF2B5EF4-FFF2-40B4-BE49-F238E27FC236}">
+                <a16:creationId xmlns:a16="http://schemas.microsoft.com/office/drawing/2014/main" id="{E0B5783A-5D0B-4815-BF45-5B4543D0A190}"/>
+              </a:ext>
+            </a:extLst>
+          </p:cNvPr>
+          <p:cNvSpPr>
+            <a:spLocks xmlns:a="http://schemas.openxmlformats.org/drawingml/2006/main" noGrp="1"/>
+          </p:cNvSpPr>
+          <p:nvPr/>
+        </p:nvSpPr>
+        <p:spPr>
+          <a:xfrm xmlns:a="http://schemas.openxmlformats.org/drawingml/2006/main">
+            <a:off x="685800" y="5667375"/>
+            <a:ext cx="10287000" cy="361950"/>
+          </a:xfrm>
+          <a:prstGeom xmlns:a="http://schemas.openxmlformats.org/drawingml/2006/main" prst="rect">
+            <a:avLst/>
+          </a:prstGeom>
+          <a:noFill xmlns:a="http://schemas.openxmlformats.org/drawingml/2006/main"/>
+          <a:ln xmlns:a="http://schemas.openxmlformats.org/drawingml/2006/main" w="0">
+            <a:noFill/>
+            <a:prstDash val="solid"/>
+          </a:ln>
+        </p:spPr>
+        <p:txBody>
+          <a:bodyPr xmlns:a="http://schemas.openxmlformats.org/drawingml/2006/main" anchor="t"/>
+          <a:lstStyle xmlns:a="http://schemas.openxmlformats.org/drawingml/2006/main"/>
+          <a:p xmlns:a="http://schemas.openxmlformats.org/drawingml/2006/main">
+            <a:pPr>
+              <a:defRPr sz="1500" b="1">
+                <a:solidFill>
+                  <a:srgbClr val="14213D"/>
+                </a:solidFill>
+                <a:latin typeface="Aptos"/>
+                <a:ea typeface="Aptos"/>
+                <a:cs typeface="Aptos"/>
+              </a:defRPr>
+            </a:pPr>
+            <a:r>
+              <a:rPr sz="1500" b="1">
+                <a:solidFill>
+                  <a:srgbClr val="14213D"/>
+                </a:solidFill>
+                <a:latin typeface="Aptos"/>
+                <a:ea typeface="Aptos"/>
+                <a:cs typeface="Aptos"/>
+              </a:rPr>
+              <a:t>Claim-limited development evidence: transfer depends on the adapter, and adding every arm is not automatically complementary.</a:t>
+            </a:r>
+          </a:p>
+        </p:txBody>
+      </p:sp>
+      <p:cxnSp>
+        <p:nvCxnSpPr>
+          <p:cNvPr id="23" name="footer-rule"/>
+          <p:cNvCxnSpPr/>
+          <p:nvPr/>
+        </p:nvCxnSpPr>
+        <p:spPr>
+          <a:xfrm xmlns:a="http://schemas.openxmlformats.org/drawingml/2006/main">
+            <a:off x="685800" y="6248400"/>
+            <a:ext cx="10820400" cy="0"/>
+          </a:xfrm>
+          <a:prstGeom xmlns:a="http://schemas.openxmlformats.org/drawingml/2006/main" prst="straightConnector1">
+            <a:avLst/>
+          </a:prstGeom>
           <a:ln xmlns:a="http://schemas.openxmlformats.org/drawingml/2006/main" w="9525">
             <a:solidFill>
               <a:srgbClr val="CBD5E1"/>
@@ -5683,25 +5860,25 @@
             <a:prstDash val="solid"/>
           </a:ln>
         </p:spPr>
-      </p:sp>
-      <p:sp>
-        <p:nvSpPr>
-          <p:cNvPr id="9" name="scope-title">
-            <a:extLst xmlns:a="http://schemas.openxmlformats.org/drawingml/2006/main">
-              <a:ext uri="{FF2B5EF4-FFF2-40B4-BE49-F238E27FC236}">
-                <a16:creationId xmlns:a16="http://schemas.microsoft.com/office/drawing/2014/main" id="{9BDDED50-EB50-47CC-AEED-D118404A73B3}"/>
-              </a:ext>
-            </a:extLst>
-          </p:cNvPr>
-          <p:cNvSpPr>
-            <a:spLocks xmlns:a="http://schemas.openxmlformats.org/drawingml/2006/main" noGrp="1"/>
-          </p:cNvSpPr>
-          <p:nvPr/>
-        </p:nvSpPr>
-        <p:spPr>
-          <a:xfrm xmlns:a="http://schemas.openxmlformats.org/drawingml/2006/main">
-            <a:off x="3905250" y="2543175"/>
-            <a:ext cx="2667000" cy="285750"/>
+      </p:cxnSp>
+      <p:sp>
+        <p:nvSpPr>
+          <p:cNvPr id="12" name="footer">
+            <a:extLst xmlns:a="http://schemas.openxmlformats.org/drawingml/2006/main">
+              <a:ext uri="{FF2B5EF4-FFF2-40B4-BE49-F238E27FC236}">
+                <a16:creationId xmlns:a16="http://schemas.microsoft.com/office/drawing/2014/main" id="{7D125C25-A4A4-428B-82CE-2BB85FB30406}"/>
+              </a:ext>
+            </a:extLst>
+          </p:cNvPr>
+          <p:cNvSpPr>
+            <a:spLocks xmlns:a="http://schemas.openxmlformats.org/drawingml/2006/main" noGrp="1"/>
+          </p:cNvSpPr>
+          <p:nvPr/>
+        </p:nvSpPr>
+        <p:spPr>
+          <a:xfrm xmlns:a="http://schemas.openxmlformats.org/drawingml/2006/main">
+            <a:off x="685800" y="6362700"/>
+            <a:ext cx="9334500" cy="190500"/>
           </a:xfrm>
           <a:prstGeom xmlns:a="http://schemas.openxmlformats.org/drawingml/2006/main" prst="rect">
             <a:avLst/>
@@ -5717,435 +5894,6 @@
           <a:lstStyle xmlns:a="http://schemas.openxmlformats.org/drawingml/2006/main"/>
           <a:p xmlns:a="http://schemas.openxmlformats.org/drawingml/2006/main">
             <a:pPr>
-              <a:defRPr sz="1725" b="1">
-                <a:solidFill>
-                  <a:srgbClr val="14213D"/>
-                </a:solidFill>
-                <a:latin typeface="Aptos"/>
-                <a:ea typeface="Aptos"/>
-                <a:cs typeface="Aptos"/>
-              </a:defRPr>
-            </a:pPr>
-            <a:r>
-              <a:rPr sz="1725" b="1">
-                <a:solidFill>
-                  <a:srgbClr val="14213D"/>
-                </a:solidFill>
-                <a:latin typeface="Aptos"/>
-                <a:ea typeface="Aptos"/>
-                <a:cs typeface="Aptos"/>
-              </a:rPr>
-              <a:t>What is being measured</a:t>
-            </a:r>
-          </a:p>
-        </p:txBody>
-      </p:sp>
-      <p:sp>
-        <p:nvSpPr>
-          <p:cNvPr id="10" name="scope-body">
-            <a:extLst xmlns:a="http://schemas.openxmlformats.org/drawingml/2006/main">
-              <a:ext uri="{FF2B5EF4-FFF2-40B4-BE49-F238E27FC236}">
-                <a16:creationId xmlns:a16="http://schemas.microsoft.com/office/drawing/2014/main" id="{09E0AB47-C56B-45D0-9842-0197B18212BE}"/>
-              </a:ext>
-            </a:extLst>
-          </p:cNvPr>
-          <p:cNvSpPr>
-            <a:spLocks xmlns:a="http://schemas.openxmlformats.org/drawingml/2006/main" noGrp="1"/>
-          </p:cNvSpPr>
-          <p:nvPr/>
-        </p:nvSpPr>
-        <p:spPr>
-          <a:xfrm xmlns:a="http://schemas.openxmlformats.org/drawingml/2006/main">
-            <a:off x="3905250" y="3086100"/>
-            <a:ext cx="2857500" cy="904875"/>
-          </a:xfrm>
-          <a:prstGeom xmlns:a="http://schemas.openxmlformats.org/drawingml/2006/main" prst="rect">
-            <a:avLst/>
-          </a:prstGeom>
-          <a:noFill xmlns:a="http://schemas.openxmlformats.org/drawingml/2006/main"/>
-          <a:ln xmlns:a="http://schemas.openxmlformats.org/drawingml/2006/main" w="0">
-            <a:noFill/>
-            <a:prstDash val="solid"/>
-          </a:ln>
-        </p:spPr>
-        <p:txBody>
-          <a:bodyPr xmlns:a="http://schemas.openxmlformats.org/drawingml/2006/main" anchor="t"/>
-          <a:lstStyle xmlns:a="http://schemas.openxmlformats.org/drawingml/2006/main"/>
-          <a:p xmlns:a="http://schemas.openxmlformats.org/drawingml/2006/main">
-            <a:pPr>
-              <a:defRPr sz="1500">
-                <a:solidFill>
-                  <a:srgbClr val="14213D"/>
-                </a:solidFill>
-                <a:latin typeface="Aptos"/>
-                <a:ea typeface="Aptos"/>
-                <a:cs typeface="Aptos"/>
-              </a:defRPr>
-            </a:pPr>
-            <a:r>
-              <a:rPr sz="1500">
-                <a:solidFill>
-                  <a:srgbClr val="14213D"/>
-                </a:solidFill>
-                <a:latin typeface="Aptos"/>
-                <a:ea typeface="Aptos"/>
-                <a:cs typeface="Aptos"/>
-              </a:rPr>
-              <a:t>- 9 transfer operations</a:t>
-            </a:r>
-          </a:p>
-          <a:p xmlns:a="http://schemas.openxmlformats.org/drawingml/2006/main">
-            <a:pPr>
-              <a:defRPr sz="1500">
-                <a:solidFill>
-                  <a:srgbClr val="14213D"/>
-                </a:solidFill>
-                <a:latin typeface="Aptos"/>
-                <a:ea typeface="Aptos"/>
-                <a:cs typeface="Aptos"/>
-              </a:defRPr>
-            </a:pPr>
-            <a:r>
-              <a:rPr sz="1500">
-                <a:solidFill>
-                  <a:srgbClr val="14213D"/>
-                </a:solidFill>
-                <a:latin typeface="Aptos"/>
-                <a:ea typeface="Aptos"/>
-                <a:cs typeface="Aptos"/>
-              </a:rPr>
-              <a:t>- 5 fixed combination controls</a:t>
-            </a:r>
-          </a:p>
-          <a:p xmlns:a="http://schemas.openxmlformats.org/drawingml/2006/main">
-            <a:pPr>
-              <a:defRPr sz="1500">
-                <a:solidFill>
-                  <a:srgbClr val="14213D"/>
-                </a:solidFill>
-                <a:latin typeface="Aptos"/>
-                <a:ea typeface="Aptos"/>
-                <a:cs typeface="Aptos"/>
-              </a:defRPr>
-            </a:pPr>
-            <a:r>
-              <a:rPr sz="1500">
-                <a:solidFill>
-                  <a:srgbClr val="14213D"/>
-                </a:solidFill>
-                <a:latin typeface="Aptos"/>
-                <a:ea typeface="Aptos"/>
-                <a:cs typeface="Aptos"/>
-              </a:rPr>
-              <a:t>- ARM-03, ARM-04, ARM-05 only</a:t>
-            </a:r>
-          </a:p>
-        </p:txBody>
-      </p:sp>
-      <p:sp>
-        <p:nvSpPr>
-          <p:cNvPr id="11" name="decision-boundary">
-            <a:extLst xmlns:a="http://schemas.openxmlformats.org/drawingml/2006/main">
-              <a:ext uri="{FF2B5EF4-FFF2-40B4-BE49-F238E27FC236}">
-                <a16:creationId xmlns:a16="http://schemas.microsoft.com/office/drawing/2014/main" id="{DDD06F3F-D6B8-4200-A227-004B84D19D61}"/>
-              </a:ext>
-            </a:extLst>
-          </p:cNvPr>
-          <p:cNvSpPr>
-            <a:spLocks xmlns:a="http://schemas.openxmlformats.org/drawingml/2006/main" noGrp="1"/>
-          </p:cNvSpPr>
-          <p:nvPr/>
-        </p:nvSpPr>
-        <p:spPr>
-          <a:xfrm xmlns:a="http://schemas.openxmlformats.org/drawingml/2006/main">
-            <a:off x="7410450" y="2238375"/>
-            <a:ext cx="3810000" cy="2095500"/>
-          </a:xfrm>
-          <a:prstGeom xmlns:a="http://schemas.openxmlformats.org/drawingml/2006/main" prst="roundRect">
-            <a:avLst>
-              <a:gd name="adj" fmla="val 3636"/>
-            </a:avLst>
-          </a:prstGeom>
-          <a:solidFill xmlns:a="http://schemas.openxmlformats.org/drawingml/2006/main">
-            <a:srgbClr val="E8F1FA"/>
-          </a:solidFill>
-          <a:ln xmlns:a="http://schemas.openxmlformats.org/drawingml/2006/main" w="9525">
-            <a:solidFill>
-              <a:srgbClr val="E8F1FA"/>
-            </a:solidFill>
-            <a:prstDash val="solid"/>
-          </a:ln>
-        </p:spPr>
-      </p:sp>
-      <p:sp>
-        <p:nvSpPr>
-          <p:cNvPr id="12" name="boundary-title">
-            <a:extLst xmlns:a="http://schemas.openxmlformats.org/drawingml/2006/main">
-              <a:ext uri="{FF2B5EF4-FFF2-40B4-BE49-F238E27FC236}">
-                <a16:creationId xmlns:a16="http://schemas.microsoft.com/office/drawing/2014/main" id="{076A602C-40C3-48A9-AE4A-B422F3DED54B}"/>
-              </a:ext>
-            </a:extLst>
-          </p:cNvPr>
-          <p:cNvSpPr>
-            <a:spLocks xmlns:a="http://schemas.openxmlformats.org/drawingml/2006/main" noGrp="1"/>
-          </p:cNvSpPr>
-          <p:nvPr/>
-        </p:nvSpPr>
-        <p:spPr>
-          <a:xfrm xmlns:a="http://schemas.openxmlformats.org/drawingml/2006/main">
-            <a:off x="7696200" y="2543175"/>
-            <a:ext cx="3143250" cy="285750"/>
-          </a:xfrm>
-          <a:prstGeom xmlns:a="http://schemas.openxmlformats.org/drawingml/2006/main" prst="rect">
-            <a:avLst/>
-          </a:prstGeom>
-          <a:noFill xmlns:a="http://schemas.openxmlformats.org/drawingml/2006/main"/>
-          <a:ln xmlns:a="http://schemas.openxmlformats.org/drawingml/2006/main" w="0">
-            <a:noFill/>
-            <a:prstDash val="solid"/>
-          </a:ln>
-        </p:spPr>
-        <p:txBody>
-          <a:bodyPr xmlns:a="http://schemas.openxmlformats.org/drawingml/2006/main" anchor="t"/>
-          <a:lstStyle xmlns:a="http://schemas.openxmlformats.org/drawingml/2006/main"/>
-          <a:p xmlns:a="http://schemas.openxmlformats.org/drawingml/2006/main">
-            <a:pPr>
-              <a:defRPr sz="1725" b="1">
-                <a:solidFill>
-                  <a:srgbClr val="0F6CBD"/>
-                </a:solidFill>
-                <a:latin typeface="Aptos"/>
-                <a:ea typeface="Aptos"/>
-                <a:cs typeface="Aptos"/>
-              </a:defRPr>
-            </a:pPr>
-            <a:r>
-              <a:rPr sz="1725" b="1">
-                <a:solidFill>
-                  <a:srgbClr val="0F6CBD"/>
-                </a:solidFill>
-                <a:latin typeface="Aptos"/>
-                <a:ea typeface="Aptos"/>
-                <a:cs typeface="Aptos"/>
-              </a:rPr>
-              <a:t>What cannot be concluded yet</a:t>
-            </a:r>
-          </a:p>
-        </p:txBody>
-      </p:sp>
-      <p:sp>
-        <p:nvSpPr>
-          <p:cNvPr id="13" name="boundary-body">
-            <a:extLst xmlns:a="http://schemas.openxmlformats.org/drawingml/2006/main">
-              <a:ext uri="{FF2B5EF4-FFF2-40B4-BE49-F238E27FC236}">
-                <a16:creationId xmlns:a16="http://schemas.microsoft.com/office/drawing/2014/main" id="{C99CFB79-C5C8-4854-AD94-E363627DBCF8}"/>
-              </a:ext>
-            </a:extLst>
-          </p:cNvPr>
-          <p:cNvSpPr>
-            <a:spLocks xmlns:a="http://schemas.openxmlformats.org/drawingml/2006/main" noGrp="1"/>
-          </p:cNvSpPr>
-          <p:nvPr/>
-        </p:nvSpPr>
-        <p:spPr>
-          <a:xfrm xmlns:a="http://schemas.openxmlformats.org/drawingml/2006/main">
-            <a:off x="7696200" y="3086100"/>
-            <a:ext cx="3000375" cy="952500"/>
-          </a:xfrm>
-          <a:prstGeom xmlns:a="http://schemas.openxmlformats.org/drawingml/2006/main" prst="rect">
-            <a:avLst/>
-          </a:prstGeom>
-          <a:noFill xmlns:a="http://schemas.openxmlformats.org/drawingml/2006/main"/>
-          <a:ln xmlns:a="http://schemas.openxmlformats.org/drawingml/2006/main" w="0">
-            <a:noFill/>
-            <a:prstDash val="solid"/>
-          </a:ln>
-        </p:spPr>
-        <p:txBody>
-          <a:bodyPr xmlns:a="http://schemas.openxmlformats.org/drawingml/2006/main" anchor="t"/>
-          <a:lstStyle xmlns:a="http://schemas.openxmlformats.org/drawingml/2006/main"/>
-          <a:p xmlns:a="http://schemas.openxmlformats.org/drawingml/2006/main">
-            <a:pPr>
-              <a:defRPr sz="1500" b="1">
-                <a:solidFill>
-                  <a:srgbClr val="14213D"/>
-                </a:solidFill>
-                <a:latin typeface="Aptos"/>
-                <a:ea typeface="Aptos"/>
-                <a:cs typeface="Aptos"/>
-              </a:defRPr>
-            </a:pPr>
-            <a:r>
-              <a:rPr sz="1500" b="1">
-                <a:solidFill>
-                  <a:srgbClr val="14213D"/>
-                </a:solidFill>
-                <a:latin typeface="Aptos"/>
-                <a:ea typeface="Aptos"/>
-                <a:cs typeface="Aptos"/>
-              </a:rPr>
-              <a:t>No transfer result</a:t>
-            </a:r>
-          </a:p>
-          <a:p xmlns:a="http://schemas.openxmlformats.org/drawingml/2006/main">
-            <a:pPr>
-              <a:defRPr sz="1500" b="1">
-                <a:solidFill>
-                  <a:srgbClr val="14213D"/>
-                </a:solidFill>
-                <a:latin typeface="Aptos"/>
-                <a:ea typeface="Aptos"/>
-                <a:cs typeface="Aptos"/>
-              </a:defRPr>
-            </a:pPr>
-            <a:r>
-              <a:rPr sz="1500" b="1">
-                <a:solidFill>
-                  <a:srgbClr val="14213D"/>
-                </a:solidFill>
-                <a:latin typeface="Aptos"/>
-                <a:ea typeface="Aptos"/>
-                <a:cs typeface="Aptos"/>
-              </a:rPr>
-              <a:t>No complementary-set decision</a:t>
-            </a:r>
-          </a:p>
-          <a:p xmlns:a="http://schemas.openxmlformats.org/drawingml/2006/main">
-            <a:pPr>
-              <a:defRPr sz="1500" b="1">
-                <a:solidFill>
-                  <a:srgbClr val="14213D"/>
-                </a:solidFill>
-                <a:latin typeface="Aptos"/>
-                <a:ea typeface="Aptos"/>
-                <a:cs typeface="Aptos"/>
-              </a:defRPr>
-            </a:pPr>
-            <a:r>
-              <a:rPr sz="1500" b="1">
-                <a:solidFill>
-                  <a:srgbClr val="14213D"/>
-                </a:solidFill>
-                <a:latin typeface="Aptos"/>
-                <a:ea typeface="Aptos"/>
-                <a:cs typeface="Aptos"/>
-              </a:rPr>
-              <a:t>No A4 production decision</a:t>
-            </a:r>
-          </a:p>
-        </p:txBody>
-      </p:sp>
-      <p:sp>
-        <p:nvSpPr>
-          <p:cNvPr id="14" name="next-step">
-            <a:extLst xmlns:a="http://schemas.openxmlformats.org/drawingml/2006/main">
-              <a:ext uri="{FF2B5EF4-FFF2-40B4-BE49-F238E27FC236}">
-                <a16:creationId xmlns:a16="http://schemas.microsoft.com/office/drawing/2014/main" id="{0833689E-E0A3-484B-8BBA-E812509C0FA7}"/>
-              </a:ext>
-            </a:extLst>
-          </p:cNvPr>
-          <p:cNvSpPr>
-            <a:spLocks xmlns:a="http://schemas.openxmlformats.org/drawingml/2006/main" noGrp="1"/>
-          </p:cNvSpPr>
-          <p:nvPr/>
-        </p:nvSpPr>
-        <p:spPr>
-          <a:xfrm xmlns:a="http://schemas.openxmlformats.org/drawingml/2006/main">
-            <a:off x="685800" y="5000625"/>
-            <a:ext cx="9763125" cy="590550"/>
-          </a:xfrm>
-          <a:prstGeom xmlns:a="http://schemas.openxmlformats.org/drawingml/2006/main" prst="rect">
-            <a:avLst/>
-          </a:prstGeom>
-          <a:noFill xmlns:a="http://schemas.openxmlformats.org/drawingml/2006/main"/>
-          <a:ln xmlns:a="http://schemas.openxmlformats.org/drawingml/2006/main" w="0">
-            <a:noFill/>
-            <a:prstDash val="solid"/>
-          </a:ln>
-        </p:spPr>
-        <p:txBody>
-          <a:bodyPr xmlns:a="http://schemas.openxmlformats.org/drawingml/2006/main" anchor="t"/>
-          <a:lstStyle xmlns:a="http://schemas.openxmlformats.org/drawingml/2006/main"/>
-          <a:p xmlns:a="http://schemas.openxmlformats.org/drawingml/2006/main">
-            <a:pPr>
-              <a:defRPr sz="1950" b="1">
-                <a:solidFill>
-                  <a:srgbClr val="14213D"/>
-                </a:solidFill>
-                <a:latin typeface="Aptos"/>
-                <a:ea typeface="Aptos"/>
-                <a:cs typeface="Aptos"/>
-              </a:defRPr>
-            </a:pPr>
-            <a:r>
-              <a:rPr sz="1950" b="1">
-                <a:solidFill>
-                  <a:srgbClr val="14213D"/>
-                </a:solidFill>
-                <a:latin typeface="Aptos"/>
-                <a:ea typeface="Aptos"/>
-                <a:cs typeface="Aptos"/>
-              </a:rPr>
-              <a:t>Next valid update: collected packages, protected local evaluation, completeness check, and independent result audit.</a:t>
-            </a:r>
-          </a:p>
-        </p:txBody>
-      </p:sp>
-      <p:cxnSp>
-        <p:nvCxnSpPr>
-          <p:cNvPr id="31" name="footer-rule"/>
-          <p:cNvCxnSpPr/>
-          <p:nvPr/>
-        </p:nvCxnSpPr>
-        <p:spPr>
-          <a:xfrm xmlns:a="http://schemas.openxmlformats.org/drawingml/2006/main">
-            <a:off x="685800" y="6248400"/>
-            <a:ext cx="10820400" cy="0"/>
-          </a:xfrm>
-          <a:prstGeom xmlns:a="http://schemas.openxmlformats.org/drawingml/2006/main" prst="straightConnector1">
-            <a:avLst/>
-          </a:prstGeom>
-          <a:ln xmlns:a="http://schemas.openxmlformats.org/drawingml/2006/main" w="9525">
-            <a:solidFill>
-              <a:srgbClr val="CBD5E1"/>
-            </a:solidFill>
-            <a:prstDash val="solid"/>
-          </a:ln>
-        </p:spPr>
-      </p:cxnSp>
-      <p:sp>
-        <p:nvSpPr>
-          <p:cNvPr id="16" name="footer">
-            <a:extLst xmlns:a="http://schemas.openxmlformats.org/drawingml/2006/main">
-              <a:ext uri="{FF2B5EF4-FFF2-40B4-BE49-F238E27FC236}">
-                <a16:creationId xmlns:a16="http://schemas.microsoft.com/office/drawing/2014/main" id="{BDE799F1-09E4-475B-8C4B-C56398336AE9}"/>
-              </a:ext>
-            </a:extLst>
-          </p:cNvPr>
-          <p:cNvSpPr>
-            <a:spLocks xmlns:a="http://schemas.openxmlformats.org/drawingml/2006/main" noGrp="1"/>
-          </p:cNvSpPr>
-          <p:nvPr/>
-        </p:nvSpPr>
-        <p:spPr>
-          <a:xfrm xmlns:a="http://schemas.openxmlformats.org/drawingml/2006/main">
-            <a:off x="685800" y="6362700"/>
-            <a:ext cx="9334500" cy="190500"/>
-          </a:xfrm>
-          <a:prstGeom xmlns:a="http://schemas.openxmlformats.org/drawingml/2006/main" prst="rect">
-            <a:avLst/>
-          </a:prstGeom>
-          <a:noFill xmlns:a="http://schemas.openxmlformats.org/drawingml/2006/main"/>
-          <a:ln xmlns:a="http://schemas.openxmlformats.org/drawingml/2006/main" w="0">
-            <a:noFill/>
-            <a:prstDash val="solid"/>
-          </a:ln>
-        </p:spPr>
-        <p:txBody>
-          <a:bodyPr xmlns:a="http://schemas.openxmlformats.org/drawingml/2006/main" anchor="t"/>
-          <a:lstStyle xmlns:a="http://schemas.openxmlformats.org/drawingml/2006/main"/>
-          <a:p xmlns:a="http://schemas.openxmlformats.org/drawingml/2006/main">
-            <a:pPr>
               <a:defRPr sz="900">
                 <a:solidFill>
                   <a:srgbClr val="52616B"/>
@@ -6164,7 +5912,7 @@
                 <a:ea typeface="Aptos"/>
                 <a:cs typeface="Aptos"/>
               </a:rPr>
-              <a:t>A4 remains locked pending valid A3 summary evidence and audit.</a:t>
+              <a:t>A3 development evidence only. Selection and Final remain closed.</a:t>
             </a:r>
           </a:p>
         </p:txBody>
@@ -6172,7 +5920,7 @@
     </p:spTree>
     <p:extLst>
       <p:ext uri="{BB962C8B-B14F-4D97-AF65-F5344CB8AC3E}">
-        <p14:creationId xmlns:p14="http://schemas.microsoft.com/office/powerpoint/2010/main" val="1864972259"/>
+        <p14:creationId xmlns:p14="http://schemas.microsoft.com/office/powerpoint/2010/main" val="1660163975"/>
       </p:ext>
     </p:extLst>
   </p:cSld>

</xml_diff>